<commit_message>
Complete deep-dives for all 5 members and rebuild deck to 22 slides
- draft/taskN_deep.py (+ outputs): province channel mix, discretionary
  gradient, occupation groups, spend timing, crossover sensitivity,
  engagement heatmap, cutoff sensitivity, segment stability/migration,
  impact scenario
- notebooks: cells generated from the deep-dive scripts, findings filled
- findings: deep-dive sections; drop unsupported two-year caveat; fix
  digital value-share claim
- deck: 4 new slides, auto-numbered, updated exec summary and closing
</commit_message>
<xml_diff>
--- a/draft/YAPPERS_BI10_R01.pptx
+++ b/draft/YAPPERS_BI10_R01.pptx
@@ -23,9 +23,13 @@
     <p:sldId id="271" r:id="rId17"/>
     <p:sldId id="272" r:id="rId18"/>
     <p:sldId id="273" r:id="rId19"/>
+    <p:sldId id="274" r:id="rId20"/>
+    <p:sldId id="275" r:id="rId21"/>
+    <p:sldId id="276" r:id="rId22"/>
+    <p:sldId id="277" r:id="rId23"/>
   </p:sldIdLst>
   <p:notesMasterIdLst>
-    <p:notesMasterId r:id="rId20"/>
+    <p:notesMasterId r:id="rId24"/>
   </p:notesMasterIdLst>
   <p:sldSz cx="12192000" cy="6858000"/>
   <p:notesSz cx="6858000" cy="12192000"/>
@@ -607,7 +611,7 @@
           <a:p>
             <a:r>
               <a:rPr lang="en-US" dirty="0"/>
-              <a:t>More than half of every stress episode happens to someone we can text right now.</a:t>
+              <a:t>Two ratios are the whole game — the quintile chart makes r = −0.90 tangible.</a:t>
             </a:r>
             <a:endParaRPr lang="en-US" dirty="0"/>
           </a:p>
@@ -695,7 +699,7 @@
           <a:p>
             <a:r>
               <a:rPr lang="en-US" dirty="0"/>
-              <a:t>Don't segment on the engagement score — it's a ceiling. Segment on behaviours underneath.</a:t>
+              <a:t>More than half of every stress episode happens to someone we can reach in-app — and we now know when.</a:t>
             </a:r>
             <a:endParaRPr lang="en-US" dirty="0"/>
           </a:p>
@@ -783,7 +787,7 @@
           <a:p>
             <a:r>
               <a:rPr lang="en-US" dirty="0"/>
-              <a:t>Build the early-warning flag on category diversity.</a:t>
+              <a:t>Deliverable 3 — the honest answer: the one demographic gap is really a spending gap.</a:t>
             </a:r>
             <a:endParaRPr lang="en-US" dirty="0"/>
           </a:p>
@@ -871,7 +875,7 @@
           <a:p>
             <a:r>
               <a:rPr lang="en-US" dirty="0"/>
-              <a:t>Two low-engagement tails, opposite remedies — don't merge them.</a:t>
+              <a:t>Bar, not pie: a pie would hide the 1% tail. Segment on the behaviours underneath, not the score.</a:t>
             </a:r>
             <a:endParaRPr lang="en-US" dirty="0"/>
           </a:p>
@@ -959,7 +963,7 @@
           <a:p>
             <a:r>
               <a:rPr lang="en-US" dirty="0"/>
-              <a:t>Moderate silhouette is expected for a behavioural continuum; the 2×2 validates the poles.</a:t>
+              <a:t>Scatter for two continuous variables; heatmap for the recency × frequency interaction.</a:t>
             </a:r>
             <a:endParaRPr lang="en-US" dirty="0"/>
           </a:p>
@@ -1047,7 +1051,7 @@
           <a:p>
             <a:r>
               <a:rPr lang="en-US" dirty="0"/>
-              <a:t>Segment 2 turns Task 1's 25–34 vulnerability into an addressable 302-person group.</a:t>
+              <a:t>The sensitivity table is the answer to 'why this cutoff and not tighter or looser'.</a:t>
             </a:r>
             <a:endParaRPr lang="en-US" dirty="0"/>
           </a:p>
@@ -1135,7 +1139,7 @@
           <a:p>
             <a:r>
               <a:rPr lang="en-US" dirty="0"/>
-              <a:t>One tool per required type, each bound to an exact size and a real ratio.</a:t>
+              <a:t>Moderate silhouette is expected for a behavioural continuum; the next slides validate it.</a:t>
             </a:r>
             <a:endParaRPr lang="en-US" dirty="0"/>
           </a:p>
@@ -1223,7 +1227,7 @@
           <a:p>
             <a:r>
               <a:rPr lang="en-US" dirty="0"/>
-              <a:t>The rule is the deck's contract — a low score triggers help offered, never access removed.</a:t>
+              <a:t>Segment 2 is the addressable wellbeing priority.</a:t>
             </a:r>
             <a:endParaRPr lang="en-US" dirty="0"/>
           </a:p>
@@ -1311,7 +1315,7 @@
           <a:p>
             <a:r>
               <a:rPr lang="en-US" dirty="0"/>
-              <a:t>Close on the contract.</a:t>
+              <a:t>Stable enough to act on; the Nov→Dec slide is the timing evidence for planning reminders.</a:t>
             </a:r>
             <a:endParaRPr lang="en-US" dirty="0"/>
           </a:p>
@@ -1335,6 +1339,94 @@
             <a:fld id="{F7021451-1387-4CA6-816F-3879F97B5CBC}" type="slidenum">
               <a:rPr lang="en-US"/>
               <a:t>18</a:t>
+            </a:fld>
+            <a:endParaRPr lang="en-US"/>
+          </a:p>
+        </p:txBody>
+      </p:sp>
+    </p:spTree>
+    <p:extLst>
+      <p:ext uri="{BB962C8B-B14F-4D97-AF65-F5344CB8AC3E}">
+        <p14:creationId xmlns:p14="http://schemas.microsoft.com/office/powerpoint/2010/main" val="1024086991"/>
+      </p:ext>
+    </p:extLst>
+  </p:cSld>
+  <p:clrMapOvr>
+    <a:masterClrMapping/>
+  </p:clrMapOvr>
+</p:notes>
+</file>
+
+<file path=ppt/notesSlides/notesSlide19.xml><?xml version="1.0" encoding="utf-8"?>
+<p:notes xmlns:a="http://schemas.openxmlformats.org/drawingml/2006/main" xmlns:r="http://schemas.openxmlformats.org/officeDocument/2006/relationships" xmlns:p="http://schemas.openxmlformats.org/presentationml/2006/main">
+  <p:cSld>
+    <p:spTree>
+      <p:nvGrpSpPr>
+        <p:cNvPr id="1" name=""/>
+        <p:cNvGrpSpPr/>
+        <p:nvPr/>
+      </p:nvGrpSpPr>
+      <p:grpSpPr>
+        <a:xfrm>
+          <a:off x="0" y="0"/>
+          <a:ext cx="0" cy="0"/>
+          <a:chOff x="0" y="0"/>
+          <a:chExt cx="0" cy="0"/>
+        </a:xfrm>
+      </p:grpSpPr>
+      <p:sp>
+        <p:nvSpPr>
+          <p:cNvPr id="2" name="Slide Image Placeholder 1"/>
+          <p:cNvSpPr>
+            <a:spLocks noGrp="1" noRot="1" noChangeAspect="1"/>
+          </p:cNvSpPr>
+          <p:nvPr>
+            <p:ph type="sldImg"/>
+          </p:nvPr>
+        </p:nvSpPr>
+        <p:spPr/>
+      </p:sp>
+      <p:sp>
+        <p:nvSpPr>
+          <p:cNvPr id="3" name="Notes Placeholder 2"/>
+          <p:cNvSpPr>
+            <a:spLocks noGrp="1"/>
+          </p:cNvSpPr>
+          <p:nvPr>
+            <p:ph type="body" idx="1"/>
+          </p:nvPr>
+        </p:nvSpPr>
+        <p:spPr/>
+        <p:txBody>
+          <a:bodyPr/>
+          <a:lstStyle/>
+          <a:p>
+            <a:r>
+              <a:rPr lang="en-US" dirty="0"/>
+              <a:t>One tool per required type, each bound to an exact size, a real ratio and now a timing.</a:t>
+            </a:r>
+            <a:endParaRPr lang="en-US" dirty="0"/>
+          </a:p>
+        </p:txBody>
+      </p:sp>
+      <p:sp>
+        <p:nvSpPr>
+          <p:cNvPr id="4" name="Slide Number Placeholder 3"/>
+          <p:cNvSpPr>
+            <a:spLocks noGrp="1"/>
+          </p:cNvSpPr>
+          <p:nvPr>
+            <p:ph type="sldNum" sz="quarter" idx="10"/>
+          </p:nvPr>
+        </p:nvSpPr>
+        <p:spPr/>
+        <p:txBody>
+          <a:bodyPr/>
+          <a:lstStyle/>
+          <a:p>
+            <a:fld id="{F7021451-1387-4CA6-816F-3879F97B5CBC}" type="slidenum">
+              <a:rPr lang="en-US"/>
+              <a:t>19</a:t>
             </a:fld>
             <a:endParaRPr lang="en-US"/>
           </a:p>
@@ -1441,6 +1533,270 @@
 </p:notes>
 </file>
 
+<file path=ppt/notesSlides/notesSlide20.xml><?xml version="1.0" encoding="utf-8"?>
+<p:notes xmlns:a="http://schemas.openxmlformats.org/drawingml/2006/main" xmlns:r="http://schemas.openxmlformats.org/officeDocument/2006/relationships" xmlns:p="http://schemas.openxmlformats.org/presentationml/2006/main">
+  <p:cSld>
+    <p:spTree>
+      <p:nvGrpSpPr>
+        <p:cNvPr id="1" name=""/>
+        <p:cNvGrpSpPr/>
+        <p:nvPr/>
+      </p:nvGrpSpPr>
+      <p:grpSpPr>
+        <a:xfrm>
+          <a:off x="0" y="0"/>
+          <a:ext cx="0" cy="0"/>
+          <a:chOff x="0" y="0"/>
+          <a:chExt cx="0" cy="0"/>
+        </a:xfrm>
+      </p:grpSpPr>
+      <p:sp>
+        <p:nvSpPr>
+          <p:cNvPr id="2" name="Slide Image Placeholder 1"/>
+          <p:cNvSpPr>
+            <a:spLocks noGrp="1" noRot="1" noChangeAspect="1"/>
+          </p:cNvSpPr>
+          <p:nvPr>
+            <p:ph type="sldImg"/>
+          </p:nvPr>
+        </p:nvSpPr>
+        <p:spPr/>
+      </p:sp>
+      <p:sp>
+        <p:nvSpPr>
+          <p:cNvPr id="3" name="Notes Placeholder 2"/>
+          <p:cNvSpPr>
+            <a:spLocks noGrp="1"/>
+          </p:cNvSpPr>
+          <p:nvPr>
+            <p:ph type="body" idx="1"/>
+          </p:nvPr>
+        </p:nvSpPr>
+        <p:spPr/>
+        <p:txBody>
+          <a:bodyPr/>
+          <a:lstStyle/>
+          <a:p>
+            <a:r>
+              <a:rPr lang="en-US" dirty="0"/>
+              <a:t>The rule is the deck's contract — a low score triggers help offered, never access removed.</a:t>
+            </a:r>
+            <a:endParaRPr lang="en-US" dirty="0"/>
+          </a:p>
+        </p:txBody>
+      </p:sp>
+      <p:sp>
+        <p:nvSpPr>
+          <p:cNvPr id="4" name="Slide Number Placeholder 3"/>
+          <p:cNvSpPr>
+            <a:spLocks noGrp="1"/>
+          </p:cNvSpPr>
+          <p:nvPr>
+            <p:ph type="sldNum" sz="quarter" idx="10"/>
+          </p:nvPr>
+        </p:nvSpPr>
+        <p:spPr/>
+        <p:txBody>
+          <a:bodyPr/>
+          <a:lstStyle/>
+          <a:p>
+            <a:fld id="{F7021451-1387-4CA6-816F-3879F97B5CBC}" type="slidenum">
+              <a:rPr lang="en-US"/>
+              <a:t>20</a:t>
+            </a:fld>
+            <a:endParaRPr lang="en-US"/>
+          </a:p>
+        </p:txBody>
+      </p:sp>
+    </p:spTree>
+    <p:extLst>
+      <p:ext uri="{BB962C8B-B14F-4D97-AF65-F5344CB8AC3E}">
+        <p14:creationId xmlns:p14="http://schemas.microsoft.com/office/powerpoint/2010/main" val="1024086991"/>
+      </p:ext>
+    </p:extLst>
+  </p:cSld>
+  <p:clrMapOvr>
+    <a:masterClrMapping/>
+  </p:clrMapOvr>
+</p:notes>
+</file>
+
+<file path=ppt/notesSlides/notesSlide21.xml><?xml version="1.0" encoding="utf-8"?>
+<p:notes xmlns:a="http://schemas.openxmlformats.org/drawingml/2006/main" xmlns:r="http://schemas.openxmlformats.org/officeDocument/2006/relationships" xmlns:p="http://schemas.openxmlformats.org/presentationml/2006/main">
+  <p:cSld>
+    <p:spTree>
+      <p:nvGrpSpPr>
+        <p:cNvPr id="1" name=""/>
+        <p:cNvGrpSpPr/>
+        <p:nvPr/>
+      </p:nvGrpSpPr>
+      <p:grpSpPr>
+        <a:xfrm>
+          <a:off x="0" y="0"/>
+          <a:ext cx="0" cy="0"/>
+          <a:chOff x="0" y="0"/>
+          <a:chExt cx="0" cy="0"/>
+        </a:xfrm>
+      </p:grpSpPr>
+      <p:sp>
+        <p:nvSpPr>
+          <p:cNvPr id="2" name="Slide Image Placeholder 1"/>
+          <p:cNvSpPr>
+            <a:spLocks noGrp="1" noRot="1" noChangeAspect="1"/>
+          </p:cNvSpPr>
+          <p:nvPr>
+            <p:ph type="sldImg"/>
+          </p:nvPr>
+        </p:nvSpPr>
+        <p:spPr/>
+      </p:sp>
+      <p:sp>
+        <p:nvSpPr>
+          <p:cNvPr id="3" name="Notes Placeholder 2"/>
+          <p:cNvSpPr>
+            <a:spLocks noGrp="1"/>
+          </p:cNvSpPr>
+          <p:nvPr>
+            <p:ph type="body" idx="1"/>
+          </p:nvPr>
+        </p:nvSpPr>
+        <p:spPr/>
+        <p:txBody>
+          <a:bodyPr/>
+          <a:lstStyle/>
+          <a:p>
+            <a:r>
+              <a:rPr lang="en-US" dirty="0"/>
+              <a:t>Impact is a hypothesis we will measure, not a promise.</a:t>
+            </a:r>
+            <a:endParaRPr lang="en-US" dirty="0"/>
+          </a:p>
+        </p:txBody>
+      </p:sp>
+      <p:sp>
+        <p:nvSpPr>
+          <p:cNvPr id="4" name="Slide Number Placeholder 3"/>
+          <p:cNvSpPr>
+            <a:spLocks noGrp="1"/>
+          </p:cNvSpPr>
+          <p:nvPr>
+            <p:ph type="sldNum" sz="quarter" idx="10"/>
+          </p:nvPr>
+        </p:nvSpPr>
+        <p:spPr/>
+        <p:txBody>
+          <a:bodyPr/>
+          <a:lstStyle/>
+          <a:p>
+            <a:fld id="{F7021451-1387-4CA6-816F-3879F97B5CBC}" type="slidenum">
+              <a:rPr lang="en-US"/>
+              <a:t>21</a:t>
+            </a:fld>
+            <a:endParaRPr lang="en-US"/>
+          </a:p>
+        </p:txBody>
+      </p:sp>
+    </p:spTree>
+    <p:extLst>
+      <p:ext uri="{BB962C8B-B14F-4D97-AF65-F5344CB8AC3E}">
+        <p14:creationId xmlns:p14="http://schemas.microsoft.com/office/powerpoint/2010/main" val="1024086991"/>
+      </p:ext>
+    </p:extLst>
+  </p:cSld>
+  <p:clrMapOvr>
+    <a:masterClrMapping/>
+  </p:clrMapOvr>
+</p:notes>
+</file>
+
+<file path=ppt/notesSlides/notesSlide22.xml><?xml version="1.0" encoding="utf-8"?>
+<p:notes xmlns:a="http://schemas.openxmlformats.org/drawingml/2006/main" xmlns:r="http://schemas.openxmlformats.org/officeDocument/2006/relationships" xmlns:p="http://schemas.openxmlformats.org/presentationml/2006/main">
+  <p:cSld>
+    <p:spTree>
+      <p:nvGrpSpPr>
+        <p:cNvPr id="1" name=""/>
+        <p:cNvGrpSpPr/>
+        <p:nvPr/>
+      </p:nvGrpSpPr>
+      <p:grpSpPr>
+        <a:xfrm>
+          <a:off x="0" y="0"/>
+          <a:ext cx="0" cy="0"/>
+          <a:chOff x="0" y="0"/>
+          <a:chExt cx="0" cy="0"/>
+        </a:xfrm>
+      </p:grpSpPr>
+      <p:sp>
+        <p:nvSpPr>
+          <p:cNvPr id="2" name="Slide Image Placeholder 1"/>
+          <p:cNvSpPr>
+            <a:spLocks noGrp="1" noRot="1" noChangeAspect="1"/>
+          </p:cNvSpPr>
+          <p:nvPr>
+            <p:ph type="sldImg"/>
+          </p:nvPr>
+        </p:nvSpPr>
+        <p:spPr/>
+      </p:sp>
+      <p:sp>
+        <p:nvSpPr>
+          <p:cNvPr id="3" name="Notes Placeholder 2"/>
+          <p:cNvSpPr>
+            <a:spLocks noGrp="1"/>
+          </p:cNvSpPr>
+          <p:nvPr>
+            <p:ph type="body" idx="1"/>
+          </p:nvPr>
+        </p:nvSpPr>
+        <p:spPr/>
+        <p:txBody>
+          <a:bodyPr/>
+          <a:lstStyle/>
+          <a:p>
+            <a:r>
+              <a:rPr lang="en-US" dirty="0"/>
+              <a:t>Close on the contract.</a:t>
+            </a:r>
+            <a:endParaRPr lang="en-US" dirty="0"/>
+          </a:p>
+        </p:txBody>
+      </p:sp>
+      <p:sp>
+        <p:nvSpPr>
+          <p:cNvPr id="4" name="Slide Number Placeholder 3"/>
+          <p:cNvSpPr>
+            <a:spLocks noGrp="1"/>
+          </p:cNvSpPr>
+          <p:nvPr>
+            <p:ph type="sldNum" sz="quarter" idx="10"/>
+          </p:nvPr>
+        </p:nvSpPr>
+        <p:spPr/>
+        <p:txBody>
+          <a:bodyPr/>
+          <a:lstStyle/>
+          <a:p>
+            <a:fld id="{F7021451-1387-4CA6-816F-3879F97B5CBC}" type="slidenum">
+              <a:rPr lang="en-US"/>
+              <a:t>22</a:t>
+            </a:fld>
+            <a:endParaRPr lang="en-US"/>
+          </a:p>
+        </p:txBody>
+      </p:sp>
+    </p:spTree>
+    <p:extLst>
+      <p:ext uri="{BB962C8B-B14F-4D97-AF65-F5344CB8AC3E}">
+        <p14:creationId xmlns:p14="http://schemas.microsoft.com/office/powerpoint/2010/main" val="1024086991"/>
+      </p:ext>
+    </p:extLst>
+  </p:cSld>
+  <p:clrMapOvr>
+    <a:masterClrMapping/>
+  </p:clrMapOvr>
+</p:notes>
+</file>
+
 <file path=ppt/notesSlides/notesSlide3.xml><?xml version="1.0" encoding="utf-8"?>
 <p:notes xmlns:a="http://schemas.openxmlformats.org/drawingml/2006/main" xmlns:r="http://schemas.openxmlformats.org/officeDocument/2006/relationships" xmlns:p="http://schemas.openxmlformats.org/presentationml/2006/main">
   <p:cSld>
@@ -1663,7 +2019,7 @@
           <a:p>
             <a:r>
               <a:rPr lang="en-US" dirty="0"/>
-              <a:t>Peaks are a frequency phenomenon — the lever is trip frequency, not upsell.</a:t>
+              <a:t>Peaks are a frequency phenomenon across every category — the lever is trip frequency, not upsell.</a:t>
             </a:r>
             <a:endParaRPr lang="en-US" dirty="0"/>
           </a:p>
@@ -1751,7 +2107,7 @@
           <a:p>
             <a:r>
               <a:rPr lang="en-US" dirty="0"/>
-              <a:t>This is THE slide — every later decision traces back to this inversion.</a:t>
+              <a:t>THE slide — the gradient proves the inversion is real, not an artefact of the 40/80 cutoffs.</a:t>
             </a:r>
             <a:endParaRPr lang="en-US" dirty="0"/>
           </a:p>
@@ -1839,7 +2195,7 @@
           <a:p>
             <a:r>
               <a:rPr lang="en-US" dirty="0"/>
-              <a:t>Two honest negatives (geography, age) + one behavioural positive.</a:t>
+              <a:t>One honest negative (age) and one habit insight (fuel/groceries are near-universal).</a:t>
             </a:r>
             <a:endParaRPr lang="en-US" dirty="0"/>
           </a:p>
@@ -1927,7 +2283,7 @@
           <a:p>
             <a:r>
               <a:rPr lang="en-US" dirty="0"/>
-              <a:t>Nobody is chronically unhealthy — trigger on the month, not the person.</a:t>
+              <a:t>Q3 asked for the channel breakdown — it answers itself: every hub has the national mix.</a:t>
             </a:r>
             <a:endParaRPr lang="en-US" dirty="0"/>
           </a:p>
@@ -2015,7 +2371,7 @@
           <a:p>
             <a:r>
               <a:rPr lang="en-US" dirty="0"/>
-              <a:t>Two ratios are the whole game — and the stressed are active, not disengaged.</a:t>
+              <a:t>Nobody is chronically unhealthy — trigger on the month, not the person.</a:t>
             </a:r>
             <a:endParaRPr lang="en-US" dirty="0"/>
           </a:p>
@@ -2688,7 +3044,7 @@
                 <a:ea typeface="Cambria" pitchFamily="34" charset="-122"/>
                 <a:cs typeface="Cambria" pitchFamily="34" charset="-120"/>
               </a:rPr>
-              <a:t>The "Stressed but Engaged" crossover</a:t>
+              <a:t>Low health is an overspend story</a:t>
             </a:r>
             <a:endParaRPr lang="en-US" sz="2700" dirty="0"/>
           </a:p>
@@ -2702,8 +3058,8 @@
         </p:nvSpPr>
         <p:spPr>
           <a:xfrm>
-            <a:off x="457200" y="1600200"/>
-            <a:ext cx="5760720" cy="3200400"/>
+            <a:off x="457200" y="1463040"/>
+            <a:ext cx="11247120" cy="1508760"/>
           </a:xfrm>
           <a:prstGeom prst="rect">
             <a:avLst/>
@@ -2731,7 +3087,7 @@
                 <a:ea typeface="Calibri" pitchFamily="34" charset="-122"/>
                 <a:cs typeface="Calibri" pitchFamily="34" charset="-120"/>
               </a:rPr>
-              <a:t>Reproducible rule (month grain): FHS &lt; 40 AND engagement ≥ p75 (81.4).</a:t>
+              <a:t>Top correlates: spend-to-income −0.90, credit-utilization −0.86, volatility −0.50. Stressed vs healthy months: spend/income 2.10 vs 0.29.</a:t>
             </a:r>
             <a:endParaRPr lang="en-US" sz="1400" dirty="0"/>
           </a:p>
@@ -2752,7 +3108,7 @@
                 <a:ea typeface="Calibri" pitchFamily="34" charset="-122"/>
                 <a:cs typeface="Calibri" pitchFamily="34" charset="-120"/>
               </a:rPr>
-              <a:t>43 consumers / 49 months = 52% of ALL stress episodes.</a:t>
+              <a:t>Step by step: mean FHS falls 72.4 → 68.4 → 66.0 → 63.8 → 60.9 across spend-to-income quintiles (−11.4 pts, ~10× the age spread).</a:t>
             </a:r>
             <a:endParaRPr lang="en-US" sz="1400" dirty="0"/>
           </a:p>
@@ -2773,28 +3129,7 @@
                 <a:ea typeface="Calibri" pitchFamily="34" charset="-122"/>
                 <a:cs typeface="Calibri" pitchFamily="34" charset="-120"/>
               </a:rPr>
-              <a:t>Profile: spend/income 1.89, credit-util 0.55, online 0.49 (2× national).</a:t>
-            </a:r>
-            <a:endParaRPr lang="en-US" sz="1400" dirty="0"/>
-          </a:p>
-          <a:p>
-            <a:pPr marL="177800" indent="-177800">
-              <a:spcAft>
-                <a:spcPts val="800"/>
-              </a:spcAft>
-              <a:buSzPct val="100000"/>
-              <a:buChar char="•"/>
-            </a:pPr>
-            <a:r>
-              <a:rPr lang="en-US" sz="1400" dirty="0">
-                <a:solidFill>
-                  <a:srgbClr val="1B2A36"/>
-                </a:solidFill>
-                <a:latin typeface="Calibri" pitchFamily="34" charset="0"/>
-                <a:ea typeface="Calibri" pitchFamily="34" charset="-122"/>
-                <a:cs typeface="Calibri" pitchFamily="34" charset="-120"/>
-              </a:rPr>
-              <a:t>Active, digital, over-extended — reachable at near-zero cost via in-app alerts.</a:t>
+              <a:t>Counter-intuitive: stressed months are MORE engaged (81.1 vs 72.7). FHS and ratios share spend fields — directional, not causal.</a:t>
             </a:r>
             <a:endParaRPr lang="en-US" sz="1400" dirty="0"/>
           </a:p>
@@ -2802,7 +3137,7 @@
       </p:sp>
       <p:pic>
         <p:nvPicPr>
-          <p:cNvPr id="5" name="Image 0" descr="D:\BI10GroupYAPPERS\outputs\figures\t2_crossover.png">    </p:cNvPr>
+          <p:cNvPr id="5" name="Image 0" descr="D:\BI10GroupYAPPERS\outputs\figures\t2_low_health_drivers.png">    </p:cNvPr>
           <p:cNvPicPr>
             <a:picLocks noChangeAspect="1"/>
           </p:cNvPicPr>
@@ -2815,156 +3150,40 @@
         </p:blipFill>
         <p:spPr>
           <a:xfrm>
-            <a:off x="6446520" y="1554480"/>
-            <a:ext cx="5303520" cy="4206240"/>
+            <a:off x="502920" y="3063240"/>
+            <a:ext cx="5440680" cy="3200400"/>
           </a:xfrm>
           <a:prstGeom prst="rect">
             <a:avLst/>
           </a:prstGeom>
         </p:spPr>
       </p:pic>
-      <p:sp>
-        <p:nvSpPr>
-          <p:cNvPr id="6" name="Text 3"/>
-          <p:cNvSpPr txBox="1"/>
-          <p:nvPr/>
-        </p:nvSpPr>
-        <p:spPr>
-          <a:xfrm>
-            <a:off x="6446520" y="5852160"/>
-            <a:ext cx="5303520" cy="548640"/>
-          </a:xfrm>
-          <a:prstGeom prst="rect">
-            <a:avLst/>
-          </a:prstGeom>
-          <a:noFill/>
-          <a:ln/>
-        </p:spPr>
-        <p:txBody>
-          <a:bodyPr wrap="square" lIns="0" tIns="0" rIns="0" bIns="0" rtlCol="0" anchor="t"/>
-          <a:lstStyle/>
-          <a:p>
-            <a:pPr indent="0" marL="0">
-              <a:buNone/>
-            </a:pPr>
-            <a:r>
-              <a:rPr lang="en-US" sz="1000" i="1" dirty="0">
-                <a:solidFill>
-                  <a:srgbClr val="5F7180"/>
-                </a:solidFill>
-                <a:latin typeface="Calibri" pitchFamily="34" charset="0"/>
-                <a:ea typeface="Calibri" pitchFamily="34" charset="-122"/>
-                <a:cs typeface="Calibri" pitchFamily="34" charset="-120"/>
-              </a:rPr>
-              <a:t>⚠  49 months / 43 consumers is a small synthetic cell — a directional archetype.</a:t>
-            </a:r>
-            <a:endParaRPr lang="en-US" sz="1000" dirty="0"/>
-          </a:p>
-        </p:txBody>
-      </p:sp>
-      <p:sp>
-        <p:nvSpPr>
-          <p:cNvPr id="7" name="Shape 4"/>
-          <p:cNvSpPr/>
-          <p:nvPr/>
-        </p:nvSpPr>
-        <p:spPr>
-          <a:xfrm>
-            <a:off x="457200" y="5029200"/>
-            <a:ext cx="3383280" cy="1097280"/>
-          </a:xfrm>
-          <a:prstGeom prst="roundRect">
-            <a:avLst>
-              <a:gd name="adj" fmla="val 6667"/>
-            </a:avLst>
-          </a:prstGeom>
-          <a:solidFill>
-            <a:srgbClr val="12435E"/>
-          </a:solidFill>
-          <a:ln/>
-        </p:spPr>
-      </p:sp>
-      <p:sp>
-        <p:nvSpPr>
-          <p:cNvPr id="8" name="Text 5"/>
-          <p:cNvSpPr txBox="1"/>
-          <p:nvPr/>
-        </p:nvSpPr>
-        <p:spPr>
-          <a:xfrm>
-            <a:off x="457200" y="5138928"/>
-            <a:ext cx="3383280" cy="658368"/>
-          </a:xfrm>
-          <a:prstGeom prst="rect">
-            <a:avLst/>
-          </a:prstGeom>
-          <a:noFill/>
-          <a:ln/>
-        </p:spPr>
-        <p:txBody>
-          <a:bodyPr wrap="square" lIns="0" tIns="0" rIns="0" bIns="0" rtlCol="0" anchor="ctr"/>
-          <a:lstStyle/>
-          <a:p>
-            <a:pPr algn="ctr" indent="0" marL="0">
-              <a:buNone/>
-            </a:pPr>
-            <a:r>
-              <a:rPr lang="en-US" sz="2800" b="1" dirty="0">
-                <a:solidFill>
-                  <a:srgbClr val="1FC3A6"/>
-                </a:solidFill>
-                <a:latin typeface="Cambria" pitchFamily="34" charset="0"/>
-                <a:ea typeface="Cambria" pitchFamily="34" charset="-122"/>
-                <a:cs typeface="Cambria" pitchFamily="34" charset="-120"/>
-              </a:rPr>
-              <a:t>52%</a:t>
-            </a:r>
-            <a:endParaRPr lang="en-US" sz="2800" dirty="0"/>
-          </a:p>
-        </p:txBody>
-      </p:sp>
-      <p:sp>
-        <p:nvSpPr>
-          <p:cNvPr id="9" name="Text 6"/>
-          <p:cNvSpPr txBox="1"/>
-          <p:nvPr/>
-        </p:nvSpPr>
-        <p:spPr>
-          <a:xfrm>
-            <a:off x="457200" y="5779008"/>
-            <a:ext cx="3383280" cy="320040"/>
-          </a:xfrm>
-          <a:prstGeom prst="rect">
-            <a:avLst/>
-          </a:prstGeom>
-          <a:noFill/>
-          <a:ln/>
-        </p:spPr>
-        <p:txBody>
-          <a:bodyPr wrap="square" lIns="0" tIns="0" rIns="0" bIns="0" rtlCol="0" anchor="ctr"/>
-          <a:lstStyle/>
-          <a:p>
-            <a:pPr algn="ctr" indent="0" marL="0">
-              <a:buNone/>
-            </a:pPr>
-            <a:r>
-              <a:rPr lang="en-US" sz="1100" dirty="0">
-                <a:solidFill>
-                  <a:srgbClr val="FFFFFF"/>
-                </a:solidFill>
-                <a:latin typeface="Calibri" pitchFamily="34" charset="0"/>
-                <a:ea typeface="Calibri" pitchFamily="34" charset="-122"/>
-                <a:cs typeface="Calibri" pitchFamily="34" charset="-120"/>
-              </a:rPr>
-              <a:t>of all stress episodes</a:t>
-            </a:r>
-            <a:endParaRPr lang="en-US" sz="1100" dirty="0"/>
-          </a:p>
-        </p:txBody>
-      </p:sp>
-      <p:sp>
-        <p:nvSpPr>
-          <p:cNvPr id="10" name="Text 7"/>
+      <p:pic>
+        <p:nvPicPr>
+          <p:cNvPr id="6" name="Image 1" descr="D:\BI10GroupYAPPERS\outputs\figures\t2_sti_quintile.png">    </p:cNvPr>
+          <p:cNvPicPr>
+            <a:picLocks noChangeAspect="1"/>
+          </p:cNvPicPr>
+          <p:nvPr/>
+        </p:nvPicPr>
+        <p:blipFill>
+          <a:blip r:embed="rId2"/>
+          <a:srcRect l="0" r="0" t="0" b="0"/>
+          <a:stretch/>
+        </p:blipFill>
+        <p:spPr>
+          <a:xfrm>
+            <a:off x="6263640" y="3063240"/>
+            <a:ext cx="5440680" cy="3200400"/>
+          </a:xfrm>
+          <a:prstGeom prst="rect">
+            <a:avLst/>
+          </a:prstGeom>
+        </p:spPr>
+      </p:pic>
+      <p:sp>
+        <p:nvSpPr>
+          <p:cNvPr id="7" name="Text 3"/>
           <p:cNvSpPr txBox="1"/>
           <p:nvPr/>
         </p:nvSpPr>
@@ -3003,7 +3222,7 @@
       </p:sp>
       <p:sp>
         <p:nvSpPr>
-          <p:cNvPr id="11" name="Text 8"/>
+          <p:cNvPr id="8" name="Text 4"/>
           <p:cNvSpPr txBox="1"/>
           <p:nvPr/>
         </p:nvSpPr>
@@ -3105,7 +3324,7 @@
                 <a:ea typeface="Calibri" pitchFamily="34" charset="-122"/>
                 <a:cs typeface="Calibri" pitchFamily="34" charset="-120"/>
               </a:rPr>
-              <a:t>TASK 3 · ENGAGEMENT</a:t>
+              <a:t>TASK 2 · FINANCIAL HEALTH</a:t>
             </a:r>
             <a:endParaRPr lang="en-US" sz="1100" dirty="0"/>
           </a:p>
@@ -3147,7 +3366,7 @@
                 <a:ea typeface="Cambria" pitchFamily="34" charset="-122"/>
                 <a:cs typeface="Cambria" pitchFamily="34" charset="-120"/>
               </a:rPr>
-              <a:t>Engagement is saturated; digital is broad but shallow</a:t>
+              <a:t>The "Stressed but Engaged" crossover — and when to reach it</a:t>
             </a:r>
             <a:endParaRPr lang="en-US" sz="2700" dirty="0"/>
           </a:p>
@@ -3190,7 +3409,7 @@
                 <a:ea typeface="Calibri" pitchFamily="34" charset="-122"/>
                 <a:cs typeface="Calibri" pitchFamily="34" charset="-120"/>
               </a:rPr>
-              <a:t>99.0% of consumer-months are high/very-high engagement (mean 77.8) — the score does NOT segment the base.</a:t>
+              <a:t>Rule (month grain): FHS &lt; 40 AND engagement ≥ p75 (81.4) → 43 consumers = 52% of ALL stress episodes; stable at p70/p80 (44/41 consumers, 53%/48%).</a:t>
             </a:r>
             <a:endParaRPr lang="en-US" sz="1400" dirty="0"/>
           </a:p>
@@ -3211,7 +3430,7 @@
                 <a:ea typeface="Calibri" pitchFamily="34" charset="-122"/>
                 <a:cs typeface="Calibri" pitchFamily="34" charset="-120"/>
               </a:rPr>
-              <a:t>Channel mix: POS 58.8% · QR 19.8% · E-com 8.7% · Mobile 7.7% · Recurring 4.9% → digital = 41% of trips but only 21% of spend.</a:t>
+              <a:t>Stressed months put 23.5% of spend into 22–23h vs 8.3% for healthy — bigger late-night tickets, not more of them (count 11.6% vs 9.7%).</a:t>
             </a:r>
             <a:endParaRPr lang="en-US" sz="1400" dirty="0"/>
           </a:p>
@@ -3232,7 +3451,7 @@
                 <a:ea typeface="Calibri" pitchFamily="34" charset="-122"/>
                 <a:cs typeface="Calibri" pitchFamily="34" charset="-120"/>
               </a:rPr>
-              <a:t>Digital handles many small tickets; big baskets stay on POS. Grow digital value, not just reach. (Note: synthetic cards are engineered highly active — the 99% is partly an artefact.)</a:t>
+              <a:t>Sunday + Monday carry 42% of stressed spend (vs 34%) → send pacing alerts Sunday–Monday evenings, before 22:00.</a:t>
             </a:r>
             <a:endParaRPr lang="en-US" sz="1400" dirty="0"/>
           </a:p>
@@ -3240,7 +3459,7 @@
       </p:sp>
       <p:pic>
         <p:nvPicPr>
-          <p:cNvPr id="5" name="Image 0" descr="D:\BI10GroupYAPPERS\outputs\figures\t3_engagement_dist.png">    </p:cNvPr>
+          <p:cNvPr id="5" name="Image 0" descr="D:\BI10GroupYAPPERS\outputs\figures\t2_crossover.png">    </p:cNvPr>
           <p:cNvPicPr>
             <a:picLocks noChangeAspect="1"/>
           </p:cNvPicPr>
@@ -3263,7 +3482,7 @@
       </p:pic>
       <p:pic>
         <p:nvPicPr>
-          <p:cNvPr id="6" name="Image 1" descr="D:\BI10GroupYAPPERS\outputs\figures\t3_channel_mix.png">    </p:cNvPr>
+          <p:cNvPr id="6" name="Image 1" descr="D:\BI10GroupYAPPERS\outputs\figures\t2_timing.png">    </p:cNvPr>
           <p:cNvPicPr>
             <a:picLocks noChangeAspect="1"/>
           </p:cNvPicPr>
@@ -3427,7 +3646,7 @@
                 <a:ea typeface="Calibri" pitchFamily="34" charset="-122"/>
                 <a:cs typeface="Calibri" pitchFamily="34" charset="-120"/>
               </a:rPr>
-              <a:t>TASK 3 · ENGAGEMENT</a:t>
+              <a:t>TASK 2 · FINANCIAL HEALTH</a:t>
             </a:r>
             <a:endParaRPr lang="en-US" sz="1100" dirty="0"/>
           </a:p>
@@ -3469,7 +3688,7 @@
                 <a:ea typeface="Cambria" pitchFamily="34" charset="-122"/>
                 <a:cs typeface="Cambria" pitchFamily="34" charset="-120"/>
               </a:rPr>
-              <a:t>What actually discriminates: diversity &amp; consistency</a:t>
+              <a:t>Who differs? Province and age barely; occupation through spending</a:t>
             </a:r>
             <a:endParaRPr lang="en-US" sz="2700" dirty="0"/>
           </a:p>
@@ -3483,8 +3702,8 @@
         </p:nvSpPr>
         <p:spPr>
           <a:xfrm>
-            <a:off x="457200" y="1600200"/>
-            <a:ext cx="5760720" cy="3200400"/>
+            <a:off x="457200" y="1463040"/>
+            <a:ext cx="11247120" cy="1417320"/>
           </a:xfrm>
           <a:prstGeom prst="rect">
             <a:avLst/>
@@ -3512,7 +3731,7 @@
                 <a:ea typeface="Calibri" pitchFamily="34" charset="-122"/>
                 <a:cs typeface="Calibri" pitchFamily="34" charset="-120"/>
               </a:rPr>
-              <a:t>Category diversity is the cleanest signal: r +0.94 with engagement (consumer level).</a:t>
+              <a:t>Province: 22 of 27 provinces (≥15 consumers) have a 95% CI containing the national mean 66.3. Age: all six cohort CIs overlap.</a:t>
             </a:r>
             <a:endParaRPr lang="en-US" sz="1400" dirty="0"/>
           </a:p>
@@ -3533,7 +3752,7 @@
                 <a:ea typeface="Calibri" pitchFamily="34" charset="-122"/>
                 <a:cs typeface="Calibri" pitchFamily="34" charset="-120"/>
               </a:rPr>
-              <a:t>The dormant tail is disengaged because it is narrow — 4–6 categories vs ~14 for the core.</a:t>
+              <a:t>Occupation (396 titles → 8 groups): Engineering/IT 69.1 and Business/finance 68.7 vs Office/public 64.5 and Manual 62.9 — a ~6-pt spread that mirrors spend-to-income (0.60 vs 0.76–0.79).</a:t>
             </a:r>
             <a:endParaRPr lang="en-US" sz="1400" dirty="0"/>
           </a:p>
@@ -3554,28 +3773,7 @@
                 <a:ea typeface="Calibri" pitchFamily="34" charset="-122"/>
                 <a:cs typeface="Calibri" pitchFamily="34" charset="-120"/>
               </a:rPr>
-              <a:t>Consistency (active days r +0.59) beats raw volume (txn count r +0.40).</a:t>
-            </a:r>
-            <a:endParaRPr lang="en-US" sz="1400" dirty="0"/>
-          </a:p>
-          <a:p>
-            <a:pPr marL="177800" indent="-177800">
-              <a:spcAft>
-                <a:spcPts val="800"/>
-              </a:spcAft>
-              <a:buSzPct val="100000"/>
-              <a:buChar char="•"/>
-            </a:pPr>
-            <a:r>
-              <a:rPr lang="en-US" sz="1400" dirty="0">
-                <a:solidFill>
-                  <a:srgbClr val="1B2A36"/>
-                </a:solidFill>
-                <a:latin typeface="Calibri" pitchFamily="34" charset="0"/>
-                <a:ea typeface="Calibri" pitchFamily="34" charset="-122"/>
-                <a:cs typeface="Calibri" pitchFamily="34" charset="-120"/>
-              </a:rPr>
-              <a:t>A falling category count flags disengagement before the composite score moves.</a:t>
+              <a:t>Demographics act through the overspend ratio → target the ratio, never the group.</a:t>
             </a:r>
             <a:endParaRPr lang="en-US" sz="1400" dirty="0"/>
           </a:p>
@@ -3583,7 +3781,7 @@
       </p:sp>
       <p:pic>
         <p:nvPicPr>
-          <p:cNvPr id="5" name="Image 0" descr="D:\BI10GroupYAPPERS\outputs\figures\t3_diversity_vs_engagement.png">    </p:cNvPr>
+          <p:cNvPr id="5" name="Image 0" descr="D:\BI10GroupYAPPERS\outputs\figures\t2_demographics.png">    </p:cNvPr>
           <p:cNvPicPr>
             <a:picLocks noChangeAspect="1"/>
           </p:cNvPicPr>
@@ -3596,8 +3794,8 @@
         </p:blipFill>
         <p:spPr>
           <a:xfrm>
-            <a:off x="6446520" y="1554480"/>
-            <a:ext cx="5303520" cy="4206240"/>
+            <a:off x="457200" y="2926080"/>
+            <a:ext cx="11247120" cy="3474720"/>
           </a:xfrm>
           <a:prstGeom prst="rect">
             <a:avLst/>
@@ -3789,7 +3987,7 @@
                 <a:ea typeface="Cambria" pitchFamily="34" charset="-122"/>
                 <a:cs typeface="Cambria" pitchFamily="34" charset="-120"/>
               </a:rPr>
-              <a:t>High-health, low-engagement: dormancy hiding in "healthy"</a:t>
+              <a:t>Engagement is saturated; digital is broad but shallow</a:t>
             </a:r>
             <a:endParaRPr lang="en-US" sz="2700" dirty="0"/>
           </a:p>
@@ -3803,8 +4001,8 @@
         </p:nvSpPr>
         <p:spPr>
           <a:xfrm>
-            <a:off x="457200" y="1600200"/>
-            <a:ext cx="5760720" cy="3200400"/>
+            <a:off x="457200" y="1463040"/>
+            <a:ext cx="11247120" cy="1508760"/>
           </a:xfrm>
           <a:prstGeom prst="rect">
             <a:avLst/>
@@ -3832,7 +4030,7 @@
                 <a:ea typeface="Calibri" pitchFamily="34" charset="-122"/>
                 <a:cs typeface="Calibri" pitchFamily="34" charset="-120"/>
               </a:rPr>
-              <a:t>Cutoff: FHS ≥ 70 AND engagement &lt; 70 → 25 consumers (2.5%).</a:t>
+              <a:t>Consumers by engagement segment: Low 1.0% · Medium 8.0% · High 74.1% · Very high 16.9% — the score does NOT segment the base.</a:t>
             </a:r>
             <a:endParaRPr lang="en-US" sz="1400" dirty="0"/>
           </a:p>
@@ -3853,7 +4051,7 @@
                 <a:ea typeface="Calibri" pitchFamily="34" charset="-122"/>
                 <a:cs typeface="Calibri" pitchFamily="34" charset="-120"/>
               </a:rPr>
-              <a:t>Why 70: the same 25 return at eng &lt; 65/68/70 — a natural gap in the data.</a:t>
+              <a:t>Channel mix: POS 58.8% · QR 19.8% · E-com 8.7% · Mobile 7.7% · Recurring 4.9%; average online spend share 24.7% per consumer.</a:t>
             </a:r>
             <a:endParaRPr lang="en-US" sz="1400" dirty="0"/>
           </a:p>
@@ -3874,28 +4072,7 @@
                 <a:ea typeface="Calibri" pitchFamily="34" charset="-122"/>
                 <a:cs typeface="Calibri" pitchFamily="34" charset="-120"/>
               </a:rPr>
-              <a:t>They moved spend off-card to narrow online use (diversity 4.7 vs 13.2; online 0.61 vs 0.24).</a:t>
-            </a:r>
-            <a:endParaRPr lang="en-US" sz="1400" dirty="0"/>
-          </a:p>
-          <a:p>
-            <a:pPr marL="177800" indent="-177800">
-              <a:spcAft>
-                <a:spcPts val="800"/>
-              </a:spcAft>
-              <a:buSzPct val="100000"/>
-              <a:buChar char="•"/>
-            </a:pPr>
-            <a:r>
-              <a:rPr lang="en-US" sz="1400" dirty="0">
-                <a:solidFill>
-                  <a:srgbClr val="1B2A36"/>
-                </a:solidFill>
-                <a:latin typeface="Calibri" pitchFamily="34" charset="0"/>
-                <a:ea typeface="Calibri" pitchFamily="34" charset="-122"/>
-                <a:cs typeface="Calibri" pitchFamily="34" charset="-120"/>
-              </a:rPr>
-              <a:t>Play = reactivation of everyday use, NOT budgeting — distinct from the 67 distress-tail customers.</a:t>
+              <a:t>Non-POS channels carry 41% of trips and 41.5% of value (same ticket size as POS); truly online E-com + Mobile is ~17% of value.</a:t>
             </a:r>
             <a:endParaRPr lang="en-US" sz="1400" dirty="0"/>
           </a:p>
@@ -3903,7 +4080,7 @@
       </p:sp>
       <p:pic>
         <p:nvPicPr>
-          <p:cNvPr id="5" name="Image 0" descr="D:\BI10GroupYAPPERS\outputs\figures\t3_health_vs_engagement_quadrant.png">    </p:cNvPr>
+          <p:cNvPr id="5" name="Image 0" descr="D:\BI10GroupYAPPERS\outputs\figures\t3_segment_share.png">    </p:cNvPr>
           <p:cNvPicPr>
             <a:picLocks noChangeAspect="1"/>
           </p:cNvPicPr>
@@ -3916,56 +4093,40 @@
         </p:blipFill>
         <p:spPr>
           <a:xfrm>
-            <a:off x="6446520" y="1554480"/>
-            <a:ext cx="5303520" cy="4206240"/>
+            <a:off x="502920" y="3063240"/>
+            <a:ext cx="5440680" cy="3200400"/>
           </a:xfrm>
           <a:prstGeom prst="rect">
             <a:avLst/>
           </a:prstGeom>
         </p:spPr>
       </p:pic>
-      <p:sp>
-        <p:nvSpPr>
-          <p:cNvPr id="6" name="Text 3"/>
-          <p:cNvSpPr txBox="1"/>
-          <p:nvPr/>
-        </p:nvSpPr>
-        <p:spPr>
-          <a:xfrm>
-            <a:off x="6446520" y="5852160"/>
-            <a:ext cx="5303520" cy="548640"/>
-          </a:xfrm>
-          <a:prstGeom prst="rect">
-            <a:avLst/>
-          </a:prstGeom>
-          <a:noFill/>
-          <a:ln/>
-        </p:spPr>
-        <p:txBody>
-          <a:bodyPr wrap="square" lIns="0" tIns="0" rIns="0" bIns="0" rtlCol="0" anchor="t"/>
-          <a:lstStyle/>
-          <a:p>
-            <a:pPr indent="0" marL="0">
-              <a:buNone/>
-            </a:pPr>
-            <a:r>
-              <a:rPr lang="en-US" sz="1000" i="1" dirty="0">
-                <a:solidFill>
-                  <a:srgbClr val="5F7180"/>
-                </a:solidFill>
-                <a:latin typeface="Calibri" pitchFamily="34" charset="0"/>
-                <a:ea typeface="Calibri" pitchFamily="34" charset="-122"/>
-                <a:cs typeface="Calibri" pitchFamily="34" charset="-120"/>
-              </a:rPr>
-              <a:t>⚠  n = 25, synthetic-inflated engagement — a cohort to watch, not a sized forecast.</a:t>
-            </a:r>
-            <a:endParaRPr lang="en-US" sz="1000" dirty="0"/>
-          </a:p>
-        </p:txBody>
-      </p:sp>
-      <p:sp>
-        <p:nvSpPr>
-          <p:cNvPr id="7" name="Text 4"/>
+      <p:pic>
+        <p:nvPicPr>
+          <p:cNvPr id="6" name="Image 1" descr="D:\BI10GroupYAPPERS\outputs\figures\t3_channel_mix.png">    </p:cNvPr>
+          <p:cNvPicPr>
+            <a:picLocks noChangeAspect="1"/>
+          </p:cNvPicPr>
+          <p:nvPr/>
+        </p:nvPicPr>
+        <p:blipFill>
+          <a:blip r:embed="rId2"/>
+          <a:srcRect l="0" r="0" t="0" b="0"/>
+          <a:stretch/>
+        </p:blipFill>
+        <p:spPr>
+          <a:xfrm>
+            <a:off x="6263640" y="3063240"/>
+            <a:ext cx="5440680" cy="3200400"/>
+          </a:xfrm>
+          <a:prstGeom prst="rect">
+            <a:avLst/>
+          </a:prstGeom>
+        </p:spPr>
+      </p:pic>
+      <p:sp>
+        <p:nvSpPr>
+          <p:cNvPr id="7" name="Text 3"/>
           <p:cNvSpPr txBox="1"/>
           <p:nvPr/>
         </p:nvSpPr>
@@ -4004,7 +4165,7 @@
       </p:sp>
       <p:sp>
         <p:nvSpPr>
-          <p:cNvPr id="8" name="Text 5"/>
+          <p:cNvPr id="8" name="Text 4"/>
           <p:cNvSpPr txBox="1"/>
           <p:nvPr/>
         </p:nvSpPr>
@@ -4106,7 +4267,7 @@
                 <a:ea typeface="Calibri" pitchFamily="34" charset="-122"/>
                 <a:cs typeface="Calibri" pitchFamily="34" charset="-120"/>
               </a:rPr>
-              <a:t>TASK 4 · SEGMENTATION</a:t>
+              <a:t>TASK 3 · ENGAGEMENT</a:t>
             </a:r>
             <a:endParaRPr lang="en-US" sz="1100" dirty="0"/>
           </a:p>
@@ -4148,7 +4309,7 @@
                 <a:ea typeface="Cambria" pitchFamily="34" charset="-122"/>
                 <a:cs typeface="Cambria" pitchFamily="34" charset="-120"/>
               </a:rPr>
-              <a:t>Method: cluster on behaviour, justify k honestly</a:t>
+              <a:t>What actually discriminates: diversity &amp; consistency</a:t>
             </a:r>
             <a:endParaRPr lang="en-US" sz="2700" dirty="0"/>
           </a:p>
@@ -4162,8 +4323,8 @@
         </p:nvSpPr>
         <p:spPr>
           <a:xfrm>
-            <a:off x="457200" y="1600200"/>
-            <a:ext cx="5760720" cy="3200400"/>
+            <a:off x="457200" y="1463040"/>
+            <a:ext cx="11247120" cy="1508760"/>
           </a:xfrm>
           <a:prstGeom prst="rect">
             <a:avLst/>
@@ -4191,7 +4352,7 @@
                 <a:ea typeface="Calibri" pitchFamily="34" charset="-122"/>
                 <a:cs typeface="Calibri" pitchFamily="34" charset="-120"/>
               </a:rPr>
-              <a:t>Aggregate 10,992 consumer-months → 999 consumers (yearly mean profile).</a:t>
+              <a:t>Category diversity: r +0.94 with engagement; still +0.81 without the dormant tail (Spearman +0.85) — not a tail artefact.</a:t>
             </a:r>
             <a:endParaRPr lang="en-US" sz="1400" dirty="0"/>
           </a:p>
@@ -4212,7 +4373,7 @@
                 <a:ea typeface="Calibri" pitchFamily="34" charset="-122"/>
                 <a:cs typeface="Calibri" pitchFamily="34" charset="-120"/>
               </a:rPr>
-              <a:t>8 z-scaled behavioural features across health, engagement &amp; spending; demographics excluded (no signal).</a:t>
+              <a:t>Heatmap: 30–31 active days &amp; recency 0 → engagement 79.8 (n=6,614); every 1–5-active-day cell stays ≤ 55 whatever the recency.</a:t>
             </a:r>
             <a:endParaRPr lang="en-US" sz="1400" dirty="0"/>
           </a:p>
@@ -4233,28 +4394,7 @@
                 <a:ea typeface="Calibri" pitchFamily="34" charset="-122"/>
                 <a:cs typeface="Calibri" pitchFamily="34" charset="-120"/>
               </a:rPr>
-              <a:t>k-means chosen over a pure 2×2 so boundaries form across all 8 dimensions at once.</a:t>
-            </a:r>
-            <a:endParaRPr lang="en-US" sz="1400" dirty="0"/>
-          </a:p>
-          <a:p>
-            <a:pPr marL="177800" indent="-177800">
-              <a:spcAft>
-                <a:spcPts val="800"/>
-              </a:spcAft>
-              <a:buSzPct val="100000"/>
-              <a:buChar char="•"/>
-            </a:pPr>
-            <a:r>
-              <a:rPr lang="en-US" sz="1400" dirty="0">
-                <a:solidFill>
-                  <a:srgbClr val="1B2A36"/>
-                </a:solidFill>
-                <a:latin typeface="Calibri" pitchFamily="34" charset="0"/>
-                <a:ea typeface="Calibri" pitchFamily="34" charset="-122"/>
-                <a:cs typeface="Calibri" pitchFamily="34" charset="-120"/>
-              </a:rPr>
-              <a:t>k=4 via elbow + silhouette (0.251); coverage 999/999, all 7 minors retained — PASS.</a:t>
+              <a:t>Consistency beats recency and volume → build the early-warning flag on falling diversity and active days.</a:t>
             </a:r>
             <a:endParaRPr lang="en-US" sz="1400" dirty="0"/>
           </a:p>
@@ -4262,7 +4402,7 @@
       </p:sp>
       <p:pic>
         <p:nvPicPr>
-          <p:cNvPr id="5" name="Image 0" descr="D:\BI10GroupYAPPERS\outputs\figures\t4_silhouette.png">    </p:cNvPr>
+          <p:cNvPr id="5" name="Image 0" descr="D:\BI10GroupYAPPERS\outputs\figures\t3_diversity_vs_engagement.png">    </p:cNvPr>
           <p:cNvPicPr>
             <a:picLocks noChangeAspect="1"/>
           </p:cNvPicPr>
@@ -4275,17 +4415,40 @@
         </p:blipFill>
         <p:spPr>
           <a:xfrm>
-            <a:off x="6446520" y="1554480"/>
-            <a:ext cx="5303520" cy="4206240"/>
+            <a:off x="502920" y="3063240"/>
+            <a:ext cx="5440680" cy="3200400"/>
           </a:xfrm>
           <a:prstGeom prst="rect">
             <a:avLst/>
           </a:prstGeom>
         </p:spPr>
       </p:pic>
-      <p:sp>
-        <p:nvSpPr>
-          <p:cNvPr id="6" name="Text 3"/>
+      <p:pic>
+        <p:nvPicPr>
+          <p:cNvPr id="6" name="Image 1" descr="D:\BI10GroupYAPPERS\outputs\figures\t3_recency_frequency.png">    </p:cNvPr>
+          <p:cNvPicPr>
+            <a:picLocks noChangeAspect="1"/>
+          </p:cNvPicPr>
+          <p:nvPr/>
+        </p:nvPicPr>
+        <p:blipFill>
+          <a:blip r:embed="rId2"/>
+          <a:srcRect l="0" r="0" t="0" b="0"/>
+          <a:stretch/>
+        </p:blipFill>
+        <p:spPr>
+          <a:xfrm>
+            <a:off x="6263640" y="3063240"/>
+            <a:ext cx="5440680" cy="3200400"/>
+          </a:xfrm>
+          <a:prstGeom prst="rect">
+            <a:avLst/>
+          </a:prstGeom>
+        </p:spPr>
+      </p:pic>
+      <p:sp>
+        <p:nvSpPr>
+          <p:cNvPr id="7" name="Text 3"/>
           <p:cNvSpPr txBox="1"/>
           <p:nvPr/>
         </p:nvSpPr>
@@ -4324,7 +4487,7 @@
       </p:sp>
       <p:sp>
         <p:nvSpPr>
-          <p:cNvPr id="7" name="Text 4"/>
+          <p:cNvPr id="8" name="Text 4"/>
           <p:cNvSpPr txBox="1"/>
           <p:nvPr/>
         </p:nvSpPr>
@@ -4426,7 +4589,7 @@
                 <a:ea typeface="Calibri" pitchFamily="34" charset="-122"/>
                 <a:cs typeface="Calibri" pitchFamily="34" charset="-120"/>
               </a:rPr>
-              <a:t>TASK 4 · SEGMENTATION</a:t>
+              <a:t>TASK 3 · ENGAGEMENT</a:t>
             </a:r>
             <a:endParaRPr lang="en-US" sz="1100" dirty="0"/>
           </a:p>
@@ -4468,7 +4631,7 @@
                 <a:ea typeface="Cambria" pitchFamily="34" charset="-122"/>
                 <a:cs typeface="Cambria" pitchFamily="34" charset="-120"/>
               </a:rPr>
-              <a:t>The four customer segments</a:t>
+              <a:t>High-health, low-engagement: dormancy hiding in "healthy"</a:t>
             </a:r>
             <a:endParaRPr lang="en-US" sz="2700" dirty="0"/>
           </a:p>
@@ -4482,8 +4645,8 @@
         </p:nvSpPr>
         <p:spPr>
           <a:xfrm>
-            <a:off x="457200" y="1463040"/>
-            <a:ext cx="11247120" cy="1508760"/>
+            <a:off x="457200" y="1600200"/>
+            <a:ext cx="5760720" cy="3200400"/>
           </a:xfrm>
           <a:prstGeom prst="rect">
             <a:avLst/>
@@ -4511,7 +4674,7 @@
                 <a:ea typeface="Calibri" pitchFamily="34" charset="-122"/>
                 <a:cs typeface="Calibri" pitchFamily="34" charset="-120"/>
               </a:rPr>
-              <a:t>Financially Healthy &amp; Highly Engaged — 351 (35%): FHS 70.5, lowest util 0.148 → retain &amp; grow value.</a:t>
+              <a:t>Cutoff: FHS ≥ 70 AND engagement &lt; 70 → 25 consumers (2.5%).</a:t>
             </a:r>
             <a:endParaRPr lang="en-US" sz="1400" dirty="0"/>
           </a:p>
@@ -4532,7 +4695,7 @@
                 <a:ea typeface="Calibri" pitchFamily="34" charset="-122"/>
                 <a:cs typeface="Calibri" pitchFamily="34" charset="-120"/>
               </a:rPr>
-              <a:t>Financially Stretched but Highly Engaged — 302 (30%): highest spend/income 0.835, still engaged → the wellbeing priority.</a:t>
+              <a:t>Why 70: the count is 25 at engagement &lt; 60, 65 and 70 (a natural gap) and jumps to 63 at &lt; 75; FHS ≥ 65 gives 48, ≥ 75 gives 9.</a:t>
             </a:r>
             <a:endParaRPr lang="en-US" sz="1400" dirty="0"/>
           </a:p>
@@ -4553,7 +4716,28 @@
                 <a:ea typeface="Calibri" pitchFamily="34" charset="-122"/>
                 <a:cs typeface="Calibri" pitchFamily="34" charset="-120"/>
               </a:rPr>
-              <a:t>High-Activity Digital Power Users — 258 (26%): most active &amp; volatile → monetise &amp; monitor drift.  ·  Low Engagement &amp; Emerging Digital — 88 (9%): near-dormant but 67% online → activate; highest growth headroom.</a:t>
+              <a:t>They moved spend to narrow online use (diversity 4.7 vs 13.2; online 0.61 vs 0.24); 24 of 25 sit in Emerging Digital.</a:t>
+            </a:r>
+            <a:endParaRPr lang="en-US" sz="1400" dirty="0"/>
+          </a:p>
+          <a:p>
+            <a:pPr marL="177800" indent="-177800">
+              <a:spcAft>
+                <a:spcPts val="800"/>
+              </a:spcAft>
+              <a:buSzPct val="100000"/>
+              <a:buChar char="•"/>
+            </a:pPr>
+            <a:r>
+              <a:rPr lang="en-US" sz="1400" dirty="0">
+                <a:solidFill>
+                  <a:srgbClr val="1B2A36"/>
+                </a:solidFill>
+                <a:latin typeface="Calibri" pitchFamily="34" charset="0"/>
+                <a:ea typeface="Calibri" pitchFamily="34" charset="-122"/>
+                <a:cs typeface="Calibri" pitchFamily="34" charset="-120"/>
+              </a:rPr>
+              <a:t>Play = reactivation of everyday use, NOT budgeting.</a:t>
             </a:r>
             <a:endParaRPr lang="en-US" sz="1400" dirty="0"/>
           </a:p>
@@ -4561,7 +4745,7 @@
       </p:sp>
       <p:pic>
         <p:nvPicPr>
-          <p:cNvPr id="5" name="Image 0" descr="D:\BI10GroupYAPPERS\outputs\figures\t4_segment_sizes.png">    </p:cNvPr>
+          <p:cNvPr id="5" name="Image 0" descr="D:\BI10GroupYAPPERS\outputs\figures\t3_health_vs_engagement_quadrant.png">    </p:cNvPr>
           <p:cNvPicPr>
             <a:picLocks noChangeAspect="1"/>
           </p:cNvPicPr>
@@ -4574,40 +4758,56 @@
         </p:blipFill>
         <p:spPr>
           <a:xfrm>
-            <a:off x="502920" y="3063240"/>
-            <a:ext cx="5440680" cy="3200400"/>
+            <a:off x="6446520" y="1554480"/>
+            <a:ext cx="5303520" cy="4206240"/>
           </a:xfrm>
           <a:prstGeom prst="rect">
             <a:avLst/>
           </a:prstGeom>
         </p:spPr>
       </p:pic>
-      <p:pic>
-        <p:nvPicPr>
-          <p:cNvPr id="6" name="Image 1" descr="D:\BI10GroupYAPPERS\outputs\figures\t4_segment_profiles.png">    </p:cNvPr>
-          <p:cNvPicPr>
-            <a:picLocks noChangeAspect="1"/>
-          </p:cNvPicPr>
-          <p:nvPr/>
-        </p:nvPicPr>
-        <p:blipFill>
-          <a:blip r:embed="rId2"/>
-          <a:srcRect l="0" r="0" t="0" b="0"/>
-          <a:stretch/>
-        </p:blipFill>
-        <p:spPr>
-          <a:xfrm>
-            <a:off x="6263640" y="3063240"/>
-            <a:ext cx="5440680" cy="3200400"/>
-          </a:xfrm>
-          <a:prstGeom prst="rect">
-            <a:avLst/>
-          </a:prstGeom>
-        </p:spPr>
-      </p:pic>
-      <p:sp>
-        <p:nvSpPr>
-          <p:cNvPr id="7" name="Text 3"/>
+      <p:sp>
+        <p:nvSpPr>
+          <p:cNvPr id="6" name="Text 3"/>
+          <p:cNvSpPr txBox="1"/>
+          <p:nvPr/>
+        </p:nvSpPr>
+        <p:spPr>
+          <a:xfrm>
+            <a:off x="6446520" y="5852160"/>
+            <a:ext cx="5303520" cy="548640"/>
+          </a:xfrm>
+          <a:prstGeom prst="rect">
+            <a:avLst/>
+          </a:prstGeom>
+          <a:noFill/>
+          <a:ln/>
+        </p:spPr>
+        <p:txBody>
+          <a:bodyPr wrap="square" lIns="0" tIns="0" rIns="0" bIns="0" rtlCol="0" anchor="t"/>
+          <a:lstStyle/>
+          <a:p>
+            <a:pPr indent="0" marL="0">
+              <a:buNone/>
+            </a:pPr>
+            <a:r>
+              <a:rPr lang="en-US" sz="1000" i="1" dirty="0">
+                <a:solidFill>
+                  <a:srgbClr val="5F7180"/>
+                </a:solidFill>
+                <a:latin typeface="Calibri" pitchFamily="34" charset="0"/>
+                <a:ea typeface="Calibri" pitchFamily="34" charset="-122"/>
+                <a:cs typeface="Calibri" pitchFamily="34" charset="-120"/>
+              </a:rPr>
+              <a:t>⚠  n = 25, synthetic-inflated engagement — a cohort to watch, not a sized forecast.</a:t>
+            </a:r>
+            <a:endParaRPr lang="en-US" sz="1000" dirty="0"/>
+          </a:p>
+        </p:txBody>
+      </p:sp>
+      <p:sp>
+        <p:nvSpPr>
+          <p:cNvPr id="7" name="Text 4"/>
           <p:cNvSpPr txBox="1"/>
           <p:nvPr/>
         </p:nvSpPr>
@@ -4646,7 +4846,7 @@
       </p:sp>
       <p:sp>
         <p:nvSpPr>
-          <p:cNvPr id="8" name="Text 4"/>
+          <p:cNvPr id="8" name="Text 5"/>
           <p:cNvSpPr txBox="1"/>
           <p:nvPr/>
         </p:nvSpPr>
@@ -4748,7 +4948,7 @@
                 <a:ea typeface="Calibri" pitchFamily="34" charset="-122"/>
                 <a:cs typeface="Calibri" pitchFamily="34" charset="-120"/>
               </a:rPr>
-              <a:t>TASK 5 · RECOMMENDATIONS</a:t>
+              <a:t>TASK 4 · SEGMENTATION</a:t>
             </a:r>
             <a:endParaRPr lang="en-US" sz="1100" dirty="0"/>
           </a:p>
@@ -4790,7 +4990,7 @@
                 <a:ea typeface="Cambria" pitchFamily="34" charset="-122"/>
                 <a:cs typeface="Cambria" pitchFamily="34" charset="-120"/>
               </a:rPr>
-              <a:t>A six-tool, non-punitive action plan</a:t>
+              <a:t>Method: cluster on behaviour, justify k honestly</a:t>
             </a:r>
             <a:endParaRPr lang="en-US" sz="2700" dirty="0"/>
           </a:p>
@@ -4833,7 +5033,7 @@
                 <a:ea typeface="Calibri" pitchFamily="34" charset="-122"/>
                 <a:cs typeface="Calibri" pitchFamily="34" charset="-120"/>
               </a:rPr>
-              <a:t>① Budgeting → Stretched-Engaged (302): spend-vs-income dashboard (driver −0.90).</a:t>
+              <a:t>Aggregate 10,992 consumer-months → 999 consumers (yearly mean profile); preprocessed dataset + dictionary delivered.</a:t>
             </a:r>
             <a:endParaRPr lang="en-US" sz="1400" dirty="0"/>
           </a:p>
@@ -4854,7 +5054,7 @@
                 <a:ea typeface="Calibri" pitchFamily="34" charset="-122"/>
                 <a:cs typeface="Calibri" pitchFamily="34" charset="-120"/>
               </a:rPr>
-              <a:t>② Spend alerts → Crossover (43 = 52% of stress): event-triggered in-app pacing.</a:t>
+              <a:t>8 z-scaled behavioural features across health, engagement &amp; spending; demographics kept out of clustering, used only to profile.</a:t>
             </a:r>
             <a:endParaRPr lang="en-US" sz="1400" dirty="0"/>
           </a:p>
@@ -4875,7 +5075,7 @@
                 <a:ea typeface="Calibri" pitchFamily="34" charset="-122"/>
                 <a:cs typeface="Calibri" pitchFamily="34" charset="-120"/>
               </a:rPr>
-              <a:t>③ Planning reminders → Power Users (258): pre-December pacing (volatility r −0.50).</a:t>
+              <a:t>k-means chosen over a pure 2×2 so boundaries form across all 8 dimensions at once.</a:t>
             </a:r>
             <a:endParaRPr lang="en-US" sz="1400" dirty="0"/>
           </a:p>
@@ -4896,49 +5096,7 @@
                 <a:ea typeface="Calibri" pitchFamily="34" charset="-122"/>
                 <a:cs typeface="Calibri" pitchFamily="34" charset="-120"/>
               </a:rPr>
-              <a:t>④ Education → Distress tail (67): needs-vs-wants modules (essential ratio +0.48).</a:t>
-            </a:r>
-            <a:endParaRPr lang="en-US" sz="1400" dirty="0"/>
-          </a:p>
-          <a:p>
-            <a:pPr marL="177800" indent="-177800">
-              <a:spcAft>
-                <a:spcPts val="800"/>
-              </a:spcAft>
-              <a:buSzPct val="100000"/>
-              <a:buChar char="•"/>
-            </a:pPr>
-            <a:r>
-              <a:rPr lang="en-US" sz="1400" dirty="0">
-                <a:solidFill>
-                  <a:srgbClr val="1B2A36"/>
-                </a:solidFill>
-                <a:latin typeface="Calibri" pitchFamily="34" charset="0"/>
-                <a:ea typeface="Calibri" pitchFamily="34" charset="-122"/>
-                <a:cs typeface="Calibri" pitchFamily="34" charset="-120"/>
-              </a:rPr>
-              <a:t>⑤ Digital nudges → Emerging Digital (88): onboarding &amp; habit loops (diversity r +0.94).</a:t>
-            </a:r>
-            <a:endParaRPr lang="en-US" sz="1400" dirty="0"/>
-          </a:p>
-          <a:p>
-            <a:pPr marL="177800" indent="-177800">
-              <a:spcAft>
-                <a:spcPts val="800"/>
-              </a:spcAft>
-              <a:buSzPct val="100000"/>
-              <a:buChar char="•"/>
-            </a:pPr>
-            <a:r>
-              <a:rPr lang="en-US" sz="1400" dirty="0">
-                <a:solidFill>
-                  <a:srgbClr val="1B2A36"/>
-                </a:solidFill>
-                <a:latin typeface="Calibri" pitchFamily="34" charset="0"/>
-                <a:ea typeface="Calibri" pitchFamily="34" charset="-122"/>
-                <a:cs typeface="Calibri" pitchFamily="34" charset="-120"/>
-              </a:rPr>
-              <a:t>⑥ Product suggestions → Healthy-Engaged (351): savings/loyalty, opt-in, never auto-extend.</a:t>
+              <a:t>k=4 via elbow + silhouette (0.251); coverage 999/999, all 7 minors retained — PASS.</a:t>
             </a:r>
             <a:endParaRPr lang="en-US" sz="1400" dirty="0"/>
           </a:p>
@@ -4946,7 +5104,7 @@
       </p:sp>
       <p:pic>
         <p:nvPicPr>
-          <p:cNvPr id="5" name="Image 0" descr="D:\BI10GroupYAPPERS\outputs\figures\t5_target_sizes.png">    </p:cNvPr>
+          <p:cNvPr id="5" name="Image 0" descr="D:\BI10GroupYAPPERS\outputs\figures\t4_silhouette.png">    </p:cNvPr>
           <p:cNvPicPr>
             <a:picLocks noChangeAspect="1"/>
           </p:cNvPicPr>
@@ -5110,7 +5268,7 @@
                 <a:ea typeface="Calibri" pitchFamily="34" charset="-122"/>
                 <a:cs typeface="Calibri" pitchFamily="34" charset="-120"/>
               </a:rPr>
-              <a:t>TASK 5 · RECOMMENDATIONS</a:t>
+              <a:t>TASK 4 · SEGMENTATION</a:t>
             </a:r>
             <a:endParaRPr lang="en-US" sz="1100" dirty="0"/>
           </a:p>
@@ -5152,7 +5310,7 @@
                 <a:ea typeface="Cambria" pitchFamily="34" charset="-122"/>
                 <a:cs typeface="Cambria" pitchFamily="34" charset="-120"/>
               </a:rPr>
-              <a:t>Prioritization &amp; the ethical rule</a:t>
+              <a:t>The four customer segments</a:t>
             </a:r>
             <a:endParaRPr lang="en-US" sz="2700" dirty="0"/>
           </a:p>
@@ -5166,8 +5324,8 @@
         </p:nvSpPr>
         <p:spPr>
           <a:xfrm>
-            <a:off x="457200" y="1600200"/>
-            <a:ext cx="5760720" cy="3200400"/>
+            <a:off x="457200" y="1463040"/>
+            <a:ext cx="11247120" cy="1508760"/>
           </a:xfrm>
           <a:prstGeom prst="rect">
             <a:avLst/>
@@ -5195,7 +5353,7 @@
                 <a:ea typeface="Calibri" pitchFamily="34" charset="-122"/>
                 <a:cs typeface="Calibri" pitchFamily="34" charset="-120"/>
               </a:rPr>
-              <a:t>Ranking (reach × driver): Budgeting → Alerts → Reminders → Products → Nudges → Education.</a:t>
+              <a:t>Financially Healthy &amp; Highly Engaged — 351 (35%): FHS 70.5, lowest util 0.148 → retain &amp; grow value.</a:t>
             </a:r>
             <a:endParaRPr lang="en-US" sz="1400" dirty="0"/>
           </a:p>
@@ -5216,7 +5374,7 @@
                 <a:ea typeface="Calibri" pitchFamily="34" charset="-122"/>
                 <a:cs typeface="Calibri" pitchFamily="34" charset="-120"/>
               </a:rPr>
-              <a:t>Lead with Budgeting + Alerts (the wellbeing mission); layer growth on top.</a:t>
+              <a:t>Financially Stretched but Highly Engaged — 302 (30%): highest spend/income 0.835, still engaged → the wellbeing priority.</a:t>
             </a:r>
             <a:endParaRPr lang="en-US" sz="1400" dirty="0"/>
           </a:p>
@@ -5237,28 +5395,7 @@
                 <a:ea typeface="Calibri" pitchFamily="34" charset="-122"/>
                 <a:cs typeface="Calibri" pitchFamily="34" charset="-120"/>
               </a:rPr>
-              <a:t>No double-counting: the 4 segments partition 999; crossover (43) &amp; distress (67) are overlays inside Segment 2.</a:t>
-            </a:r>
-            <a:endParaRPr lang="en-US" sz="1400" dirty="0"/>
-          </a:p>
-          <a:p>
-            <a:pPr marL="177800" indent="-177800">
-              <a:spcAft>
-                <a:spcPts val="800"/>
-              </a:spcAft>
-              <a:buSzPct val="100000"/>
-              <a:buChar char="•"/>
-            </a:pPr>
-            <a:r>
-              <a:rPr lang="en-US" sz="1400" dirty="0">
-                <a:solidFill>
-                  <a:srgbClr val="1B2A36"/>
-                </a:solidFill>
-                <a:latin typeface="Calibri" pitchFamily="34" charset="0"/>
-                <a:ea typeface="Calibri" pitchFamily="34" charset="-122"/>
-                <a:cs typeface="Calibri" pitchFamily="34" charset="-120"/>
-              </a:rPr>
-              <a:t>Fair by design: targeting on ratios, not demographics; monitor (don't use) a mild male skew.</a:t>
+              <a:t>High-Activity Digital Power Users — 258 (26%): most active &amp; volatile → monetise &amp; monitor drift.  ·  Low Engagement &amp; Emerging Digital — 88 (9%): near-dormant, 60% of spend via E-com/Mobile → activate.</a:t>
             </a:r>
             <a:endParaRPr lang="en-US" sz="1400" dirty="0"/>
           </a:p>
@@ -5266,7 +5403,7 @@
       </p:sp>
       <p:pic>
         <p:nvPicPr>
-          <p:cNvPr id="5" name="Image 0" descr="D:\BI10GroupYAPPERS\outputs\figures\t5_priority_ranking.png">    </p:cNvPr>
+          <p:cNvPr id="5" name="Image 0" descr="D:\BI10GroupYAPPERS\outputs\figures\t4_segment_sizes.png">    </p:cNvPr>
           <p:cNvPicPr>
             <a:picLocks noChangeAspect="1"/>
           </p:cNvPicPr>
@@ -5279,117 +5416,40 @@
         </p:blipFill>
         <p:spPr>
           <a:xfrm>
-            <a:off x="6446520" y="1554480"/>
-            <a:ext cx="5303520" cy="4206240"/>
+            <a:off x="502920" y="3063240"/>
+            <a:ext cx="5440680" cy="3200400"/>
           </a:xfrm>
           <a:prstGeom prst="rect">
             <a:avLst/>
           </a:prstGeom>
         </p:spPr>
       </p:pic>
-      <p:sp>
-        <p:nvSpPr>
-          <p:cNvPr id="6" name="Shape 3"/>
-          <p:cNvSpPr/>
-          <p:nvPr/>
-        </p:nvSpPr>
-        <p:spPr>
-          <a:xfrm>
-            <a:off x="457200" y="5029200"/>
-            <a:ext cx="3383280" cy="1097280"/>
-          </a:xfrm>
-          <a:prstGeom prst="roundRect">
-            <a:avLst>
-              <a:gd name="adj" fmla="val 6667"/>
-            </a:avLst>
-          </a:prstGeom>
-          <a:solidFill>
-            <a:srgbClr val="12435E"/>
-          </a:solidFill>
-          <a:ln/>
-        </p:spPr>
-      </p:sp>
-      <p:sp>
-        <p:nvSpPr>
-          <p:cNvPr id="7" name="Text 4"/>
-          <p:cNvSpPr txBox="1"/>
-          <p:nvPr/>
-        </p:nvSpPr>
-        <p:spPr>
-          <a:xfrm>
-            <a:off x="457200" y="5138928"/>
-            <a:ext cx="3383280" cy="658368"/>
-          </a:xfrm>
-          <a:prstGeom prst="rect">
-            <a:avLst/>
-          </a:prstGeom>
-          <a:noFill/>
-          <a:ln/>
-        </p:spPr>
-        <p:txBody>
-          <a:bodyPr wrap="square" lIns="0" tIns="0" rIns="0" bIns="0" rtlCol="0" anchor="ctr"/>
-          <a:lstStyle/>
-          <a:p>
-            <a:pPr algn="ctr" indent="0" marL="0">
-              <a:buNone/>
-            </a:pPr>
-            <a:r>
-              <a:rPr lang="en-US" sz="2800" b="1" dirty="0">
-                <a:solidFill>
-                  <a:srgbClr val="1FC3A6"/>
-                </a:solidFill>
-                <a:latin typeface="Cambria" pitchFamily="34" charset="0"/>
-                <a:ea typeface="Cambria" pitchFamily="34" charset="-122"/>
-                <a:cs typeface="Cambria" pitchFamily="34" charset="-120"/>
-              </a:rPr>
-              <a:t>NEVER</a:t>
-            </a:r>
-            <a:endParaRPr lang="en-US" sz="2800" dirty="0"/>
-          </a:p>
-        </p:txBody>
-      </p:sp>
-      <p:sp>
-        <p:nvSpPr>
-          <p:cNvPr id="8" name="Text 5"/>
-          <p:cNvSpPr txBox="1"/>
-          <p:nvPr/>
-        </p:nvSpPr>
-        <p:spPr>
-          <a:xfrm>
-            <a:off x="457200" y="5779008"/>
-            <a:ext cx="3383280" cy="320040"/>
-          </a:xfrm>
-          <a:prstGeom prst="rect">
-            <a:avLst/>
-          </a:prstGeom>
-          <a:noFill/>
-          <a:ln/>
-        </p:spPr>
-        <p:txBody>
-          <a:bodyPr wrap="square" lIns="0" tIns="0" rIns="0" bIns="0" rtlCol="0" anchor="ctr"/>
-          <a:lstStyle/>
-          <a:p>
-            <a:pPr algn="ctr" indent="0" marL="0">
-              <a:buNone/>
-            </a:pPr>
-            <a:r>
-              <a:rPr lang="en-US" sz="1100" dirty="0">
-                <a:solidFill>
-                  <a:srgbClr val="FFFFFF"/>
-                </a:solidFill>
-                <a:latin typeface="Calibri" pitchFamily="34" charset="0"/>
-                <a:ea typeface="Calibri" pitchFamily="34" charset="-122"/>
-                <a:cs typeface="Calibri" pitchFamily="34" charset="-120"/>
-              </a:rPr>
-              <a:t>FHS → credit decision</a:t>
-            </a:r>
-            <a:endParaRPr lang="en-US" sz="1100" dirty="0"/>
-          </a:p>
-        </p:txBody>
-      </p:sp>
-      <p:sp>
-        <p:nvSpPr>
-          <p:cNvPr id="9" name="Text 6"/>
+      <p:pic>
+        <p:nvPicPr>
+          <p:cNvPr id="6" name="Image 1" descr="D:\BI10GroupYAPPERS\outputs\figures\t4_segment_profiles.png">    </p:cNvPr>
+          <p:cNvPicPr>
+            <a:picLocks noChangeAspect="1"/>
+          </p:cNvPicPr>
+          <p:nvPr/>
+        </p:nvPicPr>
+        <p:blipFill>
+          <a:blip r:embed="rId2"/>
+          <a:srcRect l="0" r="0" t="0" b="0"/>
+          <a:stretch/>
+        </p:blipFill>
+        <p:spPr>
+          <a:xfrm>
+            <a:off x="6263640" y="3063240"/>
+            <a:ext cx="5440680" cy="3200400"/>
+          </a:xfrm>
+          <a:prstGeom prst="rect">
+            <a:avLst/>
+          </a:prstGeom>
+        </p:spPr>
+      </p:pic>
+      <p:sp>
+        <p:nvSpPr>
+          <p:cNvPr id="7" name="Text 3"/>
           <p:cNvSpPr txBox="1"/>
           <p:nvPr/>
         </p:nvSpPr>
@@ -5428,7 +5488,7 @@
       </p:sp>
       <p:sp>
         <p:nvSpPr>
-          <p:cNvPr id="10" name="Text 7"/>
+          <p:cNvPr id="8" name="Text 4"/>
           <p:cNvSpPr txBox="1"/>
           <p:nvPr/>
         </p:nvSpPr>
@@ -5479,7 +5539,7 @@
     <p:bg>
       <p:bgPr>
         <a:solidFill>
-          <a:srgbClr val="0F2A43"/>
+          <a:srgbClr val="FFFFFF"/>
         </a:solidFill>
       </p:bgPr>
     </p:bg>
@@ -5499,23 +5559,42 @@
       </p:grpSpPr>
       <p:sp>
         <p:nvSpPr>
-          <p:cNvPr id="2" name="Shape 0"/>
-          <p:cNvSpPr/>
-          <p:nvPr/>
-        </p:nvSpPr>
-        <p:spPr>
-          <a:xfrm>
-            <a:off x="0" y="0"/>
-            <a:ext cx="201168" cy="6858000"/>
-          </a:xfrm>
-          <a:prstGeom prst="rect">
-            <a:avLst/>
-          </a:prstGeom>
-          <a:solidFill>
-            <a:srgbClr val="1FC3A6"/>
-          </a:solidFill>
-          <a:ln/>
-        </p:spPr>
+          <p:cNvPr id="2" name="Text 0"/>
+          <p:cNvSpPr txBox="1"/>
+          <p:nvPr/>
+        </p:nvSpPr>
+        <p:spPr>
+          <a:xfrm>
+            <a:off x="457200" y="384048"/>
+            <a:ext cx="4114800" cy="292608"/>
+          </a:xfrm>
+          <a:prstGeom prst="rect">
+            <a:avLst/>
+          </a:prstGeom>
+          <a:noFill/>
+          <a:ln/>
+        </p:spPr>
+        <p:txBody>
+          <a:bodyPr wrap="square" lIns="0" tIns="0" rIns="0" bIns="0" rtlCol="0" anchor="ctr"/>
+          <a:lstStyle/>
+          <a:p>
+            <a:pPr indent="0" marL="0">
+              <a:buNone/>
+            </a:pPr>
+            <a:r>
+              <a:rPr lang="en-US" sz="1100" b="1" spc="200" kern="0" dirty="0">
+                <a:solidFill>
+                  <a:srgbClr val="058B8C"/>
+                </a:solidFill>
+                <a:latin typeface="Calibri" pitchFamily="34" charset="0"/>
+                <a:ea typeface="Calibri" pitchFamily="34" charset="-122"/>
+                <a:cs typeface="Calibri" pitchFamily="34" charset="-120"/>
+              </a:rPr>
+              <a:t>TASK 4 · SEGMENTATION</a:t>
+            </a:r>
+            <a:endParaRPr lang="en-US" sz="1100" dirty="0"/>
+          </a:p>
+        </p:txBody>
       </p:sp>
       <p:sp>
         <p:nvSpPr>
@@ -5525,94 +5604,225 @@
         </p:nvSpPr>
         <p:spPr>
           <a:xfrm>
-            <a:off x="822960" y="822960"/>
-            <a:ext cx="7315200" cy="365760"/>
-          </a:xfrm>
-          <a:prstGeom prst="rect">
-            <a:avLst/>
-          </a:prstGeom>
-          <a:noFill/>
-          <a:ln/>
-        </p:spPr>
-        <p:txBody>
-          <a:bodyPr wrap="square" lIns="0" tIns="0" rIns="0" bIns="0" rtlCol="0" anchor="ctr"/>
-          <a:lstStyle/>
-          <a:p>
-            <a:pPr indent="0" marL="0">
-              <a:buNone/>
-            </a:pPr>
-            <a:r>
-              <a:rPr lang="en-US" sz="1200" b="1" spc="300" kern="0" dirty="0">
-                <a:solidFill>
-                  <a:srgbClr val="1FC3A6"/>
-                </a:solidFill>
-                <a:latin typeface="Calibri" pitchFamily="34" charset="0"/>
-                <a:ea typeface="Calibri" pitchFamily="34" charset="-122"/>
-                <a:cs typeface="Calibri" pitchFamily="34" charset="-120"/>
-              </a:rPr>
-              <a:t>The contract</a:t>
-            </a:r>
-            <a:endParaRPr lang="en-US" sz="1200" dirty="0"/>
-          </a:p>
-        </p:txBody>
-      </p:sp>
-      <p:sp>
-        <p:nvSpPr>
-          <p:cNvPr id="4" name="Text 2"/>
-          <p:cNvSpPr txBox="1"/>
-          <p:nvPr/>
-        </p:nvSpPr>
-        <p:spPr>
-          <a:xfrm>
-            <a:off x="822960" y="1234440"/>
-            <a:ext cx="10607040" cy="1554480"/>
-          </a:xfrm>
-          <a:prstGeom prst="rect">
-            <a:avLst/>
-          </a:prstGeom>
-          <a:noFill/>
-          <a:ln/>
-        </p:spPr>
-        <p:txBody>
-          <a:bodyPr wrap="square" lIns="0" tIns="0" rIns="0" bIns="0" rtlCol="0" anchor="ctr"/>
+            <a:off x="457200" y="658368"/>
+            <a:ext cx="11247120" cy="868680"/>
+          </a:xfrm>
+          <a:prstGeom prst="rect">
+            <a:avLst/>
+          </a:prstGeom>
+          <a:noFill/>
+          <a:ln/>
+        </p:spPr>
+        <p:txBody>
+          <a:bodyPr wrap="square" lIns="0" tIns="0" rIns="0" bIns="0" rtlCol="0" anchor="t"/>
           <a:lstStyle/>
           <a:p>
             <a:pPr indent="0" marL="0">
               <a:lnSpc>
-                <a:spcPct val="105000"/>
+                <a:spcPct val="95000"/>
               </a:lnSpc>
               <a:buNone/>
             </a:pPr>
             <a:r>
-              <a:rPr lang="en-US" sz="2800" b="1" dirty="0">
-                <a:solidFill>
-                  <a:srgbClr val="FFFFFF"/>
+              <a:rPr lang="en-US" sz="2700" b="1" dirty="0">
+                <a:solidFill>
+                  <a:srgbClr val="12435E"/>
                 </a:solidFill>
                 <a:latin typeface="Cambria" pitchFamily="34" charset="0"/>
                 <a:ea typeface="Cambria" pitchFamily="34" charset="-122"/>
                 <a:cs typeface="Cambria" pitchFamily="34" charset="-120"/>
               </a:rPr>
-              <a:t>Grow the healthy, activate the dormant, protect the stretched —</a:t>
-            </a:r>
-            <a:endParaRPr lang="en-US" sz="2800" dirty="0"/>
-          </a:p>
-          <a:p>
-            <a:pPr indent="0" marL="0">
-              <a:lnSpc>
-                <a:spcPct val="105000"/>
-              </a:lnSpc>
+              <a:t>Validation: stable segments, and a December slide</a:t>
+            </a:r>
+            <a:endParaRPr lang="en-US" sz="2700" dirty="0"/>
+          </a:p>
+        </p:txBody>
+      </p:sp>
+      <p:sp>
+        <p:nvSpPr>
+          <p:cNvPr id="4" name="Text 2"/>
+          <p:cNvSpPr txBox="1"/>
+          <p:nvPr/>
+        </p:nvSpPr>
+        <p:spPr>
+          <a:xfrm>
+            <a:off x="457200" y="1600200"/>
+            <a:ext cx="5760720" cy="3200400"/>
+          </a:xfrm>
+          <a:prstGeom prst="rect">
+            <a:avLst/>
+          </a:prstGeom>
+          <a:noFill/>
+          <a:ln/>
+        </p:spPr>
+        <p:txBody>
+          <a:bodyPr wrap="square" rtlCol="0" anchor="t"/>
+          <a:lstStyle/>
+          <a:p>
+            <a:pPr marL="177800" indent="-177800">
+              <a:spcAft>
+                <a:spcPts val="800"/>
+              </a:spcAft>
+              <a:buSzPct val="100000"/>
+              <a:buChar char="•"/>
+            </a:pPr>
+            <a:r>
+              <a:rPr lang="en-US" sz="1400" dirty="0">
+                <a:solidFill>
+                  <a:srgbClr val="1B2A36"/>
+                </a:solidFill>
+                <a:latin typeface="Calibri" pitchFamily="34" charset="0"/>
+                <a:ea typeface="Calibri" pitchFamily="34" charset="-122"/>
+                <a:cs typeface="Calibri" pitchFamily="34" charset="-120"/>
+              </a:rPr>
+              <a:t>Stable: 20 random seeds → ARI 0.988; 80% bootstrap × 50 → ARI 0.911.</a:t>
+            </a:r>
+            <a:endParaRPr lang="en-US" sz="1400" dirty="0"/>
+          </a:p>
+          <a:p>
+            <a:pPr marL="177800" indent="-177800">
+              <a:spcAft>
+                <a:spcPts val="800"/>
+              </a:spcAft>
+              <a:buSzPct val="100000"/>
+              <a:buChar char="•"/>
+            </a:pPr>
+            <a:r>
+              <a:rPr lang="en-US" sz="1400" dirty="0">
+                <a:solidFill>
+                  <a:srgbClr val="1B2A36"/>
+                </a:solidFill>
+                <a:latin typeface="Calibri" pitchFamily="34" charset="0"/>
+                <a:ea typeface="Calibri" pitchFamily="34" charset="-122"/>
+                <a:cs typeface="Calibri" pitchFamily="34" charset="-120"/>
+              </a:rPr>
+              <a:t>GMM agrees only partly (ARI 0.26): Emerging Digital is identical, the three large segments form one continuum — hence silhouette 0.251.</a:t>
+            </a:r>
+            <a:endParaRPr lang="en-US" sz="1400" dirty="0"/>
+          </a:p>
+          <a:p>
+            <a:pPr marL="177800" indent="-177800">
+              <a:spcAft>
+                <a:spcPts val="800"/>
+              </a:spcAft>
+              <a:buSzPct val="100000"/>
+              <a:buChar char="•"/>
+            </a:pPr>
+            <a:r>
+              <a:rPr lang="en-US" sz="1400" dirty="0">
+                <a:solidFill>
+                  <a:srgbClr val="1B2A36"/>
+                </a:solidFill>
+                <a:latin typeface="Calibri" pitchFamily="34" charset="0"/>
+                <a:ea typeface="Calibri" pitchFamily="34" charset="-122"/>
+                <a:cs typeface="Calibri" pitchFamily="34" charset="-120"/>
+              </a:rPr>
+              <a:t>Monthly migration: a Healthy month slides to Stretched 23% of the time — but 72% from November to December.</a:t>
+            </a:r>
+            <a:endParaRPr lang="en-US" sz="1400" dirty="0"/>
+          </a:p>
+          <a:p>
+            <a:pPr marL="177800" indent="-177800">
+              <a:spcAft>
+                <a:spcPts val="800"/>
+              </a:spcAft>
+              <a:buSzPct val="100000"/>
+              <a:buChar char="•"/>
+            </a:pPr>
+            <a:r>
+              <a:rPr lang="en-US" sz="1400" dirty="0">
+                <a:solidFill>
+                  <a:srgbClr val="1B2A36"/>
+                </a:solidFill>
+                <a:latin typeface="Calibri" pitchFamily="34" charset="0"/>
+                <a:ea typeface="Calibri" pitchFamily="34" charset="-122"/>
+                <a:cs typeface="Calibri" pitchFamily="34" charset="-120"/>
+              </a:rPr>
+              <a:t>Segments correlate with age &amp; gender (p &lt; 0.01) though not used as inputs → trigger tools on behaviour only.</a:t>
+            </a:r>
+            <a:endParaRPr lang="en-US" sz="1400" dirty="0"/>
+          </a:p>
+        </p:txBody>
+      </p:sp>
+      <p:pic>
+        <p:nvPicPr>
+          <p:cNvPr id="5" name="Image 0" descr="D:\BI10GroupYAPPERS\outputs\figures\t4_pca.png">    </p:cNvPr>
+          <p:cNvPicPr>
+            <a:picLocks noChangeAspect="1"/>
+          </p:cNvPicPr>
+          <p:nvPr/>
+        </p:nvPicPr>
+        <p:blipFill>
+          <a:blip r:embed="rId1"/>
+          <a:srcRect l="0" r="0" t="0" b="0"/>
+          <a:stretch/>
+        </p:blipFill>
+        <p:spPr>
+          <a:xfrm>
+            <a:off x="6446520" y="1554480"/>
+            <a:ext cx="5303520" cy="4206240"/>
+          </a:xfrm>
+          <a:prstGeom prst="rect">
+            <a:avLst/>
+          </a:prstGeom>
+        </p:spPr>
+      </p:pic>
+      <p:sp>
+        <p:nvSpPr>
+          <p:cNvPr id="6" name="Shape 3"/>
+          <p:cNvSpPr/>
+          <p:nvPr/>
+        </p:nvSpPr>
+        <p:spPr>
+          <a:xfrm>
+            <a:off x="457200" y="5029200"/>
+            <a:ext cx="3383280" cy="1097280"/>
+          </a:xfrm>
+          <a:prstGeom prst="roundRect">
+            <a:avLst>
+              <a:gd name="adj" fmla="val 6667"/>
+            </a:avLst>
+          </a:prstGeom>
+          <a:solidFill>
+            <a:srgbClr val="12435E"/>
+          </a:solidFill>
+          <a:ln/>
+        </p:spPr>
+      </p:sp>
+      <p:sp>
+        <p:nvSpPr>
+          <p:cNvPr id="7" name="Text 4"/>
+          <p:cNvSpPr txBox="1"/>
+          <p:nvPr/>
+        </p:nvSpPr>
+        <p:spPr>
+          <a:xfrm>
+            <a:off x="457200" y="5138928"/>
+            <a:ext cx="3383280" cy="658368"/>
+          </a:xfrm>
+          <a:prstGeom prst="rect">
+            <a:avLst/>
+          </a:prstGeom>
+          <a:noFill/>
+          <a:ln/>
+        </p:spPr>
+        <p:txBody>
+          <a:bodyPr wrap="square" lIns="0" tIns="0" rIns="0" bIns="0" rtlCol="0" anchor="ctr"/>
+          <a:lstStyle/>
+          <a:p>
+            <a:pPr algn="ctr" indent="0" marL="0">
               <a:buNone/>
             </a:pPr>
             <a:r>
               <a:rPr lang="en-US" sz="2800" b="1" dirty="0">
                 <a:solidFill>
-                  <a:srgbClr val="FFFFFF"/>
+                  <a:srgbClr val="1FC3A6"/>
                 </a:solidFill>
                 <a:latin typeface="Cambria" pitchFamily="34" charset="0"/>
                 <a:ea typeface="Cambria" pitchFamily="34" charset="-122"/>
                 <a:cs typeface="Cambria" pitchFamily="34" charset="-120"/>
               </a:rPr>
-              <a:t>without ever touching their credit.</a:t>
+              <a:t>72%</a:t>
             </a:r>
             <a:endParaRPr lang="en-US" sz="2800" dirty="0"/>
           </a:p>
@@ -5620,14 +5830,202 @@
       </p:sp>
       <p:sp>
         <p:nvSpPr>
-          <p:cNvPr id="5" name="Text 3"/>
-          <p:cNvSpPr txBox="1"/>
-          <p:nvPr/>
-        </p:nvSpPr>
-        <p:spPr>
-          <a:xfrm>
-            <a:off x="822960" y="3063240"/>
-            <a:ext cx="2468880" cy="731520"/>
+          <p:cNvPr id="8" name="Text 5"/>
+          <p:cNvSpPr txBox="1"/>
+          <p:nvPr/>
+        </p:nvSpPr>
+        <p:spPr>
+          <a:xfrm>
+            <a:off x="457200" y="5779008"/>
+            <a:ext cx="3383280" cy="320040"/>
+          </a:xfrm>
+          <a:prstGeom prst="rect">
+            <a:avLst/>
+          </a:prstGeom>
+          <a:noFill/>
+          <a:ln/>
+        </p:spPr>
+        <p:txBody>
+          <a:bodyPr wrap="square" lIns="0" tIns="0" rIns="0" bIns="0" rtlCol="0" anchor="ctr"/>
+          <a:lstStyle/>
+          <a:p>
+            <a:pPr algn="ctr" indent="0" marL="0">
+              <a:buNone/>
+            </a:pPr>
+            <a:r>
+              <a:rPr lang="en-US" sz="1100" dirty="0">
+                <a:solidFill>
+                  <a:srgbClr val="FFFFFF"/>
+                </a:solidFill>
+                <a:latin typeface="Calibri" pitchFamily="34" charset="0"/>
+                <a:ea typeface="Calibri" pitchFamily="34" charset="-122"/>
+                <a:cs typeface="Calibri" pitchFamily="34" charset="-120"/>
+              </a:rPr>
+              <a:t>Healthy → Stretched, Nov → Dec</a:t>
+            </a:r>
+            <a:endParaRPr lang="en-US" sz="1100" dirty="0"/>
+          </a:p>
+        </p:txBody>
+      </p:sp>
+      <p:sp>
+        <p:nvSpPr>
+          <p:cNvPr id="9" name="Text 6"/>
+          <p:cNvSpPr txBox="1"/>
+          <p:nvPr/>
+        </p:nvSpPr>
+        <p:spPr>
+          <a:xfrm>
+            <a:off x="457200" y="6473952"/>
+            <a:ext cx="5486400" cy="274320"/>
+          </a:xfrm>
+          <a:prstGeom prst="rect">
+            <a:avLst/>
+          </a:prstGeom>
+          <a:noFill/>
+          <a:ln/>
+        </p:spPr>
+        <p:txBody>
+          <a:bodyPr wrap="square" lIns="0" tIns="0" rIns="0" bIns="0" rtlCol="0" anchor="ctr"/>
+          <a:lstStyle/>
+          <a:p>
+            <a:pPr indent="0" marL="0">
+              <a:buNone/>
+            </a:pPr>
+            <a:r>
+              <a:rPr lang="en-US" sz="900" dirty="0">
+                <a:solidFill>
+                  <a:srgbClr val="5F7180"/>
+                </a:solidFill>
+                <a:latin typeface="Calibri" pitchFamily="34" charset="0"/>
+                <a:ea typeface="Calibri" pitchFamily="34" charset="-122"/>
+                <a:cs typeface="Calibri" pitchFamily="34" charset="-120"/>
+              </a:rPr>
+              <a:t>Group YAPPERS · BI10 Round 01</a:t>
+            </a:r>
+            <a:endParaRPr lang="en-US" sz="900" dirty="0"/>
+          </a:p>
+        </p:txBody>
+      </p:sp>
+      <p:sp>
+        <p:nvSpPr>
+          <p:cNvPr id="10" name="Text 7"/>
+          <p:cNvSpPr txBox="1"/>
+          <p:nvPr/>
+        </p:nvSpPr>
+        <p:spPr>
+          <a:xfrm>
+            <a:off x="11430000" y="6473952"/>
+            <a:ext cx="457200" cy="274320"/>
+          </a:xfrm>
+          <a:prstGeom prst="rect">
+            <a:avLst/>
+          </a:prstGeom>
+          <a:noFill/>
+          <a:ln/>
+        </p:spPr>
+        <p:txBody>
+          <a:bodyPr wrap="square" lIns="0" tIns="0" rIns="0" bIns="0" rtlCol="0" anchor="ctr"/>
+          <a:lstStyle/>
+          <a:p>
+            <a:pPr algn="r" indent="0" marL="0">
+              <a:buNone/>
+            </a:pPr>
+            <a:r>
+              <a:rPr lang="en-US" sz="900" dirty="0">
+                <a:solidFill>
+                  <a:srgbClr val="5F7180"/>
+                </a:solidFill>
+                <a:latin typeface="Calibri" pitchFamily="34" charset="0"/>
+                <a:ea typeface="Calibri" pitchFamily="34" charset="-122"/>
+                <a:cs typeface="Calibri" pitchFamily="34" charset="-120"/>
+              </a:rPr>
+              <a:t>18</a:t>
+            </a:r>
+            <a:endParaRPr lang="en-US" sz="900" dirty="0"/>
+          </a:p>
+        </p:txBody>
+      </p:sp>
+    </p:spTree>
+  </p:cSld>
+  <p:clrMapOvr>
+    <a:masterClrMapping/>
+  </p:clrMapOvr>
+</p:sld>
+</file>
+
+<file path=ppt/slides/slide19.xml><?xml version="1.0" encoding="utf-8"?>
+<p:sld xmlns:a="http://schemas.openxmlformats.org/drawingml/2006/main" xmlns:r="http://schemas.openxmlformats.org/officeDocument/2006/relationships" xmlns:p="http://schemas.openxmlformats.org/presentationml/2006/main">
+  <p:cSld name="Slide 19">
+    <p:bg>
+      <p:bgPr>
+        <a:solidFill>
+          <a:srgbClr val="FFFFFF"/>
+        </a:solidFill>
+      </p:bgPr>
+    </p:bg>
+    <p:spTree>
+      <p:nvGrpSpPr>
+        <p:cNvPr id="1" name=""/>
+        <p:cNvGrpSpPr/>
+        <p:nvPr/>
+      </p:nvGrpSpPr>
+      <p:grpSpPr>
+        <a:xfrm>
+          <a:off x="0" y="0"/>
+          <a:ext cx="0" cy="0"/>
+          <a:chOff x="0" y="0"/>
+          <a:chExt cx="0" cy="0"/>
+        </a:xfrm>
+      </p:grpSpPr>
+      <p:sp>
+        <p:nvSpPr>
+          <p:cNvPr id="2" name="Text 0"/>
+          <p:cNvSpPr txBox="1"/>
+          <p:nvPr/>
+        </p:nvSpPr>
+        <p:spPr>
+          <a:xfrm>
+            <a:off x="457200" y="384048"/>
+            <a:ext cx="4114800" cy="292608"/>
+          </a:xfrm>
+          <a:prstGeom prst="rect">
+            <a:avLst/>
+          </a:prstGeom>
+          <a:noFill/>
+          <a:ln/>
+        </p:spPr>
+        <p:txBody>
+          <a:bodyPr wrap="square" lIns="0" tIns="0" rIns="0" bIns="0" rtlCol="0" anchor="ctr"/>
+          <a:lstStyle/>
+          <a:p>
+            <a:pPr indent="0" marL="0">
+              <a:buNone/>
+            </a:pPr>
+            <a:r>
+              <a:rPr lang="en-US" sz="1100" b="1" spc="200" kern="0" dirty="0">
+                <a:solidFill>
+                  <a:srgbClr val="058B8C"/>
+                </a:solidFill>
+                <a:latin typeface="Calibri" pitchFamily="34" charset="0"/>
+                <a:ea typeface="Calibri" pitchFamily="34" charset="-122"/>
+                <a:cs typeface="Calibri" pitchFamily="34" charset="-120"/>
+              </a:rPr>
+              <a:t>TASK 5 · RECOMMENDATIONS</a:t>
+            </a:r>
+            <a:endParaRPr lang="en-US" sz="1100" dirty="0"/>
+          </a:p>
+        </p:txBody>
+      </p:sp>
+      <p:sp>
+        <p:nvSpPr>
+          <p:cNvPr id="3" name="Text 1"/>
+          <p:cNvSpPr txBox="1"/>
+          <p:nvPr/>
+        </p:nvSpPr>
+        <p:spPr>
+          <a:xfrm>
+            <a:off x="457200" y="658368"/>
+            <a:ext cx="11247120" cy="868680"/>
           </a:xfrm>
           <a:prstGeom prst="rect">
             <a:avLst/>
@@ -5640,306 +6038,246 @@
           <a:lstStyle/>
           <a:p>
             <a:pPr indent="0" marL="0">
-              <a:buNone/>
-            </a:pPr>
-            <a:r>
-              <a:rPr lang="en-US" sz="1400" b="1" dirty="0">
-                <a:solidFill>
-                  <a:srgbClr val="1FC3A6"/>
-                </a:solidFill>
-                <a:latin typeface="Calibri" pitchFamily="34" charset="0"/>
-                <a:ea typeface="Calibri" pitchFamily="34" charset="-122"/>
-                <a:cs typeface="Calibri" pitchFamily="34" charset="-120"/>
-              </a:rPr>
-              <a:t>The spine</a:t>
+              <a:lnSpc>
+                <a:spcPct val="95000"/>
+              </a:lnSpc>
+              <a:buNone/>
+            </a:pPr>
+            <a:r>
+              <a:rPr lang="en-US" sz="2700" b="1" dirty="0">
+                <a:solidFill>
+                  <a:srgbClr val="12435E"/>
+                </a:solidFill>
+                <a:latin typeface="Cambria" pitchFamily="34" charset="0"/>
+                <a:ea typeface="Cambria" pitchFamily="34" charset="-122"/>
+                <a:cs typeface="Cambria" pitchFamily="34" charset="-120"/>
+              </a:rPr>
+              <a:t>A six-tool, non-punitive action plan</a:t>
+            </a:r>
+            <a:endParaRPr lang="en-US" sz="2700" dirty="0"/>
+          </a:p>
+        </p:txBody>
+      </p:sp>
+      <p:sp>
+        <p:nvSpPr>
+          <p:cNvPr id="4" name="Text 2"/>
+          <p:cNvSpPr txBox="1"/>
+          <p:nvPr/>
+        </p:nvSpPr>
+        <p:spPr>
+          <a:xfrm>
+            <a:off x="457200" y="1600200"/>
+            <a:ext cx="5760720" cy="3200400"/>
+          </a:xfrm>
+          <a:prstGeom prst="rect">
+            <a:avLst/>
+          </a:prstGeom>
+          <a:noFill/>
+          <a:ln/>
+        </p:spPr>
+        <p:txBody>
+          <a:bodyPr wrap="square" rtlCol="0" anchor="t"/>
+          <a:lstStyle/>
+          <a:p>
+            <a:pPr marL="177800" indent="-177800">
+              <a:spcAft>
+                <a:spcPts val="800"/>
+              </a:spcAft>
+              <a:buSzPct val="100000"/>
+              <a:buChar char="•"/>
+            </a:pPr>
+            <a:r>
+              <a:rPr lang="en-US" sz="1400" dirty="0">
+                <a:solidFill>
+                  <a:srgbClr val="1B2A36"/>
+                </a:solidFill>
+                <a:latin typeface="Calibri" pitchFamily="34" charset="0"/>
+                <a:ea typeface="Calibri" pitchFamily="34" charset="-122"/>
+                <a:cs typeface="Calibri" pitchFamily="34" charset="-120"/>
+              </a:rPr>
+              <a:t>① Budgeting → Stretched-Engaged (302): spend-vs-income dashboard (driver −0.90).</a:t>
             </a:r>
             <a:endParaRPr lang="en-US" sz="1400" dirty="0"/>
           </a:p>
-        </p:txBody>
-      </p:sp>
-      <p:sp>
-        <p:nvSpPr>
-          <p:cNvPr id="6" name="Text 4"/>
-          <p:cNvSpPr txBox="1"/>
-          <p:nvPr/>
-        </p:nvSpPr>
-        <p:spPr>
-          <a:xfrm>
-            <a:off x="3383280" y="3063240"/>
-            <a:ext cx="8046720" cy="731520"/>
-          </a:xfrm>
-          <a:prstGeom prst="rect">
-            <a:avLst/>
-          </a:prstGeom>
-          <a:noFill/>
-          <a:ln/>
-        </p:spPr>
-        <p:txBody>
-          <a:bodyPr wrap="square" lIns="0" tIns="0" rIns="0" bIns="0" rtlCol="0" anchor="t"/>
+          <a:p>
+            <a:pPr marL="177800" indent="-177800">
+              <a:spcAft>
+                <a:spcPts val="800"/>
+              </a:spcAft>
+              <a:buSzPct val="100000"/>
+              <a:buChar char="•"/>
+            </a:pPr>
+            <a:r>
+              <a:rPr lang="en-US" sz="1400" dirty="0">
+                <a:solidFill>
+                  <a:srgbClr val="1B2A36"/>
+                </a:solidFill>
+                <a:latin typeface="Calibri" pitchFamily="34" charset="0"/>
+                <a:ea typeface="Calibri" pitchFamily="34" charset="-122"/>
+                <a:cs typeface="Calibri" pitchFamily="34" charset="-120"/>
+              </a:rPr>
+              <a:t>② Spend alerts → Crossover (43 = 52% of stress): Sunday–Monday evenings, before 22:00.</a:t>
+            </a:r>
+            <a:endParaRPr lang="en-US" sz="1400" dirty="0"/>
+          </a:p>
+          <a:p>
+            <a:pPr marL="177800" indent="-177800">
+              <a:spcAft>
+                <a:spcPts val="800"/>
+              </a:spcAft>
+              <a:buSzPct val="100000"/>
+              <a:buChar char="•"/>
+            </a:pPr>
+            <a:r>
+              <a:rPr lang="en-US" sz="1400" dirty="0">
+                <a:solidFill>
+                  <a:srgbClr val="1B2A36"/>
+                </a:solidFill>
+                <a:latin typeface="Calibri" pitchFamily="34" charset="0"/>
+                <a:ea typeface="Calibri" pitchFamily="34" charset="-122"/>
+                <a:cs typeface="Calibri" pitchFamily="34" charset="-120"/>
+              </a:rPr>
+              <a:t>③ Planning reminders → Power Users (258) + Healthy (351) in November, before the 72% December slide.</a:t>
+            </a:r>
+            <a:endParaRPr lang="en-US" sz="1400" dirty="0"/>
+          </a:p>
+          <a:p>
+            <a:pPr marL="177800" indent="-177800">
+              <a:spcAft>
+                <a:spcPts val="800"/>
+              </a:spcAft>
+              <a:buSzPct val="100000"/>
+              <a:buChar char="•"/>
+            </a:pPr>
+            <a:r>
+              <a:rPr lang="en-US" sz="1400" dirty="0">
+                <a:solidFill>
+                  <a:srgbClr val="1B2A36"/>
+                </a:solidFill>
+                <a:latin typeface="Calibri" pitchFamily="34" charset="0"/>
+                <a:ea typeface="Calibri" pitchFamily="34" charset="-122"/>
+                <a:cs typeface="Calibri" pitchFamily="34" charset="-120"/>
+              </a:rPr>
+              <a:t>④ Education → Distress tail (67): needs-vs-wants modules (essential ratio +0.48).</a:t>
+            </a:r>
+            <a:endParaRPr lang="en-US" sz="1400" dirty="0"/>
+          </a:p>
+          <a:p>
+            <a:pPr marL="177800" indent="-177800">
+              <a:spcAft>
+                <a:spcPts val="800"/>
+              </a:spcAft>
+              <a:buSzPct val="100000"/>
+              <a:buChar char="•"/>
+            </a:pPr>
+            <a:r>
+              <a:rPr lang="en-US" sz="1400" dirty="0">
+                <a:solidFill>
+                  <a:srgbClr val="1B2A36"/>
+                </a:solidFill>
+                <a:latin typeface="Calibri" pitchFamily="34" charset="0"/>
+                <a:ea typeface="Calibri" pitchFamily="34" charset="-122"/>
+                <a:cs typeface="Calibri" pitchFamily="34" charset="-120"/>
+              </a:rPr>
+              <a:t>⑤ Digital nudges → Emerging Digital (88): in-app habit loops — they already spend 60% via E-com/Mobile.</a:t>
+            </a:r>
+            <a:endParaRPr lang="en-US" sz="1400" dirty="0"/>
+          </a:p>
+          <a:p>
+            <a:pPr marL="177800" indent="-177800">
+              <a:spcAft>
+                <a:spcPts val="800"/>
+              </a:spcAft>
+              <a:buSzPct val="100000"/>
+              <a:buChar char="•"/>
+            </a:pPr>
+            <a:r>
+              <a:rPr lang="en-US" sz="1400" dirty="0">
+                <a:solidFill>
+                  <a:srgbClr val="1B2A36"/>
+                </a:solidFill>
+                <a:latin typeface="Calibri" pitchFamily="34" charset="0"/>
+                <a:ea typeface="Calibri" pitchFamily="34" charset="-122"/>
+                <a:cs typeface="Calibri" pitchFamily="34" charset="-120"/>
+              </a:rPr>
+              <a:t>⑥ Product suggestions → Healthy-Engaged (351): savings/loyalty, opt-in, never auto-extend.</a:t>
+            </a:r>
+            <a:endParaRPr lang="en-US" sz="1400" dirty="0"/>
+          </a:p>
+        </p:txBody>
+      </p:sp>
+      <p:pic>
+        <p:nvPicPr>
+          <p:cNvPr id="5" name="Image 0" descr="D:\BI10GroupYAPPERS\outputs\figures\t5_target_sizes.png">    </p:cNvPr>
+          <p:cNvPicPr>
+            <a:picLocks noChangeAspect="1"/>
+          </p:cNvPicPr>
+          <p:nvPr/>
+        </p:nvPicPr>
+        <p:blipFill>
+          <a:blip r:embed="rId1"/>
+          <a:srcRect l="0" r="0" t="0" b="0"/>
+          <a:stretch/>
+        </p:blipFill>
+        <p:spPr>
+          <a:xfrm>
+            <a:off x="6446520" y="1554480"/>
+            <a:ext cx="5303520" cy="4206240"/>
+          </a:xfrm>
+          <a:prstGeom prst="rect">
+            <a:avLst/>
+          </a:prstGeom>
+        </p:spPr>
+      </p:pic>
+      <p:sp>
+        <p:nvSpPr>
+          <p:cNvPr id="6" name="Text 3"/>
+          <p:cNvSpPr txBox="1"/>
+          <p:nvPr/>
+        </p:nvSpPr>
+        <p:spPr>
+          <a:xfrm>
+            <a:off x="457200" y="6473952"/>
+            <a:ext cx="5486400" cy="274320"/>
+          </a:xfrm>
+          <a:prstGeom prst="rect">
+            <a:avLst/>
+          </a:prstGeom>
+          <a:noFill/>
+          <a:ln/>
+        </p:spPr>
+        <p:txBody>
+          <a:bodyPr wrap="square" lIns="0" tIns="0" rIns="0" bIns="0" rtlCol="0" anchor="ctr"/>
           <a:lstStyle/>
           <a:p>
             <a:pPr indent="0" marL="0">
               <a:buNone/>
             </a:pPr>
             <a:r>
-              <a:rPr lang="en-US" sz="1300" dirty="0">
-                <a:solidFill>
-                  <a:srgbClr val="DCEAEC"/>
-                </a:solidFill>
-                <a:latin typeface="Calibri" pitchFamily="34" charset="0"/>
-                <a:ea typeface="Calibri" pitchFamily="34" charset="-122"/>
-                <a:cs typeface="Calibri" pitchFamily="34" charset="-120"/>
-              </a:rPr>
-              <a:t>Overspend drives poor health; the budget inverts under stress; stress is episodic, striking the most engaged.</a:t>
-            </a:r>
-            <a:endParaRPr lang="en-US" sz="1300" dirty="0"/>
-          </a:p>
-        </p:txBody>
-      </p:sp>
-      <p:sp>
-        <p:nvSpPr>
-          <p:cNvPr id="7" name="Text 5"/>
-          <p:cNvSpPr txBox="1"/>
-          <p:nvPr/>
-        </p:nvSpPr>
-        <p:spPr>
-          <a:xfrm>
-            <a:off x="822960" y="3849624"/>
-            <a:ext cx="2468880" cy="731520"/>
-          </a:xfrm>
-          <a:prstGeom prst="rect">
-            <a:avLst/>
-          </a:prstGeom>
-          <a:noFill/>
-          <a:ln/>
-        </p:spPr>
-        <p:txBody>
-          <a:bodyPr wrap="square" lIns="0" tIns="0" rIns="0" bIns="0" rtlCol="0" anchor="t"/>
-          <a:lstStyle/>
-          <a:p>
-            <a:pPr indent="0" marL="0">
-              <a:buNone/>
-            </a:pPr>
-            <a:r>
-              <a:rPr lang="en-US" sz="1400" b="1" dirty="0">
-                <a:solidFill>
-                  <a:srgbClr val="1FC3A6"/>
-                </a:solidFill>
-                <a:latin typeface="Calibri" pitchFamily="34" charset="0"/>
-                <a:ea typeface="Calibri" pitchFamily="34" charset="-122"/>
-                <a:cs typeface="Calibri" pitchFamily="34" charset="-120"/>
-              </a:rPr>
-              <a:t>The payoff</a:t>
-            </a:r>
-            <a:endParaRPr lang="en-US" sz="1400" dirty="0"/>
-          </a:p>
-        </p:txBody>
-      </p:sp>
-      <p:sp>
-        <p:nvSpPr>
-          <p:cNvPr id="8" name="Text 6"/>
-          <p:cNvSpPr txBox="1"/>
-          <p:nvPr/>
-        </p:nvSpPr>
-        <p:spPr>
-          <a:xfrm>
-            <a:off x="3383280" y="3849624"/>
-            <a:ext cx="8046720" cy="731520"/>
-          </a:xfrm>
-          <a:prstGeom prst="rect">
-            <a:avLst/>
-          </a:prstGeom>
-          <a:noFill/>
-          <a:ln/>
-        </p:spPr>
-        <p:txBody>
-          <a:bodyPr wrap="square" lIns="0" tIns="0" rIns="0" bIns="0" rtlCol="0" anchor="t"/>
-          <a:lstStyle/>
-          <a:p>
-            <a:pPr indent="0" marL="0">
-              <a:buNone/>
-            </a:pPr>
-            <a:r>
-              <a:rPr lang="en-US" sz="1300" dirty="0">
-                <a:solidFill>
-                  <a:srgbClr val="DCEAEC"/>
-                </a:solidFill>
-                <a:latin typeface="Calibri" pitchFamily="34" charset="0"/>
-                <a:ea typeface="Calibri" pitchFamily="34" charset="-122"/>
-                <a:cs typeface="Calibri" pitchFamily="34" charset="-120"/>
-              </a:rPr>
-              <a:t>4 clean segments (351/302/258/88) and a 6-tool plan reaching every customer with the right non-punitive touch.</a:t>
-            </a:r>
-            <a:endParaRPr lang="en-US" sz="1300" dirty="0"/>
-          </a:p>
-        </p:txBody>
-      </p:sp>
-      <p:sp>
-        <p:nvSpPr>
-          <p:cNvPr id="9" name="Text 7"/>
-          <p:cNvSpPr txBox="1"/>
-          <p:nvPr/>
-        </p:nvSpPr>
-        <p:spPr>
-          <a:xfrm>
-            <a:off x="822960" y="4636008"/>
-            <a:ext cx="2468880" cy="731520"/>
-          </a:xfrm>
-          <a:prstGeom prst="rect">
-            <a:avLst/>
-          </a:prstGeom>
-          <a:noFill/>
-          <a:ln/>
-        </p:spPr>
-        <p:txBody>
-          <a:bodyPr wrap="square" lIns="0" tIns="0" rIns="0" bIns="0" rtlCol="0" anchor="t"/>
-          <a:lstStyle/>
-          <a:p>
-            <a:pPr indent="0" marL="0">
-              <a:buNone/>
-            </a:pPr>
-            <a:r>
-              <a:rPr lang="en-US" sz="1400" b="1" dirty="0">
-                <a:solidFill>
-                  <a:srgbClr val="1FC3A6"/>
-                </a:solidFill>
-                <a:latin typeface="Calibri" pitchFamily="34" charset="0"/>
-                <a:ea typeface="Calibri" pitchFamily="34" charset="-122"/>
-                <a:cs typeface="Calibri" pitchFamily="34" charset="-120"/>
-              </a:rPr>
-              <a:t>Lead action</a:t>
-            </a:r>
-            <a:endParaRPr lang="en-US" sz="1400" dirty="0"/>
-          </a:p>
-        </p:txBody>
-      </p:sp>
-      <p:sp>
-        <p:nvSpPr>
-          <p:cNvPr id="10" name="Text 8"/>
-          <p:cNvSpPr txBox="1"/>
-          <p:nvPr/>
-        </p:nvSpPr>
-        <p:spPr>
-          <a:xfrm>
-            <a:off x="3383280" y="4636008"/>
-            <a:ext cx="8046720" cy="731520"/>
-          </a:xfrm>
-          <a:prstGeom prst="rect">
-            <a:avLst/>
-          </a:prstGeom>
-          <a:noFill/>
-          <a:ln/>
-        </p:spPr>
-        <p:txBody>
-          <a:bodyPr wrap="square" lIns="0" tIns="0" rIns="0" bIns="0" rtlCol="0" anchor="t"/>
-          <a:lstStyle/>
-          <a:p>
-            <a:pPr indent="0" marL="0">
-              <a:buNone/>
-            </a:pPr>
-            <a:r>
-              <a:rPr lang="en-US" sz="1300" dirty="0">
-                <a:solidFill>
-                  <a:srgbClr val="DCEAEC"/>
-                </a:solidFill>
-                <a:latin typeface="Calibri" pitchFamily="34" charset="0"/>
-                <a:ea typeface="Calibri" pitchFamily="34" charset="-122"/>
-                <a:cs typeface="Calibri" pitchFamily="34" charset="-120"/>
-              </a:rPr>
-              <a:t>Budgeting for 302 + real-time Alerts catching 52% of all stress — highest reach × strongest driver, near-zero cost.</a:t>
-            </a:r>
-            <a:endParaRPr lang="en-US" sz="1300" dirty="0"/>
-          </a:p>
-        </p:txBody>
-      </p:sp>
-      <p:sp>
-        <p:nvSpPr>
-          <p:cNvPr id="11" name="Text 9"/>
-          <p:cNvSpPr txBox="1"/>
-          <p:nvPr/>
-        </p:nvSpPr>
-        <p:spPr>
-          <a:xfrm>
-            <a:off x="822960" y="5422392"/>
-            <a:ext cx="2468880" cy="731520"/>
-          </a:xfrm>
-          <a:prstGeom prst="rect">
-            <a:avLst/>
-          </a:prstGeom>
-          <a:noFill/>
-          <a:ln/>
-        </p:spPr>
-        <p:txBody>
-          <a:bodyPr wrap="square" lIns="0" tIns="0" rIns="0" bIns="0" rtlCol="0" anchor="t"/>
-          <a:lstStyle/>
-          <a:p>
-            <a:pPr indent="0" marL="0">
-              <a:buNone/>
-            </a:pPr>
-            <a:r>
-              <a:rPr lang="en-US" sz="1400" b="1" dirty="0">
-                <a:solidFill>
-                  <a:srgbClr val="1FC3A6"/>
-                </a:solidFill>
-                <a:latin typeface="Calibri" pitchFamily="34" charset="0"/>
-                <a:ea typeface="Calibri" pitchFamily="34" charset="-122"/>
-                <a:cs typeface="Calibri" pitchFamily="34" charset="-120"/>
-              </a:rPr>
-              <a:t>Honest limits</a:t>
-            </a:r>
-            <a:endParaRPr lang="en-US" sz="1400" dirty="0"/>
-          </a:p>
-        </p:txBody>
-      </p:sp>
-      <p:sp>
-        <p:nvSpPr>
-          <p:cNvPr id="12" name="Text 10"/>
-          <p:cNvSpPr txBox="1"/>
-          <p:nvPr/>
-        </p:nvSpPr>
-        <p:spPr>
-          <a:xfrm>
-            <a:off x="3383280" y="5422392"/>
-            <a:ext cx="8046720" cy="731520"/>
-          </a:xfrm>
-          <a:prstGeom prst="rect">
-            <a:avLst/>
-          </a:prstGeom>
-          <a:noFill/>
-          <a:ln/>
-        </p:spPr>
-        <p:txBody>
-          <a:bodyPr wrap="square" lIns="0" tIns="0" rIns="0" bIns="0" rtlCol="0" anchor="t"/>
-          <a:lstStyle/>
-          <a:p>
-            <a:pPr indent="0" marL="0">
-              <a:buNone/>
-            </a:pPr>
-            <a:r>
-              <a:rPr lang="en-US" sz="1300" dirty="0">
-                <a:solidFill>
-                  <a:srgbClr val="DCEAEC"/>
-                </a:solidFill>
-                <a:latin typeface="Calibri" pitchFamily="34" charset="0"/>
-                <a:ea typeface="Calibri" pitchFamily="34" charset="-122"/>
-                <a:cs typeface="Calibri" pitchFamily="34" charset="-120"/>
-              </a:rPr>
-              <a:t>Synthetic single-year data, flat geography/age, engineered engagement — sizes directional, conclusions robust on ratios.</a:t>
-            </a:r>
-            <a:endParaRPr lang="en-US" sz="1300" dirty="0"/>
-          </a:p>
-        </p:txBody>
-      </p:sp>
-      <p:sp>
-        <p:nvSpPr>
-          <p:cNvPr id="13" name="Text 11"/>
-          <p:cNvSpPr txBox="1"/>
-          <p:nvPr/>
-        </p:nvSpPr>
-        <p:spPr>
-          <a:xfrm>
-            <a:off x="822960" y="6263640"/>
-            <a:ext cx="10607040" cy="365760"/>
+              <a:rPr lang="en-US" sz="900" dirty="0">
+                <a:solidFill>
+                  <a:srgbClr val="5F7180"/>
+                </a:solidFill>
+                <a:latin typeface="Calibri" pitchFamily="34" charset="0"/>
+                <a:ea typeface="Calibri" pitchFamily="34" charset="-122"/>
+                <a:cs typeface="Calibri" pitchFamily="34" charset="-120"/>
+              </a:rPr>
+              <a:t>Group YAPPERS · BI10 Round 01</a:t>
+            </a:r>
+            <a:endParaRPr lang="en-US" sz="900" dirty="0"/>
+          </a:p>
+        </p:txBody>
+      </p:sp>
+      <p:sp>
+        <p:nvSpPr>
+          <p:cNvPr id="7" name="Text 4"/>
+          <p:cNvSpPr txBox="1"/>
+          <p:nvPr/>
+        </p:nvSpPr>
+        <p:spPr>
+          <a:xfrm>
+            <a:off x="11430000" y="6473952"/>
+            <a:ext cx="457200" cy="274320"/>
           </a:xfrm>
           <a:prstGeom prst="rect">
             <a:avLst/>
@@ -5951,21 +6289,21 @@
           <a:bodyPr wrap="square" lIns="0" tIns="0" rIns="0" bIns="0" rtlCol="0" anchor="ctr"/>
           <a:lstStyle/>
           <a:p>
-            <a:pPr indent="0" marL="0">
-              <a:buNone/>
-            </a:pPr>
-            <a:r>
-              <a:rPr lang="en-US" sz="1300" b="1" i="1" dirty="0">
-                <a:solidFill>
-                  <a:srgbClr val="1FC3A6"/>
-                </a:solidFill>
-                <a:latin typeface="Calibri" pitchFamily="34" charset="0"/>
-                <a:ea typeface="Calibri" pitchFamily="34" charset="-122"/>
-                <a:cs typeface="Calibri" pitchFamily="34" charset="-120"/>
-              </a:rPr>
-              <a:t>One guarantee: wellbeing help, never a credit decision.</a:t>
-            </a:r>
-            <a:endParaRPr lang="en-US" sz="1300" dirty="0"/>
+            <a:pPr algn="r" indent="0" marL="0">
+              <a:buNone/>
+            </a:pPr>
+            <a:r>
+              <a:rPr lang="en-US" sz="900" dirty="0">
+                <a:solidFill>
+                  <a:srgbClr val="5F7180"/>
+                </a:solidFill>
+                <a:latin typeface="Calibri" pitchFamily="34" charset="0"/>
+                <a:ea typeface="Calibri" pitchFamily="34" charset="-122"/>
+                <a:cs typeface="Calibri" pitchFamily="34" charset="-120"/>
+              </a:rPr>
+              <a:t>19</a:t>
+            </a:r>
+            <a:endParaRPr lang="en-US" sz="900" dirty="0"/>
           </a:p>
         </p:txBody>
       </p:sp>
@@ -6307,7 +6645,7 @@
                 <a:ea typeface="Calibri" pitchFamily="34" charset="-122"/>
                 <a:cs typeface="Calibri" pitchFamily="34" charset="-120"/>
               </a:rPr>
-              <a:t>0 of 999 chronically stressed; the crossover = 43 consumers = 52% of ALL stress episodes.</a:t>
+              <a:t>0 of 999 chronically stressed; the crossover = 43 consumers = 52% of ALL stress episodes; 72% of Healthy→Stretched slides happen Nov→Dec.</a:t>
             </a:r>
             <a:endParaRPr lang="en-US" sz="1350" dirty="0"/>
           </a:p>
@@ -6346,7 +6684,7 @@
                 <a:ea typeface="Calibri" pitchFamily="34" charset="-122"/>
                 <a:cs typeface="Calibri" pitchFamily="34" charset="-120"/>
               </a:rPr>
-              <a:t>Four actionable segments</a:t>
+              <a:t>Four stable segments</a:t>
             </a:r>
             <a:endParaRPr lang="en-US" sz="1500" dirty="0"/>
           </a:p>
@@ -6385,7 +6723,7 @@
                 <a:ea typeface="Calibri" pitchFamily="34" charset="-122"/>
                 <a:cs typeface="Calibri" pitchFamily="34" charset="-120"/>
               </a:rPr>
-              <a:t>k-means (k=4), 999/999 covered — sizes 351 / 302 / 258 / 88.</a:t>
+              <a:t>k-means (k=4), 999/999 covered — sizes 351 / 302 / 258 / 88; stable across seeds (ARI 0.99).</a:t>
             </a:r>
             <a:endParaRPr lang="en-US" sz="1350" dirty="0"/>
           </a:p>
@@ -6463,9 +6801,1371 @@
                 <a:ea typeface="Calibri" pitchFamily="34" charset="-122"/>
                 <a:cs typeface="Calibri" pitchFamily="34" charset="-120"/>
               </a:rPr>
-              <a:t>lead with Budgeting (302) + in-app Spend Alerts (43); FHS never denies, cuts, or blocks credit.</a:t>
+              <a:t>lead with Budgeting (302) + Spend Alerts (43, Sun–Mon evenings); a 10% spend trim cuts stress months ~32%. FHS never denies, cuts, or blocks credit.</a:t>
             </a:r>
             <a:endParaRPr lang="en-US" sz="1350" dirty="0"/>
+          </a:p>
+        </p:txBody>
+      </p:sp>
+    </p:spTree>
+  </p:cSld>
+  <p:clrMapOvr>
+    <a:masterClrMapping/>
+  </p:clrMapOvr>
+</p:sld>
+</file>
+
+<file path=ppt/slides/slide20.xml><?xml version="1.0" encoding="utf-8"?>
+<p:sld xmlns:a="http://schemas.openxmlformats.org/drawingml/2006/main" xmlns:r="http://schemas.openxmlformats.org/officeDocument/2006/relationships" xmlns:p="http://schemas.openxmlformats.org/presentationml/2006/main">
+  <p:cSld name="Slide 20">
+    <p:bg>
+      <p:bgPr>
+        <a:solidFill>
+          <a:srgbClr val="FFFFFF"/>
+        </a:solidFill>
+      </p:bgPr>
+    </p:bg>
+    <p:spTree>
+      <p:nvGrpSpPr>
+        <p:cNvPr id="1" name=""/>
+        <p:cNvGrpSpPr/>
+        <p:nvPr/>
+      </p:nvGrpSpPr>
+      <p:grpSpPr>
+        <a:xfrm>
+          <a:off x="0" y="0"/>
+          <a:ext cx="0" cy="0"/>
+          <a:chOff x="0" y="0"/>
+          <a:chExt cx="0" cy="0"/>
+        </a:xfrm>
+      </p:grpSpPr>
+      <p:sp>
+        <p:nvSpPr>
+          <p:cNvPr id="2" name="Text 0"/>
+          <p:cNvSpPr txBox="1"/>
+          <p:nvPr/>
+        </p:nvSpPr>
+        <p:spPr>
+          <a:xfrm>
+            <a:off x="457200" y="384048"/>
+            <a:ext cx="4114800" cy="292608"/>
+          </a:xfrm>
+          <a:prstGeom prst="rect">
+            <a:avLst/>
+          </a:prstGeom>
+          <a:noFill/>
+          <a:ln/>
+        </p:spPr>
+        <p:txBody>
+          <a:bodyPr wrap="square" lIns="0" tIns="0" rIns="0" bIns="0" rtlCol="0" anchor="ctr"/>
+          <a:lstStyle/>
+          <a:p>
+            <a:pPr indent="0" marL="0">
+              <a:buNone/>
+            </a:pPr>
+            <a:r>
+              <a:rPr lang="en-US" sz="1100" b="1" spc="200" kern="0" dirty="0">
+                <a:solidFill>
+                  <a:srgbClr val="058B8C"/>
+                </a:solidFill>
+                <a:latin typeface="Calibri" pitchFamily="34" charset="0"/>
+                <a:ea typeface="Calibri" pitchFamily="34" charset="-122"/>
+                <a:cs typeface="Calibri" pitchFamily="34" charset="-120"/>
+              </a:rPr>
+              <a:t>TASK 5 · RECOMMENDATIONS</a:t>
+            </a:r>
+            <a:endParaRPr lang="en-US" sz="1100" dirty="0"/>
+          </a:p>
+        </p:txBody>
+      </p:sp>
+      <p:sp>
+        <p:nvSpPr>
+          <p:cNvPr id="3" name="Text 1"/>
+          <p:cNvSpPr txBox="1"/>
+          <p:nvPr/>
+        </p:nvSpPr>
+        <p:spPr>
+          <a:xfrm>
+            <a:off x="457200" y="658368"/>
+            <a:ext cx="11247120" cy="868680"/>
+          </a:xfrm>
+          <a:prstGeom prst="rect">
+            <a:avLst/>
+          </a:prstGeom>
+          <a:noFill/>
+          <a:ln/>
+        </p:spPr>
+        <p:txBody>
+          <a:bodyPr wrap="square" lIns="0" tIns="0" rIns="0" bIns="0" rtlCol="0" anchor="t"/>
+          <a:lstStyle/>
+          <a:p>
+            <a:pPr indent="0" marL="0">
+              <a:lnSpc>
+                <a:spcPct val="95000"/>
+              </a:lnSpc>
+              <a:buNone/>
+            </a:pPr>
+            <a:r>
+              <a:rPr lang="en-US" sz="2700" b="1" dirty="0">
+                <a:solidFill>
+                  <a:srgbClr val="12435E"/>
+                </a:solidFill>
+                <a:latin typeface="Cambria" pitchFamily="34" charset="0"/>
+                <a:ea typeface="Cambria" pitchFamily="34" charset="-122"/>
+                <a:cs typeface="Cambria" pitchFamily="34" charset="-120"/>
+              </a:rPr>
+              <a:t>Prioritization &amp; the ethical rule</a:t>
+            </a:r>
+            <a:endParaRPr lang="en-US" sz="2700" dirty="0"/>
+          </a:p>
+        </p:txBody>
+      </p:sp>
+      <p:sp>
+        <p:nvSpPr>
+          <p:cNvPr id="4" name="Text 2"/>
+          <p:cNvSpPr txBox="1"/>
+          <p:nvPr/>
+        </p:nvSpPr>
+        <p:spPr>
+          <a:xfrm>
+            <a:off x="457200" y="1600200"/>
+            <a:ext cx="5760720" cy="3200400"/>
+          </a:xfrm>
+          <a:prstGeom prst="rect">
+            <a:avLst/>
+          </a:prstGeom>
+          <a:noFill/>
+          <a:ln/>
+        </p:spPr>
+        <p:txBody>
+          <a:bodyPr wrap="square" rtlCol="0" anchor="t"/>
+          <a:lstStyle/>
+          <a:p>
+            <a:pPr marL="177800" indent="-177800">
+              <a:spcAft>
+                <a:spcPts val="800"/>
+              </a:spcAft>
+              <a:buSzPct val="100000"/>
+              <a:buChar char="•"/>
+            </a:pPr>
+            <a:r>
+              <a:rPr lang="en-US" sz="1400" dirty="0">
+                <a:solidFill>
+                  <a:srgbClr val="1B2A36"/>
+                </a:solidFill>
+                <a:latin typeface="Calibri" pitchFamily="34" charset="0"/>
+                <a:ea typeface="Calibri" pitchFamily="34" charset="-122"/>
+                <a:cs typeface="Calibri" pitchFamily="34" charset="-120"/>
+              </a:rPr>
+              <a:t>Ranking (reach × driver): Budgeting → Alerts → Reminders → Products → Nudges → Education.</a:t>
+            </a:r>
+            <a:endParaRPr lang="en-US" sz="1400" dirty="0"/>
+          </a:p>
+          <a:p>
+            <a:pPr marL="177800" indent="-177800">
+              <a:spcAft>
+                <a:spcPts val="800"/>
+              </a:spcAft>
+              <a:buSzPct val="100000"/>
+              <a:buChar char="•"/>
+            </a:pPr>
+            <a:r>
+              <a:rPr lang="en-US" sz="1400" dirty="0">
+                <a:solidFill>
+                  <a:srgbClr val="1B2A36"/>
+                </a:solidFill>
+                <a:latin typeface="Calibri" pitchFamily="34" charset="0"/>
+                <a:ea typeface="Calibri" pitchFamily="34" charset="-122"/>
+                <a:cs typeface="Calibri" pitchFamily="34" charset="-120"/>
+              </a:rPr>
+              <a:t>Lead with Budgeting + Alerts (the wellbeing mission); layer growth on top.</a:t>
+            </a:r>
+            <a:endParaRPr lang="en-US" sz="1400" dirty="0"/>
+          </a:p>
+          <a:p>
+            <a:pPr marL="177800" indent="-177800">
+              <a:spcAft>
+                <a:spcPts val="800"/>
+              </a:spcAft>
+              <a:buSzPct val="100000"/>
+              <a:buChar char="•"/>
+            </a:pPr>
+            <a:r>
+              <a:rPr lang="en-US" sz="1400" dirty="0">
+                <a:solidFill>
+                  <a:srgbClr val="1B2A36"/>
+                </a:solidFill>
+                <a:latin typeface="Calibri" pitchFamily="34" charset="0"/>
+                <a:ea typeface="Calibri" pitchFamily="34" charset="-122"/>
+                <a:cs typeface="Calibri" pitchFamily="34" charset="-120"/>
+              </a:rPr>
+              <a:t>No double-counting: the 4 segments partition 999; crossover (43) &amp; distress (67) are overlays inside Segment 2.</a:t>
+            </a:r>
+            <a:endParaRPr lang="en-US" sz="1400" dirty="0"/>
+          </a:p>
+          <a:p>
+            <a:pPr marL="177800" indent="-177800">
+              <a:spcAft>
+                <a:spcPts val="800"/>
+              </a:spcAft>
+              <a:buSzPct val="100000"/>
+              <a:buChar char="•"/>
+            </a:pPr>
+            <a:r>
+              <a:rPr lang="en-US" sz="1400" dirty="0">
+                <a:solidFill>
+                  <a:srgbClr val="1B2A36"/>
+                </a:solidFill>
+                <a:latin typeface="Calibri" pitchFamily="34" charset="0"/>
+                <a:ea typeface="Calibri" pitchFamily="34" charset="-122"/>
+                <a:cs typeface="Calibri" pitchFamily="34" charset="-120"/>
+              </a:rPr>
+              <a:t>Fair by design: every trigger is a behavioural ratio; segments correlate with age/gender, so we never target by demographics.</a:t>
+            </a:r>
+            <a:endParaRPr lang="en-US" sz="1400" dirty="0"/>
+          </a:p>
+        </p:txBody>
+      </p:sp>
+      <p:pic>
+        <p:nvPicPr>
+          <p:cNvPr id="5" name="Image 0" descr="D:\BI10GroupYAPPERS\outputs\figures\t5_priority_ranking.png">    </p:cNvPr>
+          <p:cNvPicPr>
+            <a:picLocks noChangeAspect="1"/>
+          </p:cNvPicPr>
+          <p:nvPr/>
+        </p:nvPicPr>
+        <p:blipFill>
+          <a:blip r:embed="rId1"/>
+          <a:srcRect l="0" r="0" t="0" b="0"/>
+          <a:stretch/>
+        </p:blipFill>
+        <p:spPr>
+          <a:xfrm>
+            <a:off x="6446520" y="1554480"/>
+            <a:ext cx="5303520" cy="4206240"/>
+          </a:xfrm>
+          <a:prstGeom prst="rect">
+            <a:avLst/>
+          </a:prstGeom>
+        </p:spPr>
+      </p:pic>
+      <p:sp>
+        <p:nvSpPr>
+          <p:cNvPr id="6" name="Shape 3"/>
+          <p:cNvSpPr/>
+          <p:nvPr/>
+        </p:nvSpPr>
+        <p:spPr>
+          <a:xfrm>
+            <a:off x="457200" y="5029200"/>
+            <a:ext cx="3383280" cy="1097280"/>
+          </a:xfrm>
+          <a:prstGeom prst="roundRect">
+            <a:avLst>
+              <a:gd name="adj" fmla="val 6667"/>
+            </a:avLst>
+          </a:prstGeom>
+          <a:solidFill>
+            <a:srgbClr val="12435E"/>
+          </a:solidFill>
+          <a:ln/>
+        </p:spPr>
+      </p:sp>
+      <p:sp>
+        <p:nvSpPr>
+          <p:cNvPr id="7" name="Text 4"/>
+          <p:cNvSpPr txBox="1"/>
+          <p:nvPr/>
+        </p:nvSpPr>
+        <p:spPr>
+          <a:xfrm>
+            <a:off x="457200" y="5138928"/>
+            <a:ext cx="3383280" cy="658368"/>
+          </a:xfrm>
+          <a:prstGeom prst="rect">
+            <a:avLst/>
+          </a:prstGeom>
+          <a:noFill/>
+          <a:ln/>
+        </p:spPr>
+        <p:txBody>
+          <a:bodyPr wrap="square" lIns="0" tIns="0" rIns="0" bIns="0" rtlCol="0" anchor="ctr"/>
+          <a:lstStyle/>
+          <a:p>
+            <a:pPr algn="ctr" indent="0" marL="0">
+              <a:buNone/>
+            </a:pPr>
+            <a:r>
+              <a:rPr lang="en-US" sz="2800" b="1" dirty="0">
+                <a:solidFill>
+                  <a:srgbClr val="1FC3A6"/>
+                </a:solidFill>
+                <a:latin typeface="Cambria" pitchFamily="34" charset="0"/>
+                <a:ea typeface="Cambria" pitchFamily="34" charset="-122"/>
+                <a:cs typeface="Cambria" pitchFamily="34" charset="-120"/>
+              </a:rPr>
+              <a:t>NEVER</a:t>
+            </a:r>
+            <a:endParaRPr lang="en-US" sz="2800" dirty="0"/>
+          </a:p>
+        </p:txBody>
+      </p:sp>
+      <p:sp>
+        <p:nvSpPr>
+          <p:cNvPr id="8" name="Text 5"/>
+          <p:cNvSpPr txBox="1"/>
+          <p:nvPr/>
+        </p:nvSpPr>
+        <p:spPr>
+          <a:xfrm>
+            <a:off x="457200" y="5779008"/>
+            <a:ext cx="3383280" cy="320040"/>
+          </a:xfrm>
+          <a:prstGeom prst="rect">
+            <a:avLst/>
+          </a:prstGeom>
+          <a:noFill/>
+          <a:ln/>
+        </p:spPr>
+        <p:txBody>
+          <a:bodyPr wrap="square" lIns="0" tIns="0" rIns="0" bIns="0" rtlCol="0" anchor="ctr"/>
+          <a:lstStyle/>
+          <a:p>
+            <a:pPr algn="ctr" indent="0" marL="0">
+              <a:buNone/>
+            </a:pPr>
+            <a:r>
+              <a:rPr lang="en-US" sz="1100" dirty="0">
+                <a:solidFill>
+                  <a:srgbClr val="FFFFFF"/>
+                </a:solidFill>
+                <a:latin typeface="Calibri" pitchFamily="34" charset="0"/>
+                <a:ea typeface="Calibri" pitchFamily="34" charset="-122"/>
+                <a:cs typeface="Calibri" pitchFamily="34" charset="-120"/>
+              </a:rPr>
+              <a:t>FHS → credit decision</a:t>
+            </a:r>
+            <a:endParaRPr lang="en-US" sz="1100" dirty="0"/>
+          </a:p>
+        </p:txBody>
+      </p:sp>
+      <p:sp>
+        <p:nvSpPr>
+          <p:cNvPr id="9" name="Text 6"/>
+          <p:cNvSpPr txBox="1"/>
+          <p:nvPr/>
+        </p:nvSpPr>
+        <p:spPr>
+          <a:xfrm>
+            <a:off x="457200" y="6473952"/>
+            <a:ext cx="5486400" cy="274320"/>
+          </a:xfrm>
+          <a:prstGeom prst="rect">
+            <a:avLst/>
+          </a:prstGeom>
+          <a:noFill/>
+          <a:ln/>
+        </p:spPr>
+        <p:txBody>
+          <a:bodyPr wrap="square" lIns="0" tIns="0" rIns="0" bIns="0" rtlCol="0" anchor="ctr"/>
+          <a:lstStyle/>
+          <a:p>
+            <a:pPr indent="0" marL="0">
+              <a:buNone/>
+            </a:pPr>
+            <a:r>
+              <a:rPr lang="en-US" sz="900" dirty="0">
+                <a:solidFill>
+                  <a:srgbClr val="5F7180"/>
+                </a:solidFill>
+                <a:latin typeface="Calibri" pitchFamily="34" charset="0"/>
+                <a:ea typeface="Calibri" pitchFamily="34" charset="-122"/>
+                <a:cs typeface="Calibri" pitchFamily="34" charset="-120"/>
+              </a:rPr>
+              <a:t>Group YAPPERS · BI10 Round 01</a:t>
+            </a:r>
+            <a:endParaRPr lang="en-US" sz="900" dirty="0"/>
+          </a:p>
+        </p:txBody>
+      </p:sp>
+      <p:sp>
+        <p:nvSpPr>
+          <p:cNvPr id="10" name="Text 7"/>
+          <p:cNvSpPr txBox="1"/>
+          <p:nvPr/>
+        </p:nvSpPr>
+        <p:spPr>
+          <a:xfrm>
+            <a:off x="11430000" y="6473952"/>
+            <a:ext cx="457200" cy="274320"/>
+          </a:xfrm>
+          <a:prstGeom prst="rect">
+            <a:avLst/>
+          </a:prstGeom>
+          <a:noFill/>
+          <a:ln/>
+        </p:spPr>
+        <p:txBody>
+          <a:bodyPr wrap="square" lIns="0" tIns="0" rIns="0" bIns="0" rtlCol="0" anchor="ctr"/>
+          <a:lstStyle/>
+          <a:p>
+            <a:pPr algn="r" indent="0" marL="0">
+              <a:buNone/>
+            </a:pPr>
+            <a:r>
+              <a:rPr lang="en-US" sz="900" dirty="0">
+                <a:solidFill>
+                  <a:srgbClr val="5F7180"/>
+                </a:solidFill>
+                <a:latin typeface="Calibri" pitchFamily="34" charset="0"/>
+                <a:ea typeface="Calibri" pitchFamily="34" charset="-122"/>
+                <a:cs typeface="Calibri" pitchFamily="34" charset="-120"/>
+              </a:rPr>
+              <a:t>20</a:t>
+            </a:r>
+            <a:endParaRPr lang="en-US" sz="900" dirty="0"/>
+          </a:p>
+        </p:txBody>
+      </p:sp>
+    </p:spTree>
+  </p:cSld>
+  <p:clrMapOvr>
+    <a:masterClrMapping/>
+  </p:clrMapOvr>
+</p:sld>
+</file>
+
+<file path=ppt/slides/slide21.xml><?xml version="1.0" encoding="utf-8"?>
+<p:sld xmlns:a="http://schemas.openxmlformats.org/drawingml/2006/main" xmlns:r="http://schemas.openxmlformats.org/officeDocument/2006/relationships" xmlns:p="http://schemas.openxmlformats.org/presentationml/2006/main">
+  <p:cSld name="Slide 21">
+    <p:bg>
+      <p:bgPr>
+        <a:solidFill>
+          <a:srgbClr val="FFFFFF"/>
+        </a:solidFill>
+      </p:bgPr>
+    </p:bg>
+    <p:spTree>
+      <p:nvGrpSpPr>
+        <p:cNvPr id="1" name=""/>
+        <p:cNvGrpSpPr/>
+        <p:nvPr/>
+      </p:nvGrpSpPr>
+      <p:grpSpPr>
+        <a:xfrm>
+          <a:off x="0" y="0"/>
+          <a:ext cx="0" cy="0"/>
+          <a:chOff x="0" y="0"/>
+          <a:chExt cx="0" cy="0"/>
+        </a:xfrm>
+      </p:grpSpPr>
+      <p:sp>
+        <p:nvSpPr>
+          <p:cNvPr id="2" name="Text 0"/>
+          <p:cNvSpPr txBox="1"/>
+          <p:nvPr/>
+        </p:nvSpPr>
+        <p:spPr>
+          <a:xfrm>
+            <a:off x="457200" y="384048"/>
+            <a:ext cx="4114800" cy="292608"/>
+          </a:xfrm>
+          <a:prstGeom prst="rect">
+            <a:avLst/>
+          </a:prstGeom>
+          <a:noFill/>
+          <a:ln/>
+        </p:spPr>
+        <p:txBody>
+          <a:bodyPr wrap="square" lIns="0" tIns="0" rIns="0" bIns="0" rtlCol="0" anchor="ctr"/>
+          <a:lstStyle/>
+          <a:p>
+            <a:pPr indent="0" marL="0">
+              <a:buNone/>
+            </a:pPr>
+            <a:r>
+              <a:rPr lang="en-US" sz="1100" b="1" spc="200" kern="0" dirty="0">
+                <a:solidFill>
+                  <a:srgbClr val="058B8C"/>
+                </a:solidFill>
+                <a:latin typeface="Calibri" pitchFamily="34" charset="0"/>
+                <a:ea typeface="Calibri" pitchFamily="34" charset="-122"/>
+                <a:cs typeface="Calibri" pitchFamily="34" charset="-120"/>
+              </a:rPr>
+              <a:t>TASK 5 · IMPACT</a:t>
+            </a:r>
+            <a:endParaRPr lang="en-US" sz="1100" dirty="0"/>
+          </a:p>
+        </p:txBody>
+      </p:sp>
+      <p:sp>
+        <p:nvSpPr>
+          <p:cNvPr id="3" name="Text 1"/>
+          <p:cNvSpPr txBox="1"/>
+          <p:nvPr/>
+        </p:nvSpPr>
+        <p:spPr>
+          <a:xfrm>
+            <a:off x="457200" y="658368"/>
+            <a:ext cx="11247120" cy="868680"/>
+          </a:xfrm>
+          <a:prstGeom prst="rect">
+            <a:avLst/>
+          </a:prstGeom>
+          <a:noFill/>
+          <a:ln/>
+        </p:spPr>
+        <p:txBody>
+          <a:bodyPr wrap="square" lIns="0" tIns="0" rIns="0" bIns="0" rtlCol="0" anchor="t"/>
+          <a:lstStyle/>
+          <a:p>
+            <a:pPr indent="0" marL="0">
+              <a:lnSpc>
+                <a:spcPct val="95000"/>
+              </a:lnSpc>
+              <a:buNone/>
+            </a:pPr>
+            <a:r>
+              <a:rPr lang="en-US" sz="2700" b="1" dirty="0">
+                <a:solidFill>
+                  <a:srgbClr val="12435E"/>
+                </a:solidFill>
+                <a:latin typeface="Cambria" pitchFamily="34" charset="0"/>
+                <a:ea typeface="Cambria" pitchFamily="34" charset="-122"/>
+                <a:cs typeface="Cambria" pitchFamily="34" charset="-120"/>
+              </a:rPr>
+              <a:t>Expected impact, measurement &amp; a 90-day roadmap</a:t>
+            </a:r>
+            <a:endParaRPr lang="en-US" sz="2700" dirty="0"/>
+          </a:p>
+        </p:txBody>
+      </p:sp>
+      <p:sp>
+        <p:nvSpPr>
+          <p:cNvPr id="4" name="Text 2"/>
+          <p:cNvSpPr txBox="1"/>
+          <p:nvPr/>
+        </p:nvSpPr>
+        <p:spPr>
+          <a:xfrm>
+            <a:off x="457200" y="1600200"/>
+            <a:ext cx="5760720" cy="3200400"/>
+          </a:xfrm>
+          <a:prstGeom prst="rect">
+            <a:avLst/>
+          </a:prstGeom>
+          <a:noFill/>
+          <a:ln/>
+        </p:spPr>
+        <p:txBody>
+          <a:bodyPr wrap="square" rtlCol="0" anchor="t"/>
+          <a:lstStyle/>
+          <a:p>
+            <a:pPr marL="177800" indent="-177800">
+              <a:spcAft>
+                <a:spcPts val="800"/>
+              </a:spcAft>
+              <a:buSzPct val="100000"/>
+              <a:buChar char="•"/>
+            </a:pPr>
+            <a:r>
+              <a:rPr lang="en-US" sz="1400" dirty="0">
+                <a:solidFill>
+                  <a:srgbClr val="1B2A36"/>
+                </a:solidFill>
+                <a:latin typeface="Calibri" pitchFamily="34" charset="0"/>
+                <a:ea typeface="Calibri" pitchFamily="34" charset="-122"/>
+                <a:cs typeface="Calibri" pitchFamily="34" charset="-120"/>
+              </a:rPr>
+              <a:t>Scenario (illustrative): FHS = 84.1 − 25.3 × spend/income. A 10% trim for the Stretched 302 cuts stress months 95 → 65 (−32%); 5% → 80 (−16%).</a:t>
+            </a:r>
+            <a:endParaRPr lang="en-US" sz="1400" dirty="0"/>
+          </a:p>
+          <a:p>
+            <a:pPr marL="177800" indent="-177800">
+              <a:spcAft>
+                <a:spcPts val="800"/>
+              </a:spcAft>
+              <a:buSzPct val="100000"/>
+              <a:buChar char="•"/>
+            </a:pPr>
+            <a:r>
+              <a:rPr lang="en-US" sz="1400" dirty="0">
+                <a:solidFill>
+                  <a:srgbClr val="1B2A36"/>
+                </a:solidFill>
+                <a:latin typeface="Calibri" pitchFamily="34" charset="0"/>
+                <a:ea typeface="Calibri" pitchFamily="34" charset="-122"/>
+                <a:cs typeface="Calibri" pitchFamily="34" charset="-120"/>
+              </a:rPr>
+              <a:t>Every tool gets one KPI and a randomised holdout (e.g. Budgeting: spend-to-income, 10% holdout for 3 months).</a:t>
+            </a:r>
+            <a:endParaRPr lang="en-US" sz="1400" dirty="0"/>
+          </a:p>
+          <a:p>
+            <a:pPr marL="177800" indent="-177800">
+              <a:spcAft>
+                <a:spcPts val="800"/>
+              </a:spcAft>
+              <a:buSzPct val="100000"/>
+              <a:buChar char="•"/>
+            </a:pPr>
+            <a:r>
+              <a:rPr lang="en-US" sz="1400" dirty="0">
+                <a:solidFill>
+                  <a:srgbClr val="1B2A36"/>
+                </a:solidFill>
+                <a:latin typeface="Calibri" pitchFamily="34" charset="0"/>
+                <a:ea typeface="Calibri" pitchFamily="34" charset="-122"/>
+                <a:cs typeface="Calibri" pitchFamily="34" charset="-120"/>
+              </a:rPr>
+              <a:t>Days 0–30: Budgeting + Alerts · 31–60: November Reminders + Nudges · 61–90: Education + opt-in Products; keep what moves the KPI.</a:t>
+            </a:r>
+            <a:endParaRPr lang="en-US" sz="1400" dirty="0"/>
+          </a:p>
+        </p:txBody>
+      </p:sp>
+      <p:pic>
+        <p:nvPicPr>
+          <p:cNvPr id="5" name="Image 0" descr="D:\BI10GroupYAPPERS\outputs\figures\t5_impact_scenario.png">    </p:cNvPr>
+          <p:cNvPicPr>
+            <a:picLocks noChangeAspect="1"/>
+          </p:cNvPicPr>
+          <p:nvPr/>
+        </p:nvPicPr>
+        <p:blipFill>
+          <a:blip r:embed="rId1"/>
+          <a:srcRect l="0" r="0" t="0" b="0"/>
+          <a:stretch/>
+        </p:blipFill>
+        <p:spPr>
+          <a:xfrm>
+            <a:off x="6446520" y="1554480"/>
+            <a:ext cx="5303520" cy="4206240"/>
+          </a:xfrm>
+          <a:prstGeom prst="rect">
+            <a:avLst/>
+          </a:prstGeom>
+        </p:spPr>
+      </p:pic>
+      <p:sp>
+        <p:nvSpPr>
+          <p:cNvPr id="6" name="Text 3"/>
+          <p:cNvSpPr txBox="1"/>
+          <p:nvPr/>
+        </p:nvSpPr>
+        <p:spPr>
+          <a:xfrm>
+            <a:off x="6446520" y="5852160"/>
+            <a:ext cx="5303520" cy="548640"/>
+          </a:xfrm>
+          <a:prstGeom prst="rect">
+            <a:avLst/>
+          </a:prstGeom>
+          <a:noFill/>
+          <a:ln/>
+        </p:spPr>
+        <p:txBody>
+          <a:bodyPr wrap="square" lIns="0" tIns="0" rIns="0" bIns="0" rtlCol="0" anchor="t"/>
+          <a:lstStyle/>
+          <a:p>
+            <a:pPr indent="0" marL="0">
+              <a:buNone/>
+            </a:pPr>
+            <a:r>
+              <a:rPr lang="en-US" sz="1000" i="1" dirty="0">
+                <a:solidFill>
+                  <a:srgbClr val="5F7180"/>
+                </a:solidFill>
+                <a:latin typeface="Calibri" pitchFamily="34" charset="0"/>
+                <a:ea typeface="Calibri" pitchFamily="34" charset="-122"/>
+                <a:cs typeface="Calibri" pitchFamily="34" charset="-120"/>
+              </a:rPr>
+              <a:t>⚠  FHS embeds spend fields — the slope is mechanical; a scenario to test, not a forecast.</a:t>
+            </a:r>
+            <a:endParaRPr lang="en-US" sz="1000" dirty="0"/>
+          </a:p>
+        </p:txBody>
+      </p:sp>
+      <p:sp>
+        <p:nvSpPr>
+          <p:cNvPr id="7" name="Shape 4"/>
+          <p:cNvSpPr/>
+          <p:nvPr/>
+        </p:nvSpPr>
+        <p:spPr>
+          <a:xfrm>
+            <a:off x="457200" y="5029200"/>
+            <a:ext cx="3383280" cy="1097280"/>
+          </a:xfrm>
+          <a:prstGeom prst="roundRect">
+            <a:avLst>
+              <a:gd name="adj" fmla="val 6667"/>
+            </a:avLst>
+          </a:prstGeom>
+          <a:solidFill>
+            <a:srgbClr val="12435E"/>
+          </a:solidFill>
+          <a:ln/>
+        </p:spPr>
+      </p:sp>
+      <p:sp>
+        <p:nvSpPr>
+          <p:cNvPr id="8" name="Text 5"/>
+          <p:cNvSpPr txBox="1"/>
+          <p:nvPr/>
+        </p:nvSpPr>
+        <p:spPr>
+          <a:xfrm>
+            <a:off x="457200" y="5138928"/>
+            <a:ext cx="3383280" cy="658368"/>
+          </a:xfrm>
+          <a:prstGeom prst="rect">
+            <a:avLst/>
+          </a:prstGeom>
+          <a:noFill/>
+          <a:ln/>
+        </p:spPr>
+        <p:txBody>
+          <a:bodyPr wrap="square" lIns="0" tIns="0" rIns="0" bIns="0" rtlCol="0" anchor="ctr"/>
+          <a:lstStyle/>
+          <a:p>
+            <a:pPr algn="ctr" indent="0" marL="0">
+              <a:buNone/>
+            </a:pPr>
+            <a:r>
+              <a:rPr lang="en-US" sz="2800" b="1" dirty="0">
+                <a:solidFill>
+                  <a:srgbClr val="1FC3A6"/>
+                </a:solidFill>
+                <a:latin typeface="Cambria" pitchFamily="34" charset="0"/>
+                <a:ea typeface="Cambria" pitchFamily="34" charset="-122"/>
+                <a:cs typeface="Cambria" pitchFamily="34" charset="-120"/>
+              </a:rPr>
+              <a:t>−32%</a:t>
+            </a:r>
+            <a:endParaRPr lang="en-US" sz="2800" dirty="0"/>
+          </a:p>
+        </p:txBody>
+      </p:sp>
+      <p:sp>
+        <p:nvSpPr>
+          <p:cNvPr id="9" name="Text 6"/>
+          <p:cNvSpPr txBox="1"/>
+          <p:nvPr/>
+        </p:nvSpPr>
+        <p:spPr>
+          <a:xfrm>
+            <a:off x="457200" y="5779008"/>
+            <a:ext cx="3383280" cy="320040"/>
+          </a:xfrm>
+          <a:prstGeom prst="rect">
+            <a:avLst/>
+          </a:prstGeom>
+          <a:noFill/>
+          <a:ln/>
+        </p:spPr>
+        <p:txBody>
+          <a:bodyPr wrap="square" lIns="0" tIns="0" rIns="0" bIns="0" rtlCol="0" anchor="ctr"/>
+          <a:lstStyle/>
+          <a:p>
+            <a:pPr algn="ctr" indent="0" marL="0">
+              <a:buNone/>
+            </a:pPr>
+            <a:r>
+              <a:rPr lang="en-US" sz="1100" dirty="0">
+                <a:solidFill>
+                  <a:srgbClr val="FFFFFF"/>
+                </a:solidFill>
+                <a:latin typeface="Calibri" pitchFamily="34" charset="0"/>
+                <a:ea typeface="Calibri" pitchFamily="34" charset="-122"/>
+                <a:cs typeface="Calibri" pitchFamily="34" charset="-120"/>
+              </a:rPr>
+              <a:t>stress months at a 10% trim</a:t>
+            </a:r>
+            <a:endParaRPr lang="en-US" sz="1100" dirty="0"/>
+          </a:p>
+        </p:txBody>
+      </p:sp>
+      <p:sp>
+        <p:nvSpPr>
+          <p:cNvPr id="10" name="Text 7"/>
+          <p:cNvSpPr txBox="1"/>
+          <p:nvPr/>
+        </p:nvSpPr>
+        <p:spPr>
+          <a:xfrm>
+            <a:off x="457200" y="6473952"/>
+            <a:ext cx="5486400" cy="274320"/>
+          </a:xfrm>
+          <a:prstGeom prst="rect">
+            <a:avLst/>
+          </a:prstGeom>
+          <a:noFill/>
+          <a:ln/>
+        </p:spPr>
+        <p:txBody>
+          <a:bodyPr wrap="square" lIns="0" tIns="0" rIns="0" bIns="0" rtlCol="0" anchor="ctr"/>
+          <a:lstStyle/>
+          <a:p>
+            <a:pPr indent="0" marL="0">
+              <a:buNone/>
+            </a:pPr>
+            <a:r>
+              <a:rPr lang="en-US" sz="900" dirty="0">
+                <a:solidFill>
+                  <a:srgbClr val="5F7180"/>
+                </a:solidFill>
+                <a:latin typeface="Calibri" pitchFamily="34" charset="0"/>
+                <a:ea typeface="Calibri" pitchFamily="34" charset="-122"/>
+                <a:cs typeface="Calibri" pitchFamily="34" charset="-120"/>
+              </a:rPr>
+              <a:t>Group YAPPERS · BI10 Round 01</a:t>
+            </a:r>
+            <a:endParaRPr lang="en-US" sz="900" dirty="0"/>
+          </a:p>
+        </p:txBody>
+      </p:sp>
+      <p:sp>
+        <p:nvSpPr>
+          <p:cNvPr id="11" name="Text 8"/>
+          <p:cNvSpPr txBox="1"/>
+          <p:nvPr/>
+        </p:nvSpPr>
+        <p:spPr>
+          <a:xfrm>
+            <a:off x="11430000" y="6473952"/>
+            <a:ext cx="457200" cy="274320"/>
+          </a:xfrm>
+          <a:prstGeom prst="rect">
+            <a:avLst/>
+          </a:prstGeom>
+          <a:noFill/>
+          <a:ln/>
+        </p:spPr>
+        <p:txBody>
+          <a:bodyPr wrap="square" lIns="0" tIns="0" rIns="0" bIns="0" rtlCol="0" anchor="ctr"/>
+          <a:lstStyle/>
+          <a:p>
+            <a:pPr algn="r" indent="0" marL="0">
+              <a:buNone/>
+            </a:pPr>
+            <a:r>
+              <a:rPr lang="en-US" sz="900" dirty="0">
+                <a:solidFill>
+                  <a:srgbClr val="5F7180"/>
+                </a:solidFill>
+                <a:latin typeface="Calibri" pitchFamily="34" charset="0"/>
+                <a:ea typeface="Calibri" pitchFamily="34" charset="-122"/>
+                <a:cs typeface="Calibri" pitchFamily="34" charset="-120"/>
+              </a:rPr>
+              <a:t>21</a:t>
+            </a:r>
+            <a:endParaRPr lang="en-US" sz="900" dirty="0"/>
+          </a:p>
+        </p:txBody>
+      </p:sp>
+    </p:spTree>
+  </p:cSld>
+  <p:clrMapOvr>
+    <a:masterClrMapping/>
+  </p:clrMapOvr>
+</p:sld>
+</file>
+
+<file path=ppt/slides/slide22.xml><?xml version="1.0" encoding="utf-8"?>
+<p:sld xmlns:a="http://schemas.openxmlformats.org/drawingml/2006/main" xmlns:r="http://schemas.openxmlformats.org/officeDocument/2006/relationships" xmlns:p="http://schemas.openxmlformats.org/presentationml/2006/main">
+  <p:cSld name="Slide 22">
+    <p:bg>
+      <p:bgPr>
+        <a:solidFill>
+          <a:srgbClr val="0F2A43"/>
+        </a:solidFill>
+      </p:bgPr>
+    </p:bg>
+    <p:spTree>
+      <p:nvGrpSpPr>
+        <p:cNvPr id="1" name=""/>
+        <p:cNvGrpSpPr/>
+        <p:nvPr/>
+      </p:nvGrpSpPr>
+      <p:grpSpPr>
+        <a:xfrm>
+          <a:off x="0" y="0"/>
+          <a:ext cx="0" cy="0"/>
+          <a:chOff x="0" y="0"/>
+          <a:chExt cx="0" cy="0"/>
+        </a:xfrm>
+      </p:grpSpPr>
+      <p:sp>
+        <p:nvSpPr>
+          <p:cNvPr id="2" name="Shape 0"/>
+          <p:cNvSpPr/>
+          <p:nvPr/>
+        </p:nvSpPr>
+        <p:spPr>
+          <a:xfrm>
+            <a:off x="0" y="0"/>
+            <a:ext cx="201168" cy="6858000"/>
+          </a:xfrm>
+          <a:prstGeom prst="rect">
+            <a:avLst/>
+          </a:prstGeom>
+          <a:solidFill>
+            <a:srgbClr val="1FC3A6"/>
+          </a:solidFill>
+          <a:ln/>
+        </p:spPr>
+      </p:sp>
+      <p:sp>
+        <p:nvSpPr>
+          <p:cNvPr id="3" name="Text 1"/>
+          <p:cNvSpPr txBox="1"/>
+          <p:nvPr/>
+        </p:nvSpPr>
+        <p:spPr>
+          <a:xfrm>
+            <a:off x="822960" y="822960"/>
+            <a:ext cx="7315200" cy="365760"/>
+          </a:xfrm>
+          <a:prstGeom prst="rect">
+            <a:avLst/>
+          </a:prstGeom>
+          <a:noFill/>
+          <a:ln/>
+        </p:spPr>
+        <p:txBody>
+          <a:bodyPr wrap="square" lIns="0" tIns="0" rIns="0" bIns="0" rtlCol="0" anchor="ctr"/>
+          <a:lstStyle/>
+          <a:p>
+            <a:pPr indent="0" marL="0">
+              <a:buNone/>
+            </a:pPr>
+            <a:r>
+              <a:rPr lang="en-US" sz="1200" b="1" spc="300" kern="0" dirty="0">
+                <a:solidFill>
+                  <a:srgbClr val="1FC3A6"/>
+                </a:solidFill>
+                <a:latin typeface="Calibri" pitchFamily="34" charset="0"/>
+                <a:ea typeface="Calibri" pitchFamily="34" charset="-122"/>
+                <a:cs typeface="Calibri" pitchFamily="34" charset="-120"/>
+              </a:rPr>
+              <a:t>The contract</a:t>
+            </a:r>
+            <a:endParaRPr lang="en-US" sz="1200" dirty="0"/>
+          </a:p>
+        </p:txBody>
+      </p:sp>
+      <p:sp>
+        <p:nvSpPr>
+          <p:cNvPr id="4" name="Text 2"/>
+          <p:cNvSpPr txBox="1"/>
+          <p:nvPr/>
+        </p:nvSpPr>
+        <p:spPr>
+          <a:xfrm>
+            <a:off x="822960" y="1234440"/>
+            <a:ext cx="10607040" cy="1554480"/>
+          </a:xfrm>
+          <a:prstGeom prst="rect">
+            <a:avLst/>
+          </a:prstGeom>
+          <a:noFill/>
+          <a:ln/>
+        </p:spPr>
+        <p:txBody>
+          <a:bodyPr wrap="square" lIns="0" tIns="0" rIns="0" bIns="0" rtlCol="0" anchor="ctr"/>
+          <a:lstStyle/>
+          <a:p>
+            <a:pPr indent="0" marL="0">
+              <a:lnSpc>
+                <a:spcPct val="105000"/>
+              </a:lnSpc>
+              <a:buNone/>
+            </a:pPr>
+            <a:r>
+              <a:rPr lang="en-US" sz="2800" b="1" dirty="0">
+                <a:solidFill>
+                  <a:srgbClr val="FFFFFF"/>
+                </a:solidFill>
+                <a:latin typeface="Cambria" pitchFamily="34" charset="0"/>
+                <a:ea typeface="Cambria" pitchFamily="34" charset="-122"/>
+                <a:cs typeface="Cambria" pitchFamily="34" charset="-120"/>
+              </a:rPr>
+              <a:t>Grow the healthy, activate the dormant, protect the stretched —</a:t>
+            </a:r>
+            <a:endParaRPr lang="en-US" sz="2800" dirty="0"/>
+          </a:p>
+          <a:p>
+            <a:pPr indent="0" marL="0">
+              <a:lnSpc>
+                <a:spcPct val="105000"/>
+              </a:lnSpc>
+              <a:buNone/>
+            </a:pPr>
+            <a:r>
+              <a:rPr lang="en-US" sz="2800" b="1" dirty="0">
+                <a:solidFill>
+                  <a:srgbClr val="FFFFFF"/>
+                </a:solidFill>
+                <a:latin typeface="Cambria" pitchFamily="34" charset="0"/>
+                <a:ea typeface="Cambria" pitchFamily="34" charset="-122"/>
+                <a:cs typeface="Cambria" pitchFamily="34" charset="-120"/>
+              </a:rPr>
+              <a:t>without ever touching their credit.</a:t>
+            </a:r>
+            <a:endParaRPr lang="en-US" sz="2800" dirty="0"/>
+          </a:p>
+        </p:txBody>
+      </p:sp>
+      <p:sp>
+        <p:nvSpPr>
+          <p:cNvPr id="5" name="Text 3"/>
+          <p:cNvSpPr txBox="1"/>
+          <p:nvPr/>
+        </p:nvSpPr>
+        <p:spPr>
+          <a:xfrm>
+            <a:off x="822960" y="3063240"/>
+            <a:ext cx="2468880" cy="731520"/>
+          </a:xfrm>
+          <a:prstGeom prst="rect">
+            <a:avLst/>
+          </a:prstGeom>
+          <a:noFill/>
+          <a:ln/>
+        </p:spPr>
+        <p:txBody>
+          <a:bodyPr wrap="square" lIns="0" tIns="0" rIns="0" bIns="0" rtlCol="0" anchor="t"/>
+          <a:lstStyle/>
+          <a:p>
+            <a:pPr indent="0" marL="0">
+              <a:buNone/>
+            </a:pPr>
+            <a:r>
+              <a:rPr lang="en-US" sz="1400" b="1" dirty="0">
+                <a:solidFill>
+                  <a:srgbClr val="1FC3A6"/>
+                </a:solidFill>
+                <a:latin typeface="Calibri" pitchFamily="34" charset="0"/>
+                <a:ea typeface="Calibri" pitchFamily="34" charset="-122"/>
+                <a:cs typeface="Calibri" pitchFamily="34" charset="-120"/>
+              </a:rPr>
+              <a:t>The spine</a:t>
+            </a:r>
+            <a:endParaRPr lang="en-US" sz="1400" dirty="0"/>
+          </a:p>
+        </p:txBody>
+      </p:sp>
+      <p:sp>
+        <p:nvSpPr>
+          <p:cNvPr id="6" name="Text 4"/>
+          <p:cNvSpPr txBox="1"/>
+          <p:nvPr/>
+        </p:nvSpPr>
+        <p:spPr>
+          <a:xfrm>
+            <a:off x="3383280" y="3063240"/>
+            <a:ext cx="8046720" cy="731520"/>
+          </a:xfrm>
+          <a:prstGeom prst="rect">
+            <a:avLst/>
+          </a:prstGeom>
+          <a:noFill/>
+          <a:ln/>
+        </p:spPr>
+        <p:txBody>
+          <a:bodyPr wrap="square" lIns="0" tIns="0" rIns="0" bIns="0" rtlCol="0" anchor="t"/>
+          <a:lstStyle/>
+          <a:p>
+            <a:pPr indent="0" marL="0">
+              <a:buNone/>
+            </a:pPr>
+            <a:r>
+              <a:rPr lang="en-US" sz="1300" dirty="0">
+                <a:solidFill>
+                  <a:srgbClr val="DCEAEC"/>
+                </a:solidFill>
+                <a:latin typeface="Calibri" pitchFamily="34" charset="0"/>
+                <a:ea typeface="Calibri" pitchFamily="34" charset="-122"/>
+                <a:cs typeface="Calibri" pitchFamily="34" charset="-120"/>
+              </a:rPr>
+              <a:t>Overspend drives poor health; the budget inverts under stress; stress is episodic, striking the most engaged.</a:t>
+            </a:r>
+            <a:endParaRPr lang="en-US" sz="1300" dirty="0"/>
+          </a:p>
+        </p:txBody>
+      </p:sp>
+      <p:sp>
+        <p:nvSpPr>
+          <p:cNvPr id="7" name="Text 5"/>
+          <p:cNvSpPr txBox="1"/>
+          <p:nvPr/>
+        </p:nvSpPr>
+        <p:spPr>
+          <a:xfrm>
+            <a:off x="822960" y="3849624"/>
+            <a:ext cx="2468880" cy="731520"/>
+          </a:xfrm>
+          <a:prstGeom prst="rect">
+            <a:avLst/>
+          </a:prstGeom>
+          <a:noFill/>
+          <a:ln/>
+        </p:spPr>
+        <p:txBody>
+          <a:bodyPr wrap="square" lIns="0" tIns="0" rIns="0" bIns="0" rtlCol="0" anchor="t"/>
+          <a:lstStyle/>
+          <a:p>
+            <a:pPr indent="0" marL="0">
+              <a:buNone/>
+            </a:pPr>
+            <a:r>
+              <a:rPr lang="en-US" sz="1400" b="1" dirty="0">
+                <a:solidFill>
+                  <a:srgbClr val="1FC3A6"/>
+                </a:solidFill>
+                <a:latin typeface="Calibri" pitchFamily="34" charset="0"/>
+                <a:ea typeface="Calibri" pitchFamily="34" charset="-122"/>
+                <a:cs typeface="Calibri" pitchFamily="34" charset="-120"/>
+              </a:rPr>
+              <a:t>The payoff</a:t>
+            </a:r>
+            <a:endParaRPr lang="en-US" sz="1400" dirty="0"/>
+          </a:p>
+        </p:txBody>
+      </p:sp>
+      <p:sp>
+        <p:nvSpPr>
+          <p:cNvPr id="8" name="Text 6"/>
+          <p:cNvSpPr txBox="1"/>
+          <p:nvPr/>
+        </p:nvSpPr>
+        <p:spPr>
+          <a:xfrm>
+            <a:off x="3383280" y="3849624"/>
+            <a:ext cx="8046720" cy="731520"/>
+          </a:xfrm>
+          <a:prstGeom prst="rect">
+            <a:avLst/>
+          </a:prstGeom>
+          <a:noFill/>
+          <a:ln/>
+        </p:spPr>
+        <p:txBody>
+          <a:bodyPr wrap="square" lIns="0" tIns="0" rIns="0" bIns="0" rtlCol="0" anchor="t"/>
+          <a:lstStyle/>
+          <a:p>
+            <a:pPr indent="0" marL="0">
+              <a:buNone/>
+            </a:pPr>
+            <a:r>
+              <a:rPr lang="en-US" sz="1300" dirty="0">
+                <a:solidFill>
+                  <a:srgbClr val="DCEAEC"/>
+                </a:solidFill>
+                <a:latin typeface="Calibri" pitchFamily="34" charset="0"/>
+                <a:ea typeface="Calibri" pitchFamily="34" charset="-122"/>
+                <a:cs typeface="Calibri" pitchFamily="34" charset="-120"/>
+              </a:rPr>
+              <a:t>4 clean segments (351/302/258/88) and a 6-tool plan reaching every customer with the right non-punitive touch.</a:t>
+            </a:r>
+            <a:endParaRPr lang="en-US" sz="1300" dirty="0"/>
+          </a:p>
+        </p:txBody>
+      </p:sp>
+      <p:sp>
+        <p:nvSpPr>
+          <p:cNvPr id="9" name="Text 7"/>
+          <p:cNvSpPr txBox="1"/>
+          <p:nvPr/>
+        </p:nvSpPr>
+        <p:spPr>
+          <a:xfrm>
+            <a:off x="822960" y="4636008"/>
+            <a:ext cx="2468880" cy="731520"/>
+          </a:xfrm>
+          <a:prstGeom prst="rect">
+            <a:avLst/>
+          </a:prstGeom>
+          <a:noFill/>
+          <a:ln/>
+        </p:spPr>
+        <p:txBody>
+          <a:bodyPr wrap="square" lIns="0" tIns="0" rIns="0" bIns="0" rtlCol="0" anchor="t"/>
+          <a:lstStyle/>
+          <a:p>
+            <a:pPr indent="0" marL="0">
+              <a:buNone/>
+            </a:pPr>
+            <a:r>
+              <a:rPr lang="en-US" sz="1400" b="1" dirty="0">
+                <a:solidFill>
+                  <a:srgbClr val="1FC3A6"/>
+                </a:solidFill>
+                <a:latin typeface="Calibri" pitchFamily="34" charset="0"/>
+                <a:ea typeface="Calibri" pitchFamily="34" charset="-122"/>
+                <a:cs typeface="Calibri" pitchFamily="34" charset="-120"/>
+              </a:rPr>
+              <a:t>Lead action</a:t>
+            </a:r>
+            <a:endParaRPr lang="en-US" sz="1400" dirty="0"/>
+          </a:p>
+        </p:txBody>
+      </p:sp>
+      <p:sp>
+        <p:nvSpPr>
+          <p:cNvPr id="10" name="Text 8"/>
+          <p:cNvSpPr txBox="1"/>
+          <p:nvPr/>
+        </p:nvSpPr>
+        <p:spPr>
+          <a:xfrm>
+            <a:off x="3383280" y="4636008"/>
+            <a:ext cx="8046720" cy="731520"/>
+          </a:xfrm>
+          <a:prstGeom prst="rect">
+            <a:avLst/>
+          </a:prstGeom>
+          <a:noFill/>
+          <a:ln/>
+        </p:spPr>
+        <p:txBody>
+          <a:bodyPr wrap="square" lIns="0" tIns="0" rIns="0" bIns="0" rtlCol="0" anchor="t"/>
+          <a:lstStyle/>
+          <a:p>
+            <a:pPr indent="0" marL="0">
+              <a:buNone/>
+            </a:pPr>
+            <a:r>
+              <a:rPr lang="en-US" sz="1300" dirty="0">
+                <a:solidFill>
+                  <a:srgbClr val="DCEAEC"/>
+                </a:solidFill>
+                <a:latin typeface="Calibri" pitchFamily="34" charset="0"/>
+                <a:ea typeface="Calibri" pitchFamily="34" charset="-122"/>
+                <a:cs typeface="Calibri" pitchFamily="34" charset="-120"/>
+              </a:rPr>
+              <a:t>Budgeting for 302 + real-time Alerts catching 52% of all stress — highest reach × strongest driver, near-zero cost.</a:t>
+            </a:r>
+            <a:endParaRPr lang="en-US" sz="1300" dirty="0"/>
+          </a:p>
+        </p:txBody>
+      </p:sp>
+      <p:sp>
+        <p:nvSpPr>
+          <p:cNvPr id="11" name="Text 9"/>
+          <p:cNvSpPr txBox="1"/>
+          <p:nvPr/>
+        </p:nvSpPr>
+        <p:spPr>
+          <a:xfrm>
+            <a:off x="822960" y="5422392"/>
+            <a:ext cx="2468880" cy="731520"/>
+          </a:xfrm>
+          <a:prstGeom prst="rect">
+            <a:avLst/>
+          </a:prstGeom>
+          <a:noFill/>
+          <a:ln/>
+        </p:spPr>
+        <p:txBody>
+          <a:bodyPr wrap="square" lIns="0" tIns="0" rIns="0" bIns="0" rtlCol="0" anchor="t"/>
+          <a:lstStyle/>
+          <a:p>
+            <a:pPr indent="0" marL="0">
+              <a:buNone/>
+            </a:pPr>
+            <a:r>
+              <a:rPr lang="en-US" sz="1400" b="1" dirty="0">
+                <a:solidFill>
+                  <a:srgbClr val="1FC3A6"/>
+                </a:solidFill>
+                <a:latin typeface="Calibri" pitchFamily="34" charset="0"/>
+                <a:ea typeface="Calibri" pitchFamily="34" charset="-122"/>
+                <a:cs typeface="Calibri" pitchFamily="34" charset="-120"/>
+              </a:rPr>
+              <a:t>Honest limits</a:t>
+            </a:r>
+            <a:endParaRPr lang="en-US" sz="1400" dirty="0"/>
+          </a:p>
+        </p:txBody>
+      </p:sp>
+      <p:sp>
+        <p:nvSpPr>
+          <p:cNvPr id="12" name="Text 10"/>
+          <p:cNvSpPr txBox="1"/>
+          <p:nvPr/>
+        </p:nvSpPr>
+        <p:spPr>
+          <a:xfrm>
+            <a:off x="3383280" y="5422392"/>
+            <a:ext cx="8046720" cy="731520"/>
+          </a:xfrm>
+          <a:prstGeom prst="rect">
+            <a:avLst/>
+          </a:prstGeom>
+          <a:noFill/>
+          <a:ln/>
+        </p:spPr>
+        <p:txBody>
+          <a:bodyPr wrap="square" lIns="0" tIns="0" rIns="0" bIns="0" rtlCol="0" anchor="t"/>
+          <a:lstStyle/>
+          <a:p>
+            <a:pPr indent="0" marL="0">
+              <a:buNone/>
+            </a:pPr>
+            <a:r>
+              <a:rPr lang="en-US" sz="1300" dirty="0">
+                <a:solidFill>
+                  <a:srgbClr val="DCEAEC"/>
+                </a:solidFill>
+                <a:latin typeface="Calibri" pitchFamily="34" charset="0"/>
+                <a:ea typeface="Calibri" pitchFamily="34" charset="-122"/>
+                <a:cs typeface="Calibri" pitchFamily="34" charset="-120"/>
+              </a:rPr>
+              <a:t>Synthetic single-year data, uniform December uplift, engineered engagement, segments on a continuum — sizes directional, conclusions robust on ratios.</a:t>
+            </a:r>
+            <a:endParaRPr lang="en-US" sz="1300" dirty="0"/>
+          </a:p>
+        </p:txBody>
+      </p:sp>
+      <p:sp>
+        <p:nvSpPr>
+          <p:cNvPr id="13" name="Text 11"/>
+          <p:cNvSpPr txBox="1"/>
+          <p:nvPr/>
+        </p:nvSpPr>
+        <p:spPr>
+          <a:xfrm>
+            <a:off x="822960" y="6263640"/>
+            <a:ext cx="10607040" cy="365760"/>
+          </a:xfrm>
+          <a:prstGeom prst="rect">
+            <a:avLst/>
+          </a:prstGeom>
+          <a:noFill/>
+          <a:ln/>
+        </p:spPr>
+        <p:txBody>
+          <a:bodyPr wrap="square" lIns="0" tIns="0" rIns="0" bIns="0" rtlCol="0" anchor="ctr"/>
+          <a:lstStyle/>
+          <a:p>
+            <a:pPr indent="0" marL="0">
+              <a:buNone/>
+            </a:pPr>
+            <a:r>
+              <a:rPr lang="en-US" sz="1300" b="1" i="1" dirty="0">
+                <a:solidFill>
+                  <a:srgbClr val="1FC3A6"/>
+                </a:solidFill>
+                <a:latin typeface="Calibri" pitchFamily="34" charset="0"/>
+                <a:ea typeface="Calibri" pitchFamily="34" charset="-122"/>
+                <a:cs typeface="Calibri" pitchFamily="34" charset="-120"/>
+              </a:rPr>
+              <a:t>One guarantee: wellbeing help, never a credit decision.</a:t>
+            </a:r>
+            <a:endParaRPr lang="en-US" sz="1300" dirty="0"/>
           </a:p>
         </p:txBody>
       </p:sp>
@@ -8254,7 +9954,7 @@
                 <a:ea typeface="Calibri" pitchFamily="34" charset="-122"/>
                 <a:cs typeface="Calibri" pitchFamily="34" charset="-120"/>
               </a:rPr>
-              <a:t>Customers buy more often, not pricier (year-end / Tết prep).</a:t>
+              <a:t>The uplift is uniform: all 14 categories grow +181% to +193% — no single category drives it.</a:t>
             </a:r>
             <a:endParaRPr lang="en-US" sz="1400" dirty="0"/>
           </a:p>
@@ -8337,7 +10037,7 @@
                 <a:ea typeface="Calibri" pitchFamily="34" charset="-122"/>
                 <a:cs typeface="Calibri" pitchFamily="34" charset="-120"/>
               </a:rPr>
-              <a:t>⚠  Source folds two years onto 2025, amplifying December — treat 15% as directional.</a:t>
+              <a:t>⚠  All timestamps are 2025; the uniform uplift looks like a synthetic seasonal multiplier — treat 15% as directional.</a:t>
             </a:r>
             <a:endParaRPr lang="en-US" sz="1000" dirty="0"/>
           </a:p>
@@ -8542,8 +10242,8 @@
         </p:nvSpPr>
         <p:spPr>
           <a:xfrm>
-            <a:off x="457200" y="1600200"/>
-            <a:ext cx="5760720" cy="3200400"/>
+            <a:off x="457200" y="1463040"/>
+            <a:ext cx="11247120" cy="1508760"/>
           </a:xfrm>
           <a:prstGeom prst="rect">
             <a:avLst/>
@@ -8571,7 +10271,7 @@
                 <a:ea typeface="Calibri" pitchFamily="34" charset="-122"/>
                 <a:cs typeface="Calibri" pitchFamily="34" charset="-120"/>
               </a:rPr>
-              <a:t>Stressed (FHS &lt; 40): 28% essential / 72% discretionary.</a:t>
+              <a:t>Stressed (FHS &lt; 40): 72% discretionary vs healthy (FHS ≥ 80): 40% — the mix inverts completely.</a:t>
             </a:r>
             <a:endParaRPr lang="en-US" sz="1400" dirty="0"/>
           </a:p>
@@ -8592,7 +10292,7 @@
                 <a:ea typeface="Calibri" pitchFamily="34" charset="-122"/>
                 <a:cs typeface="Calibri" pitchFamily="34" charset="-120"/>
               </a:rPr>
-              <a:t>Healthy (FHS ≥ 80): 60% essential / 40% discretionary.</a:t>
+              <a:t>It is a gradient, not a threshold artefact: 72% → 64% → 57% → 54% → 49% → 41% across FHS bands; any cutoff pair keeps the direction (FHS&lt;35 vs ≥85: 74% vs 30%).</a:t>
             </a:r>
             <a:endParaRPr lang="en-US" sz="1400" dirty="0"/>
           </a:p>
@@ -8613,49 +10313,7 @@
                 <a:ea typeface="Calibri" pitchFamily="34" charset="-122"/>
                 <a:cs typeface="Calibri" pitchFamily="34" charset="-120"/>
               </a:rPr>
-              <a:t>The mix inverts completely — low health is NOT people scraping by on necessities.</a:t>
-            </a:r>
-            <a:endParaRPr lang="en-US" sz="1400" dirty="0"/>
-          </a:p>
-          <a:p>
-            <a:pPr marL="177800" indent="-177800">
-              <a:spcAft>
-                <a:spcPts val="800"/>
-              </a:spcAft>
-              <a:buSzPct val="100000"/>
-              <a:buChar char="•"/>
-            </a:pPr>
-            <a:r>
-              <a:rPr lang="en-US" sz="1400" dirty="0">
-                <a:solidFill>
-                  <a:srgbClr val="1B2A36"/>
-                </a:solidFill>
-                <a:latin typeface="Calibri" pitchFamily="34" charset="0"/>
-                <a:ea typeface="Calibri" pitchFamily="34" charset="-122"/>
-                <a:cs typeface="Calibri" pitchFamily="34" charset="-120"/>
-              </a:rPr>
-              <a:t>Highest-leverage help = budgeting visibility on discretionary spend, not credit restriction.</a:t>
-            </a:r>
-            <a:endParaRPr lang="en-US" sz="1400" dirty="0"/>
-          </a:p>
-          <a:p>
-            <a:pPr marL="177800" indent="-177800">
-              <a:spcAft>
-                <a:spcPts val="800"/>
-              </a:spcAft>
-              <a:buSzPct val="100000"/>
-              <a:buChar char="•"/>
-            </a:pPr>
-            <a:r>
-              <a:rPr lang="en-US" sz="1400" dirty="0">
-                <a:solidFill>
-                  <a:srgbClr val="1B2A36"/>
-                </a:solidFill>
-                <a:latin typeface="Calibri" pitchFamily="34" charset="0"/>
-                <a:ea typeface="Calibri" pitchFamily="34" charset="-122"/>
-                <a:cs typeface="Calibri" pitchFamily="34" charset="-120"/>
-              </a:rPr>
-              <a:t>This single contrast anchors segmentation (Task 4) and recommendations (Task 5).</a:t>
+              <a:t>Highest-leverage help = budgeting visibility on discretionary spend, not credit restriction. This contrast anchors Tasks 4 and 5.</a:t>
             </a:r>
             <a:endParaRPr lang="en-US" sz="1400" dirty="0"/>
           </a:p>
@@ -8676,117 +10334,40 @@
         </p:blipFill>
         <p:spPr>
           <a:xfrm>
-            <a:off x="6446520" y="1554480"/>
-            <a:ext cx="5303520" cy="4206240"/>
+            <a:off x="502920" y="3063240"/>
+            <a:ext cx="5440680" cy="3200400"/>
           </a:xfrm>
           <a:prstGeom prst="rect">
             <a:avLst/>
           </a:prstGeom>
         </p:spPr>
       </p:pic>
-      <p:sp>
-        <p:nvSpPr>
-          <p:cNvPr id="6" name="Shape 3"/>
-          <p:cNvSpPr/>
-          <p:nvPr/>
-        </p:nvSpPr>
-        <p:spPr>
-          <a:xfrm>
-            <a:off x="457200" y="5029200"/>
-            <a:ext cx="3383280" cy="1097280"/>
-          </a:xfrm>
-          <a:prstGeom prst="roundRect">
-            <a:avLst>
-              <a:gd name="adj" fmla="val 6667"/>
-            </a:avLst>
-          </a:prstGeom>
-          <a:solidFill>
-            <a:srgbClr val="12435E"/>
-          </a:solidFill>
-          <a:ln/>
-        </p:spPr>
-      </p:sp>
-      <p:sp>
-        <p:nvSpPr>
-          <p:cNvPr id="7" name="Text 4"/>
-          <p:cNvSpPr txBox="1"/>
-          <p:nvPr/>
-        </p:nvSpPr>
-        <p:spPr>
-          <a:xfrm>
-            <a:off x="457200" y="5138928"/>
-            <a:ext cx="3383280" cy="658368"/>
-          </a:xfrm>
-          <a:prstGeom prst="rect">
-            <a:avLst/>
-          </a:prstGeom>
-          <a:noFill/>
-          <a:ln/>
-        </p:spPr>
-        <p:txBody>
-          <a:bodyPr wrap="square" lIns="0" tIns="0" rIns="0" bIns="0" rtlCol="0" anchor="ctr"/>
-          <a:lstStyle/>
-          <a:p>
-            <a:pPr algn="ctr" indent="0" marL="0">
-              <a:buNone/>
-            </a:pPr>
-            <a:r>
-              <a:rPr lang="en-US" sz="2800" b="1" dirty="0">
-                <a:solidFill>
-                  <a:srgbClr val="1FC3A6"/>
-                </a:solidFill>
-                <a:latin typeface="Cambria" pitchFamily="34" charset="0"/>
-                <a:ea typeface="Cambria" pitchFamily="34" charset="-122"/>
-                <a:cs typeface="Cambria" pitchFamily="34" charset="-120"/>
-              </a:rPr>
-              <a:t>72% vs 40%</a:t>
-            </a:r>
-            <a:endParaRPr lang="en-US" sz="2800" dirty="0"/>
-          </a:p>
-        </p:txBody>
-      </p:sp>
-      <p:sp>
-        <p:nvSpPr>
-          <p:cNvPr id="8" name="Text 5"/>
-          <p:cNvSpPr txBox="1"/>
-          <p:nvPr/>
-        </p:nvSpPr>
-        <p:spPr>
-          <a:xfrm>
-            <a:off x="457200" y="5779008"/>
-            <a:ext cx="3383280" cy="320040"/>
-          </a:xfrm>
-          <a:prstGeom prst="rect">
-            <a:avLst/>
-          </a:prstGeom>
-          <a:noFill/>
-          <a:ln/>
-        </p:spPr>
-        <p:txBody>
-          <a:bodyPr wrap="square" lIns="0" tIns="0" rIns="0" bIns="0" rtlCol="0" anchor="ctr"/>
-          <a:lstStyle/>
-          <a:p>
-            <a:pPr algn="ctr" indent="0" marL="0">
-              <a:buNone/>
-            </a:pPr>
-            <a:r>
-              <a:rPr lang="en-US" sz="1100" dirty="0">
-                <a:solidFill>
-                  <a:srgbClr val="FFFFFF"/>
-                </a:solidFill>
-                <a:latin typeface="Calibri" pitchFamily="34" charset="0"/>
-                <a:ea typeface="Calibri" pitchFamily="34" charset="-122"/>
-                <a:cs typeface="Calibri" pitchFamily="34" charset="-120"/>
-              </a:rPr>
-              <a:t>discretionary: stressed vs healthy</a:t>
-            </a:r>
-            <a:endParaRPr lang="en-US" sz="1100" dirty="0"/>
-          </a:p>
-        </p:txBody>
-      </p:sp>
-      <p:sp>
-        <p:nvSpPr>
-          <p:cNvPr id="9" name="Text 6"/>
+      <p:pic>
+        <p:nvPicPr>
+          <p:cNvPr id="6" name="Image 1" descr="D:\BI10GroupYAPPERS\outputs\figures\t1_discretionary_gradient.png">    </p:cNvPr>
+          <p:cNvPicPr>
+            <a:picLocks noChangeAspect="1"/>
+          </p:cNvPicPr>
+          <p:nvPr/>
+        </p:nvPicPr>
+        <p:blipFill>
+          <a:blip r:embed="rId2"/>
+          <a:srcRect l="0" r="0" t="0" b="0"/>
+          <a:stretch/>
+        </p:blipFill>
+        <p:spPr>
+          <a:xfrm>
+            <a:off x="6263640" y="3063240"/>
+            <a:ext cx="5440680" cy="3200400"/>
+          </a:xfrm>
+          <a:prstGeom prst="rect">
+            <a:avLst/>
+          </a:prstGeom>
+        </p:spPr>
+      </p:pic>
+      <p:sp>
+        <p:nvSpPr>
+          <p:cNvPr id="7" name="Text 3"/>
           <p:cNvSpPr txBox="1"/>
           <p:nvPr/>
         </p:nvSpPr>
@@ -8825,7 +10406,7 @@
       </p:sp>
       <p:sp>
         <p:nvSpPr>
-          <p:cNvPr id="10" name="Text 7"/>
+          <p:cNvPr id="8" name="Text 4"/>
           <p:cNvSpPr txBox="1"/>
           <p:nvPr/>
         </p:nvSpPr>
@@ -8969,7 +10550,7 @@
                 <a:ea typeface="Cambria" pitchFamily="34" charset="-122"/>
                 <a:cs typeface="Cambria" pitchFamily="34" charset="-120"/>
               </a:rPr>
-              <a:t>Where the signal is NOT: geography &amp; age are flat</a:t>
+              <a:t>Where the signal is NOT: age is flat; categories are habits</a:t>
             </a:r>
             <a:endParaRPr lang="en-US" sz="2700" dirty="0"/>
           </a:p>
@@ -9012,7 +10593,7 @@
                 <a:ea typeface="Calibri" pitchFamily="34" charset="-122"/>
                 <a:cs typeface="Calibri" pitchFamily="34" charset="-120"/>
               </a:rPr>
-              <a:t>No regional digital divide — every high-spend province sits at ~41% digital (±0.5pp); province is not a lever.</a:t>
+              <a:t>Two shopping rhythms: Fuel = frequent touchpoint (1.59M ticket, bought by 96.8% of consumers); Groceries = 1.8× larger basket, bought by 99.3%.</a:t>
             </a:r>
             <a:endParaRPr lang="en-US" sz="1400" dirty="0"/>
           </a:p>
@@ -9033,7 +10614,7 @@
                 <a:ea typeface="Calibri" pitchFamily="34" charset="-122"/>
                 <a:cs typeface="Calibri" pitchFamily="34" charset="-120"/>
               </a:rPr>
-              <a:t>Two shopping rhythms: Fuel = frequent touchpoint (1.59M ticket); Groceries = 1.8× larger stock-up basket.</a:t>
+              <a:t>25–34 has the lowest point estimate (FHS 65.8, highest spend/income 0.716) — but bootstrap 95% CIs of all six age cohorts overlap (65.8–67.0).</a:t>
             </a:r>
             <a:endParaRPr lang="en-US" sz="1400" dirty="0"/>
           </a:p>
@@ -9054,7 +10635,7 @@
                 <a:ea typeface="Calibri" pitchFamily="34" charset="-122"/>
                 <a:cs typeface="Calibri" pitchFamily="34" charset="-120"/>
               </a:rPr>
-              <a:t>25–34 is the vulnerability hotspot (lowest FHS 65.8, highest spend/income 0.716) — but age spreads only 65.8–67.0, a weak differentiator. Target behavioural ratios, not the map or birth year.</a:t>
+              <a:t>Age does not separate financial health → target behavioural ratios, not birth year.</a:t>
             </a:r>
             <a:endParaRPr lang="en-US" sz="1400" dirty="0"/>
           </a:p>
@@ -9249,7 +10830,7 @@
                 <a:ea typeface="Calibri" pitchFamily="34" charset="-122"/>
                 <a:cs typeface="Calibri" pitchFamily="34" charset="-120"/>
               </a:rPr>
-              <a:t>TASK 2 · FINANCIAL HEALTH</a:t>
+              <a:t>TASK 1 · EDA</a:t>
             </a:r>
             <a:endParaRPr lang="en-US" sz="1100" dirty="0"/>
           </a:p>
@@ -9291,7 +10872,7 @@
                 <a:ea typeface="Cambria" pitchFamily="34" charset="-122"/>
                 <a:cs typeface="Cambria" pitchFamily="34" charset="-120"/>
               </a:rPr>
-              <a:t>Health is a tight band; distress is episodic, never chronic</a:t>
+              <a:t>No regional digital divide: high-spend provinces mirror the nation</a:t>
             </a:r>
             <a:endParaRPr lang="en-US" sz="2700" dirty="0"/>
           </a:p>
@@ -9334,7 +10915,7 @@
                 <a:ea typeface="Calibri" pitchFamily="34" charset="-122"/>
                 <a:cs typeface="Calibri" pitchFamily="34" charset="-120"/>
               </a:rPr>
-              <a:t>Consumer-level FHS: mean 66.3, range 42–81 — a narrow band with a mild low tail.</a:t>
+              <a:t>5 high-spend provinces with below-average digital share: Ha Noi, Dong Nai, Lam Dong, Hung Yen, Hai Phong.</a:t>
             </a:r>
             <a:endParaRPr lang="en-US" sz="1400" dirty="0"/>
           </a:p>
@@ -9355,7 +10936,7 @@
                 <a:ea typeface="Calibri" pitchFamily="34" charset="-122"/>
                 <a:cs typeface="Calibri" pitchFamily="34" charset="-120"/>
               </a:rPr>
-              <a:t>Stressed months only 0.9%; 0 of 999 consumers have a 12-month mean below 40.</a:t>
+              <a:t>POS 58.9–59.3% of transactions vs 58.8% nationally; QR ~20%, E-com ~8.5%, Mobile ~7.5%, Recurring ~5%.</a:t>
             </a:r>
             <a:endParaRPr lang="en-US" sz="1400" dirty="0"/>
           </a:p>
@@ -9376,7 +10957,7 @@
                 <a:ea typeface="Calibri" pitchFamily="34" charset="-122"/>
                 <a:cs typeface="Calibri" pitchFamily="34" charset="-120"/>
               </a:rPr>
-              <a:t>Distress is episodic — healthy people dip in specific months (Feb 73.6 → Dec 54.2).</a:t>
+              <a:t>Largest digital gap: −0.46pp (Dong Nai); digital value share 40.9–41.5% vs 41.5%.</a:t>
             </a:r>
             <a:endParaRPr lang="en-US" sz="1400" dirty="0"/>
           </a:p>
@@ -9397,7 +10978,7 @@
                 <a:ea typeface="Calibri" pitchFamily="34" charset="-122"/>
                 <a:cs typeface="Calibri" pitchFamily="34" charset="-120"/>
               </a:rPr>
-              <a:t>Interventions must be event-triggered on the current month, not a static risk list.</a:t>
+              <a:t>The gap is real but commercially negligible → province is not a lever for digital adoption.</a:t>
             </a:r>
             <a:endParaRPr lang="en-US" sz="1400" dirty="0"/>
           </a:p>
@@ -9405,7 +10986,7 @@
       </p:sp>
       <p:pic>
         <p:nvPicPr>
-          <p:cNvPr id="5" name="Image 0" descr="D:\BI10GroupYAPPERS\outputs\figures\t2_fhs_distribution.png">    </p:cNvPr>
+          <p:cNvPr id="5" name="Image 0" descr="D:\BI10GroupYAPPERS\outputs\figures\t1_province_channel.png">    </p:cNvPr>
           <p:cNvPicPr>
             <a:picLocks noChangeAspect="1"/>
           </p:cNvPicPr>
@@ -9428,7 +11009,107 @@
       </p:pic>
       <p:sp>
         <p:nvSpPr>
-          <p:cNvPr id="6" name="Text 3"/>
+          <p:cNvPr id="6" name="Shape 3"/>
+          <p:cNvSpPr/>
+          <p:nvPr/>
+        </p:nvSpPr>
+        <p:spPr>
+          <a:xfrm>
+            <a:off x="457200" y="5029200"/>
+            <a:ext cx="3383280" cy="1097280"/>
+          </a:xfrm>
+          <a:prstGeom prst="roundRect">
+            <a:avLst>
+              <a:gd name="adj" fmla="val 6667"/>
+            </a:avLst>
+          </a:prstGeom>
+          <a:solidFill>
+            <a:srgbClr val="12435E"/>
+          </a:solidFill>
+          <a:ln/>
+        </p:spPr>
+      </p:sp>
+      <p:sp>
+        <p:nvSpPr>
+          <p:cNvPr id="7" name="Text 4"/>
+          <p:cNvSpPr txBox="1"/>
+          <p:nvPr/>
+        </p:nvSpPr>
+        <p:spPr>
+          <a:xfrm>
+            <a:off x="457200" y="5138928"/>
+            <a:ext cx="3383280" cy="658368"/>
+          </a:xfrm>
+          <a:prstGeom prst="rect">
+            <a:avLst/>
+          </a:prstGeom>
+          <a:noFill/>
+          <a:ln/>
+        </p:spPr>
+        <p:txBody>
+          <a:bodyPr wrap="square" lIns="0" tIns="0" rIns="0" bIns="0" rtlCol="0" anchor="ctr"/>
+          <a:lstStyle/>
+          <a:p>
+            <a:pPr algn="ctr" indent="0" marL="0">
+              <a:buNone/>
+            </a:pPr>
+            <a:r>
+              <a:rPr lang="en-US" sz="2800" b="1" dirty="0">
+                <a:solidFill>
+                  <a:srgbClr val="1FC3A6"/>
+                </a:solidFill>
+                <a:latin typeface="Cambria" pitchFamily="34" charset="0"/>
+                <a:ea typeface="Cambria" pitchFamily="34" charset="-122"/>
+                <a:cs typeface="Cambria" pitchFamily="34" charset="-120"/>
+              </a:rPr>
+              <a:t>≤ 0.46pp</a:t>
+            </a:r>
+            <a:endParaRPr lang="en-US" sz="2800" dirty="0"/>
+          </a:p>
+        </p:txBody>
+      </p:sp>
+      <p:sp>
+        <p:nvSpPr>
+          <p:cNvPr id="8" name="Text 5"/>
+          <p:cNvSpPr txBox="1"/>
+          <p:nvPr/>
+        </p:nvSpPr>
+        <p:spPr>
+          <a:xfrm>
+            <a:off x="457200" y="5779008"/>
+            <a:ext cx="3383280" cy="320040"/>
+          </a:xfrm>
+          <a:prstGeom prst="rect">
+            <a:avLst/>
+          </a:prstGeom>
+          <a:noFill/>
+          <a:ln/>
+        </p:spPr>
+        <p:txBody>
+          <a:bodyPr wrap="square" lIns="0" tIns="0" rIns="0" bIns="0" rtlCol="0" anchor="ctr"/>
+          <a:lstStyle/>
+          <a:p>
+            <a:pPr algn="ctr" indent="0" marL="0">
+              <a:buNone/>
+            </a:pPr>
+            <a:r>
+              <a:rPr lang="en-US" sz="1100" dirty="0">
+                <a:solidFill>
+                  <a:srgbClr val="FFFFFF"/>
+                </a:solidFill>
+                <a:latin typeface="Calibri" pitchFamily="34" charset="0"/>
+                <a:ea typeface="Calibri" pitchFamily="34" charset="-122"/>
+                <a:cs typeface="Calibri" pitchFamily="34" charset="-120"/>
+              </a:rPr>
+              <a:t>largest digital-share gap</a:t>
+            </a:r>
+            <a:endParaRPr lang="en-US" sz="1100" dirty="0"/>
+          </a:p>
+        </p:txBody>
+      </p:sp>
+      <p:sp>
+        <p:nvSpPr>
+          <p:cNvPr id="9" name="Text 6"/>
           <p:cNvSpPr txBox="1"/>
           <p:nvPr/>
         </p:nvSpPr>
@@ -9467,7 +11148,7 @@
       </p:sp>
       <p:sp>
         <p:nvSpPr>
-          <p:cNvPr id="7" name="Text 4"/>
+          <p:cNvPr id="10" name="Text 7"/>
           <p:cNvSpPr txBox="1"/>
           <p:nvPr/>
         </p:nvSpPr>
@@ -9611,7 +11292,7 @@
                 <a:ea typeface="Cambria" pitchFamily="34" charset="-122"/>
                 <a:cs typeface="Cambria" pitchFamily="34" charset="-120"/>
               </a:rPr>
-              <a:t>Low health is an overspend story</a:t>
+              <a:t>Health is a tight band; distress is episodic, never chronic</a:t>
             </a:r>
             <a:endParaRPr lang="en-US" sz="2700" dirty="0"/>
           </a:p>
@@ -9654,7 +11335,7 @@
                 <a:ea typeface="Calibri" pitchFamily="34" charset="-122"/>
                 <a:cs typeface="Calibri" pitchFamily="34" charset="-120"/>
               </a:rPr>
-              <a:t>Top correlates: spend-to-income −0.90, credit-utilization −0.86, volatility −0.50.</a:t>
+              <a:t>Consumer-level FHS: mean 66.3, range 42–81 — a narrow band with a mild low tail.</a:t>
             </a:r>
             <a:endParaRPr lang="en-US" sz="1400" dirty="0"/>
           </a:p>
@@ -9675,7 +11356,7 @@
                 <a:ea typeface="Calibri" pitchFamily="34" charset="-122"/>
                 <a:cs typeface="Calibri" pitchFamily="34" charset="-120"/>
               </a:rPr>
-              <a:t>Stressed vs healthy months: spend/income 2.10 vs 0.29; util 0.58 vs 0.08.</a:t>
+              <a:t>Stressed months only 0.9%; 0 of 999 consumers have a 12-month mean below 40.</a:t>
             </a:r>
             <a:endParaRPr lang="en-US" sz="1400" dirty="0"/>
           </a:p>
@@ -9696,7 +11377,7 @@
                 <a:ea typeface="Calibri" pitchFamily="34" charset="-122"/>
                 <a:cs typeface="Calibri" pitchFamily="34" charset="-120"/>
               </a:rPr>
-              <a:t>Counter-intuitive: stressed months are MORE engaged (81.1 vs 72.7, r −0.30).</a:t>
+              <a:t>Distress is episodic — healthy people dip in specific months (Feb 73.6 → Dec 54.2).</a:t>
             </a:r>
             <a:endParaRPr lang="en-US" sz="1400" dirty="0"/>
           </a:p>
@@ -9717,7 +11398,7 @@
                 <a:ea typeface="Calibri" pitchFamily="34" charset="-122"/>
                 <a:cs typeface="Calibri" pitchFamily="34" charset="-120"/>
               </a:rPr>
-              <a:t>Demographics add nothing — score &amp; alert on two ratios, reach via the channel they use.</a:t>
+              <a:t>Interventions must be event-triggered on the current month, not a static risk list.</a:t>
             </a:r>
             <a:endParaRPr lang="en-US" sz="1400" dirty="0"/>
           </a:p>
@@ -9725,7 +11406,7 @@
       </p:sp>
       <p:pic>
         <p:nvPicPr>
-          <p:cNvPr id="5" name="Image 0" descr="D:\BI10GroupYAPPERS\outputs\figures\t2_low_health_drivers.png">    </p:cNvPr>
+          <p:cNvPr id="5" name="Image 0" descr="D:\BI10GroupYAPPERS\outputs\figures\t2_fhs_distribution.png">    </p:cNvPr>
           <p:cNvPicPr>
             <a:picLocks noChangeAspect="1"/>
           </p:cNvPicPr>
@@ -9754,45 +11435,6 @@
         </p:nvSpPr>
         <p:spPr>
           <a:xfrm>
-            <a:off x="6446520" y="5852160"/>
-            <a:ext cx="5303520" cy="548640"/>
-          </a:xfrm>
-          <a:prstGeom prst="rect">
-            <a:avLst/>
-          </a:prstGeom>
-          <a:noFill/>
-          <a:ln/>
-        </p:spPr>
-        <p:txBody>
-          <a:bodyPr wrap="square" lIns="0" tIns="0" rIns="0" bIns="0" rtlCol="0" anchor="t"/>
-          <a:lstStyle/>
-          <a:p>
-            <a:pPr indent="0" marL="0">
-              <a:buNone/>
-            </a:pPr>
-            <a:r>
-              <a:rPr lang="en-US" sz="1000" i="1" dirty="0">
-                <a:solidFill>
-                  <a:srgbClr val="5F7180"/>
-                </a:solidFill>
-                <a:latin typeface="Calibri" pitchFamily="34" charset="0"/>
-                <a:ea typeface="Calibri" pitchFamily="34" charset="-122"/>
-                <a:cs typeface="Calibri" pitchFamily="34" charset="-120"/>
-              </a:rPr>
-              <a:t>⚠  FHS and essential/discretionary ratios share spend fields — directional, not causal.</a:t>
-            </a:r>
-            <a:endParaRPr lang="en-US" sz="1000" dirty="0"/>
-          </a:p>
-        </p:txBody>
-      </p:sp>
-      <p:sp>
-        <p:nvSpPr>
-          <p:cNvPr id="7" name="Text 4"/>
-          <p:cNvSpPr txBox="1"/>
-          <p:nvPr/>
-        </p:nvSpPr>
-        <p:spPr>
-          <a:xfrm>
             <a:off x="457200" y="6473952"/>
             <a:ext cx="5486400" cy="274320"/>
           </a:xfrm>
@@ -9826,7 +11468,7 @@
       </p:sp>
       <p:sp>
         <p:nvSpPr>
-          <p:cNvPr id="8" name="Text 5"/>
+          <p:cNvPr id="7" name="Text 4"/>
           <p:cNvSpPr txBox="1"/>
           <p:nvPr/>
         </p:nvSpPr>

</xml_diff>

<commit_message>
Deck: restore 2x2 cross-check and preprocessed-dataset note; align reminder target in notebook
</commit_message>
<xml_diff>
--- a/draft/YAPPERS_BI10_R01.pptx
+++ b/draft/YAPPERS_BI10_R01.pptx
@@ -5269,7 +5269,7 @@
                 <a:ea typeface="Calibri" pitchFamily="34" charset="-122"/>
                 <a:cs typeface="Calibri" pitchFamily="34" charset="-120"/>
               </a:rPr>
-              <a:t>Preprocessing: 10,992 consumer-months → 999 consumers (yearly mean of each ratio = typical monthly profile); 0 nulls after aggregation; raw VND excluded.</a:t>
+              <a:t>Preprocessing: 10,992 consumer-months → 999 consumers (yearly mean of each ratio = typical monthly profile); 0 nulls after aggregation; raw VND excluded. The preprocessed dataset (task4_features.csv) and its data dictionary are in the submission ZIP.</a:t>
             </a:r>
             <a:endParaRPr lang="en-US" sz="1200" dirty="0"/>
           </a:p>
@@ -5990,6 +5990,27 @@
                 <a:cs typeface="Calibri" pitchFamily="34" charset="-120"/>
               </a:rPr>
               <a:t>Stability: 20 random seeds → ARI 0.988; 80% bootstrap × 50 → ARI 0.911. Alternative GMM: ARI 0.26 — Emerging Digital identical, the three large segments form one continuum (hence silhouette 0.251).</a:t>
+            </a:r>
+            <a:endParaRPr lang="en-US" sz="1200" dirty="0"/>
+          </a:p>
+          <a:p>
+            <a:pPr marL="177800" indent="-177800">
+              <a:spcAft>
+                <a:spcPts val="700"/>
+              </a:spcAft>
+              <a:buSzPct val="100000"/>
+              <a:buChar char="•"/>
+            </a:pPr>
+            <a:r>
+              <a:rPr lang="en-US" sz="1200" dirty="0">
+                <a:solidFill>
+                  <a:srgbClr val="1B2A36"/>
+                </a:solidFill>
+                <a:latin typeface="Calibri" pitchFamily="34" charset="0"/>
+                <a:ea typeface="Calibri" pitchFamily="34" charset="-122"/>
+                <a:cs typeface="Calibri" pitchFamily="34" charset="-120"/>
+              </a:rPr>
+              <a:t>Rule-based cross-check (2×2 median split of health × engagement): 344 of 351 Healthy and 273 of 302 Stretched customers fall in the matching halves.</a:t>
             </a:r>
             <a:endParaRPr lang="en-US" sz="1200" dirty="0"/>
           </a:p>

</xml_diff>

<commit_message>
Task 1 Q3: add top-performing provinces (brief deliverable 3)
</commit_message>
<xml_diff>
--- a/draft/YAPPERS_BI10_R01.pptx
+++ b/draft/YAPPERS_BI10_R01.pptx
@@ -14217,6 +14217,27 @@
                 <a:ea typeface="Calibri" pitchFamily="34" charset="-122"/>
                 <a:cs typeface="Calibri" pitchFamily="34" charset="-120"/>
               </a:rPr>
+              <a:t>Top performers: HCMC leads spend (13.6% of the national total) at 41.3% digital; highest digital share Cao Bang 43.1% (0.5% of spend), lowest Quang Ngai 39.2% — all 34 provinces sit within 3.9pp.</a:t>
+            </a:r>
+            <a:endParaRPr lang="en-US" sz="1300" dirty="0"/>
+          </a:p>
+          <a:p>
+            <a:pPr marL="177800" indent="-177800">
+              <a:spcAft>
+                <a:spcPts val="700"/>
+              </a:spcAft>
+              <a:buSzPct val="100000"/>
+              <a:buChar char="•"/>
+            </a:pPr>
+            <a:r>
+              <a:rPr lang="en-US" sz="1300" dirty="0">
+                <a:solidFill>
+                  <a:srgbClr val="1B2A36"/>
+                </a:solidFill>
+                <a:latin typeface="Calibri" pitchFamily="34" charset="0"/>
+                <a:ea typeface="Calibri" pitchFamily="34" charset="-122"/>
+                <a:cs typeface="Calibri" pitchFamily="34" charset="-120"/>
+              </a:rPr>
               <a:t>The gap is statistically real but commercially negligible → province is not a lever for digital adoption; behaviour is.</a:t>
             </a:r>
             <a:endParaRPr lang="en-US" sz="1300" dirty="0"/>

</xml_diff>

<commit_message>
Deck: order Task 1 and Task 2 slides as in the brief (Q3 before Q4-Q5, D3 before D4)
</commit_message>
<xml_diff>
--- a/draft/YAPPERS_BI10_R01.pptx
+++ b/draft/YAPPERS_BI10_R01.pptx
@@ -699,7 +699,7 @@
           <a:p>
             <a:r>
               <a:rPr lang="en-US" dirty="0"/>
-              <a:t>More than half of every stress episode happens to someone we can reach in-app — and we know when.</a:t>
+              <a:t>Deliverable 3 — the one demographic gap is really a spending gap.</a:t>
             </a:r>
             <a:endParaRPr lang="en-US" dirty="0"/>
           </a:p>
@@ -787,7 +787,7 @@
           <a:p>
             <a:r>
               <a:rPr lang="en-US" dirty="0"/>
-              <a:t>Deliverable 3 — the one demographic gap is really a spending gap.</a:t>
+              <a:t>More than half of every stress episode happens to someone we can reach in-app — and we know when.</a:t>
             </a:r>
             <a:endParaRPr lang="en-US" dirty="0"/>
           </a:p>
@@ -2195,7 +2195,7 @@
           <a:p>
             <a:r>
               <a:rPr lang="en-US" dirty="0"/>
-              <a:t>Answer Q4 and Q5 exactly as asked, then show the honest limit (CI overlap).</a:t>
+              <a:t>Q3 asked for the channel breakdown — every hub has the national mix.</a:t>
             </a:r>
             <a:endParaRPr lang="en-US" dirty="0"/>
           </a:p>
@@ -2283,7 +2283,7 @@
           <a:p>
             <a:r>
               <a:rPr lang="en-US" dirty="0"/>
-              <a:t>Q3 asked for the channel breakdown — every hub has the national mix.</a:t>
+              <a:t>Answer Q4 and Q5 exactly as asked, then show the honest limit (CI overlap).</a:t>
             </a:r>
             <a:endParaRPr lang="en-US" dirty="0"/>
           </a:p>
@@ -3363,7 +3363,7 @@
                 <a:ea typeface="Calibri" pitchFamily="34" charset="-122"/>
                 <a:cs typeface="Calibri" pitchFamily="34" charset="-120"/>
               </a:rPr>
-              <a:t>TASK 2 · FINANCIAL HEALTH · D4</a:t>
+              <a:t>TASK 2 · FINANCIAL HEALTH · D3</a:t>
             </a:r>
             <a:endParaRPr lang="en-US" sz="1100" dirty="0"/>
           </a:p>
@@ -3405,7 +3405,7 @@
                 <a:ea typeface="Cambria" pitchFamily="34" charset="-122"/>
                 <a:cs typeface="Cambria" pitchFamily="34" charset="-120"/>
               </a:rPr>
-              <a:t>The "Stressed but Engaged" crossover — and when to reach it</a:t>
+              <a:t>Who differs? Province and age barely; occupation through spending</a:t>
             </a:r>
             <a:endParaRPr lang="en-US" sz="2700" dirty="0"/>
           </a:p>
@@ -3420,7 +3420,7 @@
         <p:spPr>
           <a:xfrm>
             <a:off x="457200" y="1417320"/>
-            <a:ext cx="11247120" cy="1600200"/>
+            <a:ext cx="11247120" cy="1463040"/>
           </a:xfrm>
           <a:prstGeom prst="rect">
             <a:avLst/>
@@ -3448,7 +3448,7 @@
                 <a:ea typeface="Calibri" pitchFamily="34" charset="-122"/>
                 <a:cs typeface="Calibri" pitchFamily="34" charset="-120"/>
               </a:rPr>
-              <a:t>Reproducible rule (consumer-month): financial_health_score &lt; 40 AND engagement_score ≥ p75 (81.4) → 43 consumers / 49 months = 52% of ALL stress episodes. Robust: p70 / p80 give 44 / 41 consumers (53% / 48%).</a:t>
+              <a:t>Province: 22 of 27 provinces (≥ 15 consumers) have a 95% CI containing the national mean 66.3 (extremes Thai Nguyen 63.0, HCMC 67.6). Age: all six cohort CIs overlap (65.8–67.0).</a:t>
             </a:r>
             <a:endParaRPr lang="en-US" sz="1250" dirty="0"/>
           </a:p>
@@ -3469,7 +3469,7 @@
                 <a:ea typeface="Calibri" pitchFamily="34" charset="-122"/>
                 <a:cs typeface="Calibri" pitchFamily="34" charset="-120"/>
               </a:rPr>
-              <a:t>Profile: spend/income 1.89, credit-utilization 0.55, online share 0.49 (2× national) — active, digital, over-extended.</a:t>
+              <a:t>Occupation (396 raw titles → 8 keyword groups): Engineering/science/IT 69.1 (n = 229), Business/finance 68.7 (126) vs Office/public 64.5 (443), Manual/trades 62.9 (23) — a ~6-pt spread that mirrors spend-to-income (0.60 vs 0.76–0.79).</a:t>
             </a:r>
             <a:endParaRPr lang="en-US" sz="1250" dirty="0"/>
           </a:p>
@@ -3490,7 +3490,7 @@
                 <a:ea typeface="Calibri" pitchFamily="34" charset="-122"/>
                 <a:cs typeface="Calibri" pitchFamily="34" charset="-120"/>
               </a:rPr>
-              <a:t>Timing (transactions): stressed months put 23.5% of spend value into 22–23h vs 8.3% (bigger late tickets, not more: count 11.6% vs 9.7%); Sunday + Monday = 42% vs 34% → alerts Sun–Mon evenings, before 22:00.</a:t>
+              <a:t>Demographics act through the overspend ratio → target the ratio, never the group (fairness).</a:t>
             </a:r>
             <a:endParaRPr lang="en-US" sz="1250" dirty="0"/>
           </a:p>
@@ -3498,7 +3498,7 @@
       </p:sp>
       <p:pic>
         <p:nvPicPr>
-          <p:cNvPr id="5" name="Image 0" descr="D:\BI10GroupYAPPERS\outputs\figures\t2_crossover.png">    </p:cNvPr>
+          <p:cNvPr id="5" name="Image 0" descr="D:\BI10GroupYAPPERS\outputs\figures\t2_demographics.png">    </p:cNvPr>
           <p:cNvPicPr>
             <a:picLocks noChangeAspect="1"/>
           </p:cNvPicPr>
@@ -3511,47 +3511,24 @@
         </p:blipFill>
         <p:spPr>
           <a:xfrm>
-            <a:off x="502920" y="3017520"/>
-            <a:ext cx="5440680" cy="3063240"/>
+            <a:off x="457200" y="2926080"/>
+            <a:ext cx="11247120" cy="3154680"/>
           </a:xfrm>
           <a:prstGeom prst="rect">
             <a:avLst/>
           </a:prstGeom>
         </p:spPr>
       </p:pic>
-      <p:pic>
-        <p:nvPicPr>
-          <p:cNvPr id="6" name="Image 1" descr="D:\BI10GroupYAPPERS\outputs\figures\t2_timing.png">    </p:cNvPr>
-          <p:cNvPicPr>
-            <a:picLocks noChangeAspect="1"/>
-          </p:cNvPicPr>
-          <p:nvPr/>
-        </p:nvPicPr>
-        <p:blipFill>
-          <a:blip r:embed="rId2"/>
-          <a:srcRect l="0" r="0" t="0" b="0"/>
-          <a:stretch/>
-        </p:blipFill>
-        <p:spPr>
-          <a:xfrm>
-            <a:off x="6263640" y="3017520"/>
-            <a:ext cx="5440680" cy="3063240"/>
-          </a:xfrm>
-          <a:prstGeom prst="rect">
-            <a:avLst/>
-          </a:prstGeom>
-        </p:spPr>
-      </p:pic>
-      <p:sp>
-        <p:nvSpPr>
-          <p:cNvPr id="7" name="Text 3"/>
-          <p:cNvSpPr txBox="1"/>
-          <p:nvPr/>
-        </p:nvSpPr>
-        <p:spPr>
-          <a:xfrm>
-            <a:off x="502920" y="6144768"/>
-            <a:ext cx="11201400" cy="256032"/>
+      <p:sp>
+        <p:nvSpPr>
+          <p:cNvPr id="6" name="Text 3"/>
+          <p:cNvSpPr txBox="1"/>
+          <p:nvPr/>
+        </p:nvSpPr>
+        <p:spPr>
+          <a:xfrm>
+            <a:off x="457200" y="6144768"/>
+            <a:ext cx="11247120" cy="256032"/>
           </a:xfrm>
           <a:prstGeom prst="rect">
             <a:avLst/>
@@ -3575,7 +3552,7 @@
                 <a:ea typeface="Calibri" pitchFamily="34" charset="-122"/>
                 <a:cs typeface="Calibri" pitchFamily="34" charset="-120"/>
               </a:rPr>
-              <a:t>Source: consumer_financial_health_engagement_2025 — 10,992 consumer-months, 999 consumers, 2025. Timing: Source: transactions file joined to the consumer-month file on consumer_id + month.</a:t>
+              <a:t>Source: consumer_financial_health_engagement_2025 — 10,992 consumer-months, 999 consumers, 2025.</a:t>
             </a:r>
             <a:endParaRPr lang="en-US" sz="850" dirty="0"/>
           </a:p>
@@ -3583,7 +3560,7 @@
       </p:sp>
       <p:sp>
         <p:nvSpPr>
-          <p:cNvPr id="8" name="Text 4"/>
+          <p:cNvPr id="7" name="Text 4"/>
           <p:cNvSpPr txBox="1"/>
           <p:nvPr/>
         </p:nvSpPr>
@@ -3622,7 +3599,7 @@
       </p:sp>
       <p:sp>
         <p:nvSpPr>
-          <p:cNvPr id="9" name="Text 5"/>
+          <p:cNvPr id="8" name="Text 5"/>
           <p:cNvSpPr txBox="1"/>
           <p:nvPr/>
         </p:nvSpPr>
@@ -3724,7 +3701,7 @@
                 <a:ea typeface="Calibri" pitchFamily="34" charset="-122"/>
                 <a:cs typeface="Calibri" pitchFamily="34" charset="-120"/>
               </a:rPr>
-              <a:t>TASK 2 · FINANCIAL HEALTH · D3</a:t>
+              <a:t>TASK 2 · FINANCIAL HEALTH · D4</a:t>
             </a:r>
             <a:endParaRPr lang="en-US" sz="1100" dirty="0"/>
           </a:p>
@@ -3766,7 +3743,7 @@
                 <a:ea typeface="Cambria" pitchFamily="34" charset="-122"/>
                 <a:cs typeface="Cambria" pitchFamily="34" charset="-120"/>
               </a:rPr>
-              <a:t>Who differs? Province and age barely; occupation through spending</a:t>
+              <a:t>The "Stressed but Engaged" crossover — and when to reach it</a:t>
             </a:r>
             <a:endParaRPr lang="en-US" sz="2700" dirty="0"/>
           </a:p>
@@ -3781,7 +3758,7 @@
         <p:spPr>
           <a:xfrm>
             <a:off x="457200" y="1417320"/>
-            <a:ext cx="11247120" cy="1463040"/>
+            <a:ext cx="11247120" cy="1600200"/>
           </a:xfrm>
           <a:prstGeom prst="rect">
             <a:avLst/>
@@ -3809,7 +3786,7 @@
                 <a:ea typeface="Calibri" pitchFamily="34" charset="-122"/>
                 <a:cs typeface="Calibri" pitchFamily="34" charset="-120"/>
               </a:rPr>
-              <a:t>Province: 22 of 27 provinces (≥ 15 consumers) have a 95% CI containing the national mean 66.3 (extremes Thai Nguyen 63.0, HCMC 67.6). Age: all six cohort CIs overlap (65.8–67.0).</a:t>
+              <a:t>Reproducible rule (consumer-month): financial_health_score &lt; 40 AND engagement_score ≥ p75 (81.4) → 43 consumers / 49 months = 52% of ALL stress episodes. Robust: p70 / p80 give 44 / 41 consumers (53% / 48%).</a:t>
             </a:r>
             <a:endParaRPr lang="en-US" sz="1250" dirty="0"/>
           </a:p>
@@ -3830,7 +3807,7 @@
                 <a:ea typeface="Calibri" pitchFamily="34" charset="-122"/>
                 <a:cs typeface="Calibri" pitchFamily="34" charset="-120"/>
               </a:rPr>
-              <a:t>Occupation (396 raw titles → 8 keyword groups): Engineering/science/IT 69.1 (n = 229), Business/finance 68.7 (126) vs Office/public 64.5 (443), Manual/trades 62.9 (23) — a ~6-pt spread that mirrors spend-to-income (0.60 vs 0.76–0.79).</a:t>
+              <a:t>Profile: spend/income 1.89, credit-utilization 0.55, online share 0.49 (2× national) — active, digital, over-extended.</a:t>
             </a:r>
             <a:endParaRPr lang="en-US" sz="1250" dirty="0"/>
           </a:p>
@@ -3851,7 +3828,7 @@
                 <a:ea typeface="Calibri" pitchFamily="34" charset="-122"/>
                 <a:cs typeface="Calibri" pitchFamily="34" charset="-120"/>
               </a:rPr>
-              <a:t>Demographics act through the overspend ratio → target the ratio, never the group (fairness).</a:t>
+              <a:t>Timing (transactions): stressed months put 23.5% of spend value into 22–23h vs 8.3% (bigger late tickets, not more: count 11.6% vs 9.7%); Sunday + Monday = 42% vs 34% → alerts Sun–Mon evenings, before 22:00.</a:t>
             </a:r>
             <a:endParaRPr lang="en-US" sz="1250" dirty="0"/>
           </a:p>
@@ -3859,7 +3836,7 @@
       </p:sp>
       <p:pic>
         <p:nvPicPr>
-          <p:cNvPr id="5" name="Image 0" descr="D:\BI10GroupYAPPERS\outputs\figures\t2_demographics.png">    </p:cNvPr>
+          <p:cNvPr id="5" name="Image 0" descr="D:\BI10GroupYAPPERS\outputs\figures\t2_crossover.png">    </p:cNvPr>
           <p:cNvPicPr>
             <a:picLocks noChangeAspect="1"/>
           </p:cNvPicPr>
@@ -3872,24 +3849,47 @@
         </p:blipFill>
         <p:spPr>
           <a:xfrm>
-            <a:off x="457200" y="2926080"/>
-            <a:ext cx="11247120" cy="3154680"/>
+            <a:off x="502920" y="3017520"/>
+            <a:ext cx="5440680" cy="3063240"/>
           </a:xfrm>
           <a:prstGeom prst="rect">
             <a:avLst/>
           </a:prstGeom>
         </p:spPr>
       </p:pic>
-      <p:sp>
-        <p:nvSpPr>
-          <p:cNvPr id="6" name="Text 3"/>
-          <p:cNvSpPr txBox="1"/>
-          <p:nvPr/>
-        </p:nvSpPr>
-        <p:spPr>
-          <a:xfrm>
-            <a:off x="457200" y="6144768"/>
-            <a:ext cx="11247120" cy="256032"/>
+      <p:pic>
+        <p:nvPicPr>
+          <p:cNvPr id="6" name="Image 1" descr="D:\BI10GroupYAPPERS\outputs\figures\t2_timing.png">    </p:cNvPr>
+          <p:cNvPicPr>
+            <a:picLocks noChangeAspect="1"/>
+          </p:cNvPicPr>
+          <p:nvPr/>
+        </p:nvPicPr>
+        <p:blipFill>
+          <a:blip r:embed="rId2"/>
+          <a:srcRect l="0" r="0" t="0" b="0"/>
+          <a:stretch/>
+        </p:blipFill>
+        <p:spPr>
+          <a:xfrm>
+            <a:off x="6263640" y="3017520"/>
+            <a:ext cx="5440680" cy="3063240"/>
+          </a:xfrm>
+          <a:prstGeom prst="rect">
+            <a:avLst/>
+          </a:prstGeom>
+        </p:spPr>
+      </p:pic>
+      <p:sp>
+        <p:nvSpPr>
+          <p:cNvPr id="7" name="Text 3"/>
+          <p:cNvSpPr txBox="1"/>
+          <p:nvPr/>
+        </p:nvSpPr>
+        <p:spPr>
+          <a:xfrm>
+            <a:off x="502920" y="6144768"/>
+            <a:ext cx="11201400" cy="256032"/>
           </a:xfrm>
           <a:prstGeom prst="rect">
             <a:avLst/>
@@ -3913,7 +3913,7 @@
                 <a:ea typeface="Calibri" pitchFamily="34" charset="-122"/>
                 <a:cs typeface="Calibri" pitchFamily="34" charset="-120"/>
               </a:rPr>
-              <a:t>Source: consumer_financial_health_engagement_2025 — 10,992 consumer-months, 999 consumers, 2025.</a:t>
+              <a:t>Source: consumer_financial_health_engagement_2025 — 10,992 consumer-months, 999 consumers, 2025. Timing: Source: transactions file joined to the consumer-month file on consumer_id + month.</a:t>
             </a:r>
             <a:endParaRPr lang="en-US" sz="850" dirty="0"/>
           </a:p>
@@ -3921,7 +3921,7 @@
       </p:sp>
       <p:sp>
         <p:nvSpPr>
-          <p:cNvPr id="7" name="Text 4"/>
+          <p:cNvPr id="8" name="Text 4"/>
           <p:cNvSpPr txBox="1"/>
           <p:nvPr/>
         </p:nvSpPr>
@@ -3960,7 +3960,7 @@
       </p:sp>
       <p:sp>
         <p:nvSpPr>
-          <p:cNvPr id="8" name="Text 5"/>
+          <p:cNvPr id="9" name="Text 5"/>
           <p:cNvSpPr txBox="1"/>
           <p:nvPr/>
         </p:nvSpPr>
@@ -13708,7 +13708,7 @@
                 <a:ea typeface="Calibri" pitchFamily="34" charset="-122"/>
                 <a:cs typeface="Calibri" pitchFamily="34" charset="-120"/>
               </a:rPr>
-              <a:t>TASK 1 · EDA · Q4 &amp; Q5</a:t>
+              <a:t>TASK 1 · EDA · Q3</a:t>
             </a:r>
             <a:endParaRPr lang="en-US" sz="1100" dirty="0"/>
           </a:p>
@@ -13750,7 +13750,7 @@
                 <a:ea typeface="Cambria" pitchFamily="34" charset="-122"/>
                 <a:cs typeface="Cambria" pitchFamily="34" charset="-120"/>
               </a:rPr>
-              <a:t>Categories: habit vs basket. Age: active 25–34 is weakest — barely</a:t>
+              <a:t>No regional digital divide: high-spend provinces mirror the nation</a:t>
             </a:r>
             <a:endParaRPr lang="en-US" sz="2700" dirty="0"/>
           </a:p>
@@ -13764,8 +13764,8 @@
         </p:nvSpPr>
         <p:spPr>
           <a:xfrm>
-            <a:off x="457200" y="1417320"/>
-            <a:ext cx="11247120" cy="1600200"/>
+            <a:off x="457200" y="1554480"/>
+            <a:ext cx="5760720" cy="3429000"/>
           </a:xfrm>
           <a:prstGeom prst="rect">
             <a:avLst/>
@@ -13785,7 +13785,7 @@
               <a:buChar char="•"/>
             </a:pPr>
             <a:r>
-              <a:rPr lang="en-US" sz="1250" dirty="0">
+              <a:rPr lang="en-US" sz="1300" dirty="0">
                 <a:solidFill>
                   <a:srgbClr val="1B2A36"/>
                 </a:solidFill>
@@ -13793,9 +13793,9 @@
                 <a:ea typeface="Calibri" pitchFamily="34" charset="-122"/>
                 <a:cs typeface="Calibri" pitchFamily="34" charset="-120"/>
               </a:rPr>
-              <a:t>Q4 — top by COUNT: Fuel &amp; Transport, 188,029 transactions, avg ticket 1.59M VND (bought by 96.8% of consumers, 17.3 times per buyer-month). Top by SPEND: in-store Groceries, 513.8B VND, avg ticket 2.92M VND (1.8×) — frequent top-ups vs stock-up baskets.</a:t>
-            </a:r>
-            <a:endParaRPr lang="en-US" sz="1250" dirty="0"/>
+              <a:t>5 provinces with above-median spend but below-average digital share: Ha Noi, Dong Nai, Lam Dong, Hung Yen, Hai Phong.</a:t>
+            </a:r>
+            <a:endParaRPr lang="en-US" sz="1300" dirty="0"/>
           </a:p>
           <a:p>
             <a:pPr marL="177800" indent="-177800">
@@ -13806,7 +13806,7 @@
               <a:buChar char="•"/>
             </a:pPr>
             <a:r>
-              <a:rPr lang="en-US" sz="1250" dirty="0">
+              <a:rPr lang="en-US" sz="1300" dirty="0">
                 <a:solidFill>
                   <a:srgbClr val="1B2A36"/>
                 </a:solidFill>
@@ -13814,9 +13814,9 @@
                 <a:ea typeface="Calibri" pitchFamily="34" charset="-122"/>
                 <a:cs typeface="Calibri" pitchFamily="34" charset="-120"/>
               </a:rPr>
-              <a:t>Q5 — 25–34 is active (178.7 transactions/month, above the cohort median 177.8) with the lowest FHS 65.8 (best 67.0). Drivers: highest spend-to-income 0.716 (national 0.700) with a below-average essential ratio 0.468 (national 0.481) → overspend on wants.</a:t>
-            </a:r>
-            <a:endParaRPr lang="en-US" sz="1250" dirty="0"/>
+              <a:t>Channel breakdown (share of transactions): POS 58.9–59.3% vs 58.8% nationally · QR ~19.8–20.1% · E-commerce ~8.5% · Mobile ~7.5% · Recurring ~5%.</a:t>
+            </a:r>
+            <a:endParaRPr lang="en-US" sz="1300" dirty="0"/>
           </a:p>
           <a:p>
             <a:pPr marL="177800" indent="-177800">
@@ -13827,7 +13827,7 @@
               <a:buChar char="•"/>
             </a:pPr>
             <a:r>
-              <a:rPr lang="en-US" sz="1250" dirty="0">
+              <a:rPr lang="en-US" sz="1300" dirty="0">
                 <a:solidFill>
                   <a:srgbClr val="1B2A36"/>
                 </a:solidFill>
@@ -13835,15 +13835,57 @@
                 <a:ea typeface="Calibri" pitchFamily="34" charset="-122"/>
                 <a:cs typeface="Calibri" pitchFamily="34" charset="-120"/>
               </a:rPr>
-              <a:t>But bootstrap 95% CIs of all six cohorts overlap (65.8–67.0): age is a weak differentiator — target the ratios, not birth year.</a:t>
-            </a:r>
-            <a:endParaRPr lang="en-US" sz="1250" dirty="0"/>
+              <a:t>Largest digital gap: −0.46pp (Dong Nai); digital share of value 40.9–41.5% vs 41.5% nationally.</a:t>
+            </a:r>
+            <a:endParaRPr lang="en-US" sz="1300" dirty="0"/>
+          </a:p>
+          <a:p>
+            <a:pPr marL="177800" indent="-177800">
+              <a:spcAft>
+                <a:spcPts val="700"/>
+              </a:spcAft>
+              <a:buSzPct val="100000"/>
+              <a:buChar char="•"/>
+            </a:pPr>
+            <a:r>
+              <a:rPr lang="en-US" sz="1300" dirty="0">
+                <a:solidFill>
+                  <a:srgbClr val="1B2A36"/>
+                </a:solidFill>
+                <a:latin typeface="Calibri" pitchFamily="34" charset="0"/>
+                <a:ea typeface="Calibri" pitchFamily="34" charset="-122"/>
+                <a:cs typeface="Calibri" pitchFamily="34" charset="-120"/>
+              </a:rPr>
+              <a:t>Top performers: HCMC leads spend (13.6% of the national total) at 41.3% digital; highest digital share Cao Bang 43.1% (0.5% of spend), lowest Quang Ngai 39.2% — all 34 provinces sit within 3.9pp.</a:t>
+            </a:r>
+            <a:endParaRPr lang="en-US" sz="1300" dirty="0"/>
+          </a:p>
+          <a:p>
+            <a:pPr marL="177800" indent="-177800">
+              <a:spcAft>
+                <a:spcPts val="700"/>
+              </a:spcAft>
+              <a:buSzPct val="100000"/>
+              <a:buChar char="•"/>
+            </a:pPr>
+            <a:r>
+              <a:rPr lang="en-US" sz="1300" dirty="0">
+                <a:solidFill>
+                  <a:srgbClr val="1B2A36"/>
+                </a:solidFill>
+                <a:latin typeface="Calibri" pitchFamily="34" charset="0"/>
+                <a:ea typeface="Calibri" pitchFamily="34" charset="-122"/>
+                <a:cs typeface="Calibri" pitchFamily="34" charset="-120"/>
+              </a:rPr>
+              <a:t>The gap is statistically real but commercially negligible → province is not a lever for digital adoption; behaviour is.</a:t>
+            </a:r>
+            <a:endParaRPr lang="en-US" sz="1300" dirty="0"/>
           </a:p>
         </p:txBody>
       </p:sp>
       <p:pic>
         <p:nvPicPr>
-          <p:cNvPr id="5" name="Image 0" descr="D:\BI10GroupYAPPERS\outputs\figures\t1_category_ticket.png">    </p:cNvPr>
+          <p:cNvPr id="5" name="Image 0" descr="D:\BI10GroupYAPPERS\outputs\figures\t1_province_channel.png">    </p:cNvPr>
           <p:cNvPicPr>
             <a:picLocks noChangeAspect="1"/>
           </p:cNvPicPr>
@@ -13856,47 +13898,24 @@
         </p:blipFill>
         <p:spPr>
           <a:xfrm>
-            <a:off x="502920" y="3017520"/>
-            <a:ext cx="5440680" cy="3063240"/>
+            <a:off x="6446520" y="1554480"/>
+            <a:ext cx="5303520" cy="4023360"/>
           </a:xfrm>
           <a:prstGeom prst="rect">
             <a:avLst/>
           </a:prstGeom>
         </p:spPr>
       </p:pic>
-      <p:pic>
-        <p:nvPicPr>
-          <p:cNvPr id="6" name="Image 1" descr="D:\BI10GroupYAPPERS\outputs\figures\t1_age_cohort.png">    </p:cNvPr>
-          <p:cNvPicPr>
-            <a:picLocks noChangeAspect="1"/>
-          </p:cNvPicPr>
-          <p:nvPr/>
-        </p:nvPicPr>
-        <p:blipFill>
-          <a:blip r:embed="rId2"/>
-          <a:srcRect l="0" r="0" t="0" b="0"/>
-          <a:stretch/>
-        </p:blipFill>
-        <p:spPr>
-          <a:xfrm>
-            <a:off x="6263640" y="3017520"/>
-            <a:ext cx="5440680" cy="3063240"/>
-          </a:xfrm>
-          <a:prstGeom prst="rect">
-            <a:avLst/>
-          </a:prstGeom>
-        </p:spPr>
-      </p:pic>
-      <p:sp>
-        <p:nvSpPr>
-          <p:cNvPr id="7" name="Text 3"/>
-          <p:cNvSpPr txBox="1"/>
-          <p:nvPr/>
-        </p:nvSpPr>
-        <p:spPr>
-          <a:xfrm>
-            <a:off x="502920" y="6144768"/>
-            <a:ext cx="11201400" cy="256032"/>
+      <p:sp>
+        <p:nvSpPr>
+          <p:cNvPr id="6" name="Text 3"/>
+          <p:cNvSpPr txBox="1"/>
+          <p:nvPr/>
+        </p:nvSpPr>
+        <p:spPr>
+          <a:xfrm>
+            <a:off x="6446520" y="5623560"/>
+            <a:ext cx="5303520" cy="256032"/>
           </a:xfrm>
           <a:prstGeom prst="rect">
             <a:avLst/>
@@ -13920,7 +13939,7 @@
                 <a:ea typeface="Calibri" pitchFamily="34" charset="-122"/>
                 <a:cs typeface="Calibri" pitchFamily="34" charset="-120"/>
               </a:rPr>
-              <a:t>Source: consumer_transactions_2025 — 1,852,394 transactions, 2025. Age cohorts: consumer-month file.</a:t>
+              <a:t>Source: consumer_transactions_2025 — 1,852,394 transactions, 2025.</a:t>
             </a:r>
             <a:endParaRPr lang="en-US" sz="850" dirty="0"/>
           </a:p>
@@ -13928,7 +13947,107 @@
       </p:sp>
       <p:sp>
         <p:nvSpPr>
-          <p:cNvPr id="8" name="Text 4"/>
+          <p:cNvPr id="7" name="Shape 4"/>
+          <p:cNvSpPr/>
+          <p:nvPr/>
+        </p:nvSpPr>
+        <p:spPr>
+          <a:xfrm>
+            <a:off x="457200" y="5074920"/>
+            <a:ext cx="3383280" cy="1051560"/>
+          </a:xfrm>
+          <a:prstGeom prst="roundRect">
+            <a:avLst>
+              <a:gd name="adj" fmla="val 6957"/>
+            </a:avLst>
+          </a:prstGeom>
+          <a:solidFill>
+            <a:srgbClr val="12435E"/>
+          </a:solidFill>
+          <a:ln/>
+        </p:spPr>
+      </p:sp>
+      <p:sp>
+        <p:nvSpPr>
+          <p:cNvPr id="8" name="Text 5"/>
+          <p:cNvSpPr txBox="1"/>
+          <p:nvPr/>
+        </p:nvSpPr>
+        <p:spPr>
+          <a:xfrm>
+            <a:off x="457200" y="5148072"/>
+            <a:ext cx="3383280" cy="621792"/>
+          </a:xfrm>
+          <a:prstGeom prst="rect">
+            <a:avLst/>
+          </a:prstGeom>
+          <a:noFill/>
+          <a:ln/>
+        </p:spPr>
+        <p:txBody>
+          <a:bodyPr wrap="square" lIns="0" tIns="0" rIns="0" bIns="0" rtlCol="0" anchor="ctr"/>
+          <a:lstStyle/>
+          <a:p>
+            <a:pPr algn="ctr" indent="0" marL="0">
+              <a:buNone/>
+            </a:pPr>
+            <a:r>
+              <a:rPr lang="en-US" sz="2600" b="1" dirty="0">
+                <a:solidFill>
+                  <a:srgbClr val="1FC3A6"/>
+                </a:solidFill>
+                <a:latin typeface="Cambria" pitchFamily="34" charset="0"/>
+                <a:ea typeface="Cambria" pitchFamily="34" charset="-122"/>
+                <a:cs typeface="Cambria" pitchFamily="34" charset="-120"/>
+              </a:rPr>
+              <a:t>≤ 0.46pp</a:t>
+            </a:r>
+            <a:endParaRPr lang="en-US" sz="2600" dirty="0"/>
+          </a:p>
+        </p:txBody>
+      </p:sp>
+      <p:sp>
+        <p:nvSpPr>
+          <p:cNvPr id="9" name="Text 6"/>
+          <p:cNvSpPr txBox="1"/>
+          <p:nvPr/>
+        </p:nvSpPr>
+        <p:spPr>
+          <a:xfrm>
+            <a:off x="457200" y="5769864"/>
+            <a:ext cx="3383280" cy="301752"/>
+          </a:xfrm>
+          <a:prstGeom prst="rect">
+            <a:avLst/>
+          </a:prstGeom>
+          <a:noFill/>
+          <a:ln/>
+        </p:spPr>
+        <p:txBody>
+          <a:bodyPr wrap="square" lIns="0" tIns="0" rIns="0" bIns="0" rtlCol="0" anchor="ctr"/>
+          <a:lstStyle/>
+          <a:p>
+            <a:pPr algn="ctr" indent="0" marL="0">
+              <a:buNone/>
+            </a:pPr>
+            <a:r>
+              <a:rPr lang="en-US" sz="1100" dirty="0">
+                <a:solidFill>
+                  <a:srgbClr val="FFFFFF"/>
+                </a:solidFill>
+                <a:latin typeface="Calibri" pitchFamily="34" charset="0"/>
+                <a:ea typeface="Calibri" pitchFamily="34" charset="-122"/>
+                <a:cs typeface="Calibri" pitchFamily="34" charset="-120"/>
+              </a:rPr>
+              <a:t>largest digital-share gap vs national</a:t>
+            </a:r>
+            <a:endParaRPr lang="en-US" sz="1100" dirty="0"/>
+          </a:p>
+        </p:txBody>
+      </p:sp>
+      <p:sp>
+        <p:nvSpPr>
+          <p:cNvPr id="10" name="Text 7"/>
           <p:cNvSpPr txBox="1"/>
           <p:nvPr/>
         </p:nvSpPr>
@@ -13967,7 +14086,7 @@
       </p:sp>
       <p:sp>
         <p:nvSpPr>
-          <p:cNvPr id="9" name="Text 5"/>
+          <p:cNvPr id="11" name="Text 8"/>
           <p:cNvSpPr txBox="1"/>
           <p:nvPr/>
         </p:nvSpPr>
@@ -14069,7 +14188,7 @@
                 <a:ea typeface="Calibri" pitchFamily="34" charset="-122"/>
                 <a:cs typeface="Calibri" pitchFamily="34" charset="-120"/>
               </a:rPr>
-              <a:t>TASK 1 · EDA · Q3</a:t>
+              <a:t>TASK 1 · EDA · Q4 &amp; Q5</a:t>
             </a:r>
             <a:endParaRPr lang="en-US" sz="1100" dirty="0"/>
           </a:p>
@@ -14111,7 +14230,7 @@
                 <a:ea typeface="Cambria" pitchFamily="34" charset="-122"/>
                 <a:cs typeface="Cambria" pitchFamily="34" charset="-120"/>
               </a:rPr>
-              <a:t>No regional digital divide: high-spend provinces mirror the nation</a:t>
+              <a:t>Categories: habit vs basket. Age: active 25–34 is weakest — barely</a:t>
             </a:r>
             <a:endParaRPr lang="en-US" sz="2700" dirty="0"/>
           </a:p>
@@ -14125,8 +14244,8 @@
         </p:nvSpPr>
         <p:spPr>
           <a:xfrm>
-            <a:off x="457200" y="1554480"/>
-            <a:ext cx="5760720" cy="3429000"/>
+            <a:off x="457200" y="1417320"/>
+            <a:ext cx="11247120" cy="1600200"/>
           </a:xfrm>
           <a:prstGeom prst="rect">
             <a:avLst/>
@@ -14146,7 +14265,7 @@
               <a:buChar char="•"/>
             </a:pPr>
             <a:r>
-              <a:rPr lang="en-US" sz="1300" dirty="0">
+              <a:rPr lang="en-US" sz="1250" dirty="0">
                 <a:solidFill>
                   <a:srgbClr val="1B2A36"/>
                 </a:solidFill>
@@ -14154,9 +14273,9 @@
                 <a:ea typeface="Calibri" pitchFamily="34" charset="-122"/>
                 <a:cs typeface="Calibri" pitchFamily="34" charset="-120"/>
               </a:rPr>
-              <a:t>5 provinces with above-median spend but below-average digital share: Ha Noi, Dong Nai, Lam Dong, Hung Yen, Hai Phong.</a:t>
-            </a:r>
-            <a:endParaRPr lang="en-US" sz="1300" dirty="0"/>
+              <a:t>Q4 — top by COUNT: Fuel &amp; Transport, 188,029 transactions, avg ticket 1.59M VND (bought by 96.8% of consumers, 17.3 times per buyer-month). Top by SPEND: in-store Groceries, 513.8B VND, avg ticket 2.92M VND (1.8×) — frequent top-ups vs stock-up baskets.</a:t>
+            </a:r>
+            <a:endParaRPr lang="en-US" sz="1250" dirty="0"/>
           </a:p>
           <a:p>
             <a:pPr marL="177800" indent="-177800">
@@ -14167,7 +14286,7 @@
               <a:buChar char="•"/>
             </a:pPr>
             <a:r>
-              <a:rPr lang="en-US" sz="1300" dirty="0">
+              <a:rPr lang="en-US" sz="1250" dirty="0">
                 <a:solidFill>
                   <a:srgbClr val="1B2A36"/>
                 </a:solidFill>
@@ -14175,9 +14294,9 @@
                 <a:ea typeface="Calibri" pitchFamily="34" charset="-122"/>
                 <a:cs typeface="Calibri" pitchFamily="34" charset="-120"/>
               </a:rPr>
-              <a:t>Channel breakdown (share of transactions): POS 58.9–59.3% vs 58.8% nationally · QR ~19.8–20.1% · E-commerce ~8.5% · Mobile ~7.5% · Recurring ~5%.</a:t>
-            </a:r>
-            <a:endParaRPr lang="en-US" sz="1300" dirty="0"/>
+              <a:t>Q5 — 25–34 is active (178.7 transactions/month, above the cohort median 177.8) with the lowest FHS 65.8 (best 67.0). Drivers: highest spend-to-income 0.716 (national 0.700) with a below-average essential ratio 0.468 (national 0.481) → overspend on wants.</a:t>
+            </a:r>
+            <a:endParaRPr lang="en-US" sz="1250" dirty="0"/>
           </a:p>
           <a:p>
             <a:pPr marL="177800" indent="-177800">
@@ -14188,7 +14307,7 @@
               <a:buChar char="•"/>
             </a:pPr>
             <a:r>
-              <a:rPr lang="en-US" sz="1300" dirty="0">
+              <a:rPr lang="en-US" sz="1250" dirty="0">
                 <a:solidFill>
                   <a:srgbClr val="1B2A36"/>
                 </a:solidFill>
@@ -14196,57 +14315,15 @@
                 <a:ea typeface="Calibri" pitchFamily="34" charset="-122"/>
                 <a:cs typeface="Calibri" pitchFamily="34" charset="-120"/>
               </a:rPr>
-              <a:t>Largest digital gap: −0.46pp (Dong Nai); digital share of value 40.9–41.5% vs 41.5% nationally.</a:t>
-            </a:r>
-            <a:endParaRPr lang="en-US" sz="1300" dirty="0"/>
-          </a:p>
-          <a:p>
-            <a:pPr marL="177800" indent="-177800">
-              <a:spcAft>
-                <a:spcPts val="700"/>
-              </a:spcAft>
-              <a:buSzPct val="100000"/>
-              <a:buChar char="•"/>
-            </a:pPr>
-            <a:r>
-              <a:rPr lang="en-US" sz="1300" dirty="0">
-                <a:solidFill>
-                  <a:srgbClr val="1B2A36"/>
-                </a:solidFill>
-                <a:latin typeface="Calibri" pitchFamily="34" charset="0"/>
-                <a:ea typeface="Calibri" pitchFamily="34" charset="-122"/>
-                <a:cs typeface="Calibri" pitchFamily="34" charset="-120"/>
-              </a:rPr>
-              <a:t>Top performers: HCMC leads spend (13.6% of the national total) at 41.3% digital; highest digital share Cao Bang 43.1% (0.5% of spend), lowest Quang Ngai 39.2% — all 34 provinces sit within 3.9pp.</a:t>
-            </a:r>
-            <a:endParaRPr lang="en-US" sz="1300" dirty="0"/>
-          </a:p>
-          <a:p>
-            <a:pPr marL="177800" indent="-177800">
-              <a:spcAft>
-                <a:spcPts val="700"/>
-              </a:spcAft>
-              <a:buSzPct val="100000"/>
-              <a:buChar char="•"/>
-            </a:pPr>
-            <a:r>
-              <a:rPr lang="en-US" sz="1300" dirty="0">
-                <a:solidFill>
-                  <a:srgbClr val="1B2A36"/>
-                </a:solidFill>
-                <a:latin typeface="Calibri" pitchFamily="34" charset="0"/>
-                <a:ea typeface="Calibri" pitchFamily="34" charset="-122"/>
-                <a:cs typeface="Calibri" pitchFamily="34" charset="-120"/>
-              </a:rPr>
-              <a:t>The gap is statistically real but commercially negligible → province is not a lever for digital adoption; behaviour is.</a:t>
-            </a:r>
-            <a:endParaRPr lang="en-US" sz="1300" dirty="0"/>
+              <a:t>But bootstrap 95% CIs of all six cohorts overlap (65.8–67.0): age is a weak differentiator — target the ratios, not birth year.</a:t>
+            </a:r>
+            <a:endParaRPr lang="en-US" sz="1250" dirty="0"/>
           </a:p>
         </p:txBody>
       </p:sp>
       <p:pic>
         <p:nvPicPr>
-          <p:cNvPr id="5" name="Image 0" descr="D:\BI10GroupYAPPERS\outputs\figures\t1_province_channel.png">    </p:cNvPr>
+          <p:cNvPr id="5" name="Image 0" descr="D:\BI10GroupYAPPERS\outputs\figures\t1_category_ticket.png">    </p:cNvPr>
           <p:cNvPicPr>
             <a:picLocks noChangeAspect="1"/>
           </p:cNvPicPr>
@@ -14259,24 +14336,47 @@
         </p:blipFill>
         <p:spPr>
           <a:xfrm>
-            <a:off x="6446520" y="1554480"/>
-            <a:ext cx="5303520" cy="4023360"/>
+            <a:off x="502920" y="3017520"/>
+            <a:ext cx="5440680" cy="3063240"/>
           </a:xfrm>
           <a:prstGeom prst="rect">
             <a:avLst/>
           </a:prstGeom>
         </p:spPr>
       </p:pic>
-      <p:sp>
-        <p:nvSpPr>
-          <p:cNvPr id="6" name="Text 3"/>
-          <p:cNvSpPr txBox="1"/>
-          <p:nvPr/>
-        </p:nvSpPr>
-        <p:spPr>
-          <a:xfrm>
-            <a:off x="6446520" y="5623560"/>
-            <a:ext cx="5303520" cy="256032"/>
+      <p:pic>
+        <p:nvPicPr>
+          <p:cNvPr id="6" name="Image 1" descr="D:\BI10GroupYAPPERS\outputs\figures\t1_age_cohort.png">    </p:cNvPr>
+          <p:cNvPicPr>
+            <a:picLocks noChangeAspect="1"/>
+          </p:cNvPicPr>
+          <p:nvPr/>
+        </p:nvPicPr>
+        <p:blipFill>
+          <a:blip r:embed="rId2"/>
+          <a:srcRect l="0" r="0" t="0" b="0"/>
+          <a:stretch/>
+        </p:blipFill>
+        <p:spPr>
+          <a:xfrm>
+            <a:off x="6263640" y="3017520"/>
+            <a:ext cx="5440680" cy="3063240"/>
+          </a:xfrm>
+          <a:prstGeom prst="rect">
+            <a:avLst/>
+          </a:prstGeom>
+        </p:spPr>
+      </p:pic>
+      <p:sp>
+        <p:nvSpPr>
+          <p:cNvPr id="7" name="Text 3"/>
+          <p:cNvSpPr txBox="1"/>
+          <p:nvPr/>
+        </p:nvSpPr>
+        <p:spPr>
+          <a:xfrm>
+            <a:off x="502920" y="6144768"/>
+            <a:ext cx="11201400" cy="256032"/>
           </a:xfrm>
           <a:prstGeom prst="rect">
             <a:avLst/>
@@ -14300,7 +14400,7 @@
                 <a:ea typeface="Calibri" pitchFamily="34" charset="-122"/>
                 <a:cs typeface="Calibri" pitchFamily="34" charset="-120"/>
               </a:rPr>
-              <a:t>Source: consumer_transactions_2025 — 1,852,394 transactions, 2025.</a:t>
+              <a:t>Source: consumer_transactions_2025 — 1,852,394 transactions, 2025. Age cohorts: consumer-month file.</a:t>
             </a:r>
             <a:endParaRPr lang="en-US" sz="850" dirty="0"/>
           </a:p>
@@ -14308,107 +14408,7 @@
       </p:sp>
       <p:sp>
         <p:nvSpPr>
-          <p:cNvPr id="7" name="Shape 4"/>
-          <p:cNvSpPr/>
-          <p:nvPr/>
-        </p:nvSpPr>
-        <p:spPr>
-          <a:xfrm>
-            <a:off x="457200" y="5074920"/>
-            <a:ext cx="3383280" cy="1051560"/>
-          </a:xfrm>
-          <a:prstGeom prst="roundRect">
-            <a:avLst>
-              <a:gd name="adj" fmla="val 6957"/>
-            </a:avLst>
-          </a:prstGeom>
-          <a:solidFill>
-            <a:srgbClr val="12435E"/>
-          </a:solidFill>
-          <a:ln/>
-        </p:spPr>
-      </p:sp>
-      <p:sp>
-        <p:nvSpPr>
-          <p:cNvPr id="8" name="Text 5"/>
-          <p:cNvSpPr txBox="1"/>
-          <p:nvPr/>
-        </p:nvSpPr>
-        <p:spPr>
-          <a:xfrm>
-            <a:off x="457200" y="5148072"/>
-            <a:ext cx="3383280" cy="621792"/>
-          </a:xfrm>
-          <a:prstGeom prst="rect">
-            <a:avLst/>
-          </a:prstGeom>
-          <a:noFill/>
-          <a:ln/>
-        </p:spPr>
-        <p:txBody>
-          <a:bodyPr wrap="square" lIns="0" tIns="0" rIns="0" bIns="0" rtlCol="0" anchor="ctr"/>
-          <a:lstStyle/>
-          <a:p>
-            <a:pPr algn="ctr" indent="0" marL="0">
-              <a:buNone/>
-            </a:pPr>
-            <a:r>
-              <a:rPr lang="en-US" sz="2600" b="1" dirty="0">
-                <a:solidFill>
-                  <a:srgbClr val="1FC3A6"/>
-                </a:solidFill>
-                <a:latin typeface="Cambria" pitchFamily="34" charset="0"/>
-                <a:ea typeface="Cambria" pitchFamily="34" charset="-122"/>
-                <a:cs typeface="Cambria" pitchFamily="34" charset="-120"/>
-              </a:rPr>
-              <a:t>≤ 0.46pp</a:t>
-            </a:r>
-            <a:endParaRPr lang="en-US" sz="2600" dirty="0"/>
-          </a:p>
-        </p:txBody>
-      </p:sp>
-      <p:sp>
-        <p:nvSpPr>
-          <p:cNvPr id="9" name="Text 6"/>
-          <p:cNvSpPr txBox="1"/>
-          <p:nvPr/>
-        </p:nvSpPr>
-        <p:spPr>
-          <a:xfrm>
-            <a:off x="457200" y="5769864"/>
-            <a:ext cx="3383280" cy="301752"/>
-          </a:xfrm>
-          <a:prstGeom prst="rect">
-            <a:avLst/>
-          </a:prstGeom>
-          <a:noFill/>
-          <a:ln/>
-        </p:spPr>
-        <p:txBody>
-          <a:bodyPr wrap="square" lIns="0" tIns="0" rIns="0" bIns="0" rtlCol="0" anchor="ctr"/>
-          <a:lstStyle/>
-          <a:p>
-            <a:pPr algn="ctr" indent="0" marL="0">
-              <a:buNone/>
-            </a:pPr>
-            <a:r>
-              <a:rPr lang="en-US" sz="1100" dirty="0">
-                <a:solidFill>
-                  <a:srgbClr val="FFFFFF"/>
-                </a:solidFill>
-                <a:latin typeface="Calibri" pitchFamily="34" charset="0"/>
-                <a:ea typeface="Calibri" pitchFamily="34" charset="-122"/>
-                <a:cs typeface="Calibri" pitchFamily="34" charset="-120"/>
-              </a:rPr>
-              <a:t>largest digital-share gap vs national</a:t>
-            </a:r>
-            <a:endParaRPr lang="en-US" sz="1100" dirty="0"/>
-          </a:p>
-        </p:txBody>
-      </p:sp>
-      <p:sp>
-        <p:nvSpPr>
-          <p:cNvPr id="10" name="Text 7"/>
+          <p:cNvPr id="8" name="Text 4"/>
           <p:cNvSpPr txBox="1"/>
           <p:nvPr/>
         </p:nvSpPr>
@@ -14447,7 +14447,7 @@
       </p:sp>
       <p:sp>
         <p:nvSpPr>
-          <p:cNvPr id="11" name="Text 8"/>
+          <p:cNvPr id="9" name="Text 5"/>
           <p:cNvSpPr txBox="1"/>
           <p:nvPr/>
         </p:nvSpPr>

</xml_diff>

<commit_message>
Close brief gaps and apply review fixes; add submission ZIP
- Q3: 5-channel breakdown chart, per-province digital shares on slide 7
- Q5: essential ratio added to the cohort chart
- Task 4: limitations, bias and future work on slide 18; "8 behavioural
  features" instead of "ratios"; English data dictionary matching
  task4_features.csv
- Task 5: education rule stated; product target = 350 adults (fixes a
  minor being counted); ranking labelled a heuristic; what-if and
  90-day pilot worded as untested
- Submission ZIP YAPPERS_PhamThoaiNhaPhuong_BI10_R01_data
</commit_message>
<xml_diff>
--- a/draft/YAPPERS_BI10_R01.pptx
+++ b/draft/YAPPERS_BI10_R01.pptx
@@ -1315,7 +1315,7 @@
           <a:p>
             <a:r>
               <a:rPr lang="en-US" dirty="0"/>
-              <a:t>Stability: 20 seeds ARI 0.988; 80% bootstrap × 50 ARI 0.911; dropping December 0.873. GMM agrees 0.26 (Occasional identical). 2×2 median cross-check agrees on health (344/351, 273/302). Segments correlate with age/gender (Cramér's V 0.23 age / 0.13 gender) → act on behaviour only. Future work: hybrid model (rule for part-year + k = 3), trajectory features, chronological early-warning on next_month_low_health_flag (support only).</a:t>
+              <a:t>Stability: 20 seeds ARI 0.988; 80% bootstrap × 50 ARI 0.911; dropping December 0.873. GMM agrees 0.26 (Occasional identical). 2×2 median cross-check agrees on health (344/351, 273/302). Future work detail: hybrid model (rule for part-year customers + k = 3 on the full-year base), trajectory features (slope, December dip), chronological early-warning on next_month_low_health_flag trained Jan–Aug, validated Sep–Oct, tested Nov (support only).</a:t>
             </a:r>
             <a:endParaRPr lang="en-US" dirty="0"/>
           </a:p>
@@ -1491,7 +1491,7 @@
           <a:p>
             <a:r>
               <a:rPr lang="en-US" dirty="0"/>
-              <a:t>One row per task: signal, driver, engagement, segments, plan. The 82% (T2) is the variance explained by spend-to-income and utilization; the 28–32% is a what-if tested with holdouts (slide 21).</a:t>
+              <a:t>One row per task: signal, driver, engagement, segments, plan. The 52% (T2) is the share of the 95 stress months held by the 43 crossover customers; spend-to-income and utilization explain 82% of FHS; the 28–32% is a simulated what-if, to be tested against holdouts (slide 21).</a:t>
             </a:r>
             <a:endParaRPr lang="en-US" dirty="0"/>
           </a:p>
@@ -5744,7 +5744,7 @@
                 <a:ea typeface="Arial" pitchFamily="34" charset="-122"/>
                 <a:cs typeface="Arial" pitchFamily="34" charset="-120"/>
               </a:rPr>
-              <a:t>active days vs engagement — ahead of transaction count (+0.76) and recency (−0.58)</a:t>
+              <a:t>active days (range 1–31, median 30) — ahead of count (+0.76) and recency (−0.58; range 0 to 30 days)</a:t>
             </a:r>
             <a:endParaRPr lang="en-US" sz="1050" dirty="0"/>
           </a:p>
@@ -6210,7 +6210,7 @@
                 <a:ea typeface="Arial" pitchFamily="34" charset="-122"/>
                 <a:cs typeface="Arial" pitchFamily="34" charset="-120"/>
               </a:rPr>
-              <a:t>The cutoff sits in an empty gap: 25 at any engagement cutoff from 60 to 70</a:t>
+              <a:t>Cutoff 70 sits in an empty gap: 25 at any cutoff 60–70; looser (72.5 / 75) pulls in active users (39 / 63); stricter FHS ≥ 75 leaves 9</a:t>
             </a:r>
             <a:endParaRPr lang="en-US" sz="1200" dirty="0"/>
           </a:p>
@@ -6440,7 +6440,7 @@
                 <a:ea typeface="Arial" pitchFamily="34" charset="-122"/>
                 <a:cs typeface="Arial" pitchFamily="34" charset="-120"/>
               </a:rPr>
-              <a:t>Clustering 8 behavioural ratios yields four segments along three business axes</a:t>
+              <a:t>Clustering 8 behavioural features yields four segments along three business axes</a:t>
             </a:r>
             <a:endParaRPr lang="en-US" sz="2400" dirty="0"/>
           </a:p>
@@ -6568,7 +6568,7 @@
                 <a:ea typeface="Arial" pitchFamily="34" charset="-122"/>
                 <a:cs typeface="Arial" pitchFamily="34" charset="-120"/>
               </a:rPr>
-              <a:t>k-means on 8 scaled ratios, 999 customers</a:t>
+              <a:t>k-means on 8 z-scaled behavioural features, 999 customers</a:t>
             </a:r>
             <a:endParaRPr lang="en-US" sz="1100" dirty="0"/>
           </a:p>
@@ -6611,7 +6611,7 @@
                 <a:ea typeface="Arial" pitchFamily="34" charset="-122"/>
                 <a:cs typeface="Arial" pitchFamily="34" charset="-120"/>
               </a:rPr>
-              <a:t>Inputs: health, activity and spending-mix ratios; no raw VND, no demographics</a:t>
+              <a:t>Inputs: 4 ratios (spend/income, utilization, discretionary, online), spending volatility, FHS, engagement score, transactions/month; no raw VND, no demographics</a:t>
             </a:r>
             <a:endParaRPr lang="en-US" sz="1200" dirty="0"/>
           </a:p>
@@ -6653,7 +6653,7 @@
                 <a:ea typeface="Arial" pitchFamily="34" charset="-122"/>
                 <a:cs typeface="Arial" pitchFamily="34" charset="-120"/>
               </a:rPr>
-              <a:t>Coverage 999 / 999 incl. 7 minors; dataset + dictionary in the ZIP</a:t>
+              <a:t>Coverage 999 / 999 incl. 7 minors; preprocessed dataset task4_features.csv + dictionary in the ZIP</a:t>
             </a:r>
             <a:endParaRPr lang="en-US" sz="1200" dirty="0"/>
           </a:p>
@@ -6692,7 +6692,7 @@
                 <a:ea typeface="Arial" pitchFamily="34" charset="-122"/>
                 <a:cs typeface="Arial" pitchFamily="34" charset="-120"/>
               </a:rPr>
-              <a:t>Source: team k-means (k = 4) on 8 scaled ratios, 999 customers. Charts: notebooks/full_pipeline.ipynb.</a:t>
+              <a:t>Source: team k-means (k = 4) on 8 z-scaled behavioural features, 999 customers. Charts: notebooks/full_pipeline.ipynb.</a:t>
             </a:r>
             <a:endParaRPr lang="en-US" sz="850" dirty="0"/>
           </a:p>
@@ -7479,7 +7479,7 @@
                 <a:ea typeface="Arial" pitchFamily="34" charset="-122"/>
                 <a:cs typeface="Arial" pitchFamily="34" charset="-120"/>
               </a:rPr>
-              <a:t>Source: team k-means (k = 4) on 8 scaled ratios, 999 customers. Charts: notebooks/full_pipeline.ipynb.</a:t>
+              <a:t>Source: team k-means (k = 4) on 8 z-scaled behavioural features, 999 customers. Charts: notebooks/full_pipeline.ipynb.</a:t>
             </a:r>
             <a:endParaRPr lang="en-US" sz="850" dirty="0"/>
           </a:p>
@@ -7589,7 +7589,7 @@
                 <a:ea typeface="Arial" pitchFamily="34" charset="-122"/>
                 <a:cs typeface="Arial" pitchFamily="34" charset="-120"/>
               </a:rPr>
-              <a:t>TASK 4 · SEGMENTATION · VALIDATION</a:t>
+              <a:t>TASK 4 · VALIDATION, LIMITS &amp; FUTURE WORK</a:t>
             </a:r>
             <a:endParaRPr lang="en-US" sz="1100" dirty="0"/>
           </a:p>
@@ -7709,7 +7709,7 @@
               <a:buNone/>
             </a:pPr>
             <a:r>
-              <a:rPr lang="en-US" sz="4000" b="1" dirty="0">
+              <a:rPr lang="en-US" sz="3600" b="1" dirty="0">
                 <a:solidFill>
                   <a:srgbClr val="1F5FA8"/>
                 </a:solidFill>
@@ -7719,7 +7719,7 @@
               </a:rPr>
               <a:t>0.99</a:t>
             </a:r>
-            <a:endParaRPr lang="en-US" sz="4000" dirty="0"/>
+            <a:endParaRPr lang="en-US" sz="3600" dirty="0"/>
           </a:p>
         </p:txBody>
       </p:sp>
@@ -7791,7 +7791,7 @@
               <a:buChar char="•"/>
             </a:pPr>
             <a:r>
-              <a:rPr lang="en-US" sz="1200" dirty="0">
+              <a:rPr lang="en-US" sz="1050" dirty="0">
                 <a:solidFill>
                   <a:srgbClr val="1A2433"/>
                 </a:solidFill>
@@ -7799,9 +7799,9 @@
                 <a:ea typeface="Arial" pitchFamily="34" charset="-122"/>
                 <a:cs typeface="Arial" pitchFamily="34" charset="-120"/>
               </a:rPr>
-              <a:t>Bootstrap ARI 0.91; the three full-year segments form a continuum</a:t>
-            </a:r>
-            <a:endParaRPr lang="en-US" sz="1200" dirty="0"/>
+              <a:t>Bootstrap ARI 0.91; December cuts health 12.8–14.2 pts in every segment → reminders for all</a:t>
+            </a:r>
+            <a:endParaRPr lang="en-US" sz="1050" dirty="0"/>
           </a:p>
           <a:p>
             <a:pPr marL="342900" indent="-342900">
@@ -7812,7 +7812,7 @@
               <a:buChar char="•"/>
             </a:pPr>
             <a:r>
-              <a:rPr lang="en-US" sz="1200" dirty="0">
+              <a:rPr lang="en-US" sz="1050" dirty="0">
                 <a:solidFill>
                   <a:srgbClr val="1A2433"/>
                 </a:solidFill>
@@ -7820,9 +7820,9 @@
                 <a:ea typeface="Arial" pitchFamily="34" charset="-122"/>
                 <a:cs typeface="Arial" pitchFamily="34" charset="-120"/>
               </a:rPr>
-              <a:t>December cuts health 12.8–14.2 pts in every segment → reminders for everyone</a:t>
-            </a:r>
-            <a:endParaRPr lang="en-US" sz="1200" dirty="0"/>
+              <a:t>Limits: synthetic folded data; 88 occasional users rest on ~1 month; full-year segments form a continuum (silhouette 0.25); segments lean on age / gender (Cramér's V 0.23 / 0.13) → act on behaviour only</a:t>
+            </a:r>
+            <a:endParaRPr lang="en-US" sz="1050" dirty="0"/>
           </a:p>
           <a:p>
             <a:pPr marL="342900" indent="-342900">
@@ -7833,7 +7833,7 @@
               <a:buChar char="•"/>
             </a:pPr>
             <a:r>
-              <a:rPr lang="en-US" sz="1200" dirty="0">
+              <a:rPr lang="en-US" sz="1050" dirty="0">
                 <a:solidFill>
                   <a:srgbClr val="1A2433"/>
                 </a:solidFill>
@@ -7841,9 +7841,9 @@
                 <a:ea typeface="Arial" pitchFamily="34" charset="-122"/>
                 <a:cs typeface="Arial" pitchFamily="34" charset="-120"/>
               </a:rPr>
-              <a:t>Limits: synthetic folded data; 88 occasional users rest on ~1 month; never for lending</a:t>
-            </a:r>
-            <a:endParaRPr lang="en-US" sz="1200" dirty="0"/>
+              <a:t>Future work: hybrid rules + k-means, month-to-month trajectory features, chronological early-warning on next_month_low_health_flag (support only)</a:t>
+            </a:r>
+            <a:endParaRPr lang="en-US" sz="1050" dirty="0"/>
           </a:p>
         </p:txBody>
       </p:sp>
@@ -7880,7 +7880,7 @@
                 <a:ea typeface="Arial" pitchFamily="34" charset="-122"/>
                 <a:cs typeface="Arial" pitchFamily="34" charset="-120"/>
               </a:rPr>
-              <a:t>Source: team k-means (k = 4) on 8 scaled ratios, 999 customers. Charts: notebooks/full_pipeline.ipynb.</a:t>
+              <a:t>Source: team k-means (k = 4) on 8 z-scaled behavioural features, 999 customers. Charts: notebooks/full_pipeline.ipynb.</a:t>
             </a:r>
             <a:endParaRPr lang="en-US" sz="850" dirty="0"/>
           </a:p>
@@ -9518,7 +9518,7 @@
                           <a:ea typeface="Arial" pitchFamily="34" charset="-122"/>
                           <a:cs typeface="Arial" pitchFamily="34" charset="-120"/>
                         </a:rPr>
-                        <a:t>Low health &amp; engagement · 67 (6.7%)</a:t>
+                        <a:t>FHS &lt; 70 &amp; engagement &lt; 70 (yearly means) · 67 (6.7%)</a:t>
                       </a:r>
                       <a:endParaRPr lang="en-US" sz="1100" dirty="0">
                         <a:latin typeface="Arial" charset="0"/>
@@ -10202,7 +10202,7 @@
                           <a:ea typeface="Arial" pitchFamily="34" charset="-122"/>
                           <a:cs typeface="Arial" pitchFamily="34" charset="-120"/>
                         </a:rPr>
-                        <a:t>Healthy &amp; Engaged · 351 (35.1%), adults</a:t>
+                        <a:t>Healthy &amp; Engaged, adults 18+ · 350 (35.0%)</a:t>
                       </a:r>
                       <a:endParaRPr lang="en-US" sz="1100" dirty="0">
                         <a:latin typeface="Arial" charset="0"/>
@@ -10495,7 +10495,7 @@
                 <a:ea typeface="Arial" pitchFamily="34" charset="-122"/>
                 <a:cs typeface="Arial" pitchFamily="34" charset="-120"/>
               </a:rPr>
-              <a:t>Segments ① ③ ⑤ ⑥ cover all 999 customers. Overlays: alerts 43 = 39 Stretched + 4 Healthy; education 67 = 64 Occasional + 3 Stretched (sequenced, never in the same week).</a:t>
+              <a:t>Segments ① ③ ⑤ ⑥ cover all 999 customers (1 minor in Healthy &amp; Engaged gets no product offer). Overlays: alerts 43 = 39 Stretched + 4 Healthy; education 67 = 64 Occasional + 3 Stretched (sequenced, never in the same week).</a:t>
             </a:r>
             <a:endParaRPr lang="en-US" sz="1100" dirty="0"/>
           </a:p>
@@ -10534,7 +10534,7 @@
                 <a:ea typeface="Arial" pitchFamily="34" charset="-122"/>
                 <a:cs typeface="Arial" pitchFamily="34" charset="-120"/>
               </a:rPr>
-              <a:t>Source: team k-means (k = 4) on 8 scaled ratios, 999 customers; consumer_financial_health_engagement_2025 (10,992 consumer-months, 999 customers); consumer_transactions_2025 (1,852,394 transactions). Charts: notebooks/full_pipeline.ipynb.</a:t>
+              <a:t>Source: team k-means (k = 4) on 8 z-scaled behavioural features, 999 customers; consumer_financial_health_engagement_2025 (10,992 consumer-months, 999 customers); consumer_transactions_2025 (1,852,394 transactions). Charts: notebooks/full_pipeline.ipynb.</a:t>
             </a:r>
             <a:endParaRPr lang="en-US" sz="850" dirty="0"/>
           </a:p>
@@ -11598,7 +11598,7 @@
                 <a:ea typeface="Arial" pitchFamily="34" charset="-122"/>
                 <a:cs typeface="Arial" pitchFamily="34" charset="-120"/>
               </a:rPr>
-              <a:t>Budgeting → November reminders → evening alerts lead. A 10% spend trim could cut stress months 28–32%. FHS never touches credit.</a:t>
+              <a:t>Budgeting → November reminders → evening alerts lead. In a what-if, a 10% spend trim cuts stress months 28–32% (to be tested). FHS never touches credit.</a:t>
             </a:r>
             <a:endParaRPr lang="en-US" sz="1150" dirty="0"/>
           </a:p>
@@ -11910,7 +11910,7 @@
               <a:buChar char="•"/>
             </a:pPr>
             <a:r>
-              <a:rPr lang="en-US" sz="1200" dirty="0">
+              <a:rPr lang="en-US" sz="1100" dirty="0">
                 <a:solidFill>
                   <a:srgbClr val="1A2433"/>
                 </a:solidFill>
@@ -11918,9 +11918,9 @@
                 <a:ea typeface="Arial" pitchFamily="34" charset="-122"/>
                 <a:cs typeface="Arial" pitchFamily="34" charset="-120"/>
               </a:rPr>
-              <a:t>Score = reach × |r| of the trigger with its outcome; wellbeing before growth</a:t>
-            </a:r>
-            <a:endParaRPr lang="en-US" sz="1200" dirty="0"/>
+              <a:t>Reach × |r|: a ranking heuristic, not an impact estimate; wellbeing first</a:t>
+            </a:r>
+            <a:endParaRPr lang="en-US" sz="1100" dirty="0"/>
           </a:p>
           <a:p>
             <a:pPr marL="342900" indent="-342900">
@@ -11931,7 +11931,7 @@
               <a:buChar char="•"/>
             </a:pPr>
             <a:r>
-              <a:rPr lang="en-US" sz="1200" dirty="0">
+              <a:rPr lang="en-US" sz="1100" dirty="0">
                 <a:solidFill>
                   <a:srgbClr val="1A2433"/>
                 </a:solidFill>
@@ -11941,7 +11941,7 @@
               </a:rPr>
               <a:t>Alerts reach only 43 customers but 71% of stress months → wave 1</a:t>
             </a:r>
-            <a:endParaRPr lang="en-US" sz="1200" dirty="0"/>
+            <a:endParaRPr lang="en-US" sz="1100" dirty="0"/>
           </a:p>
           <a:p>
             <a:pPr marL="342900" indent="-342900">
@@ -11952,7 +11952,7 @@
               <a:buChar char="•"/>
             </a:pPr>
             <a:r>
-              <a:rPr lang="en-US" sz="1200" dirty="0">
+              <a:rPr lang="en-US" sz="1100" dirty="0">
                 <a:solidFill>
                   <a:srgbClr val="1A2433"/>
                 </a:solidFill>
@@ -11962,7 +11962,7 @@
               </a:rPr>
               <a:t>Fairness: behaviour-only triggers; uptake tracked by age &amp; gender; no offers to minors</a:t>
             </a:r>
-            <a:endParaRPr lang="en-US" sz="1200" dirty="0"/>
+            <a:endParaRPr lang="en-US" sz="1100" dirty="0"/>
           </a:p>
         </p:txBody>
       </p:sp>
@@ -11999,7 +11999,7 @@
                 <a:ea typeface="Arial" pitchFamily="34" charset="-122"/>
                 <a:cs typeface="Arial" pitchFamily="34" charset="-120"/>
               </a:rPr>
-              <a:t>Source: consumer_financial_health_engagement_2025 (10,992 consumer-months, 999 customers); team k-means (k = 4) on 8 scaled ratios, 999 customers. Charts: notebooks/full_pipeline.ipynb.</a:t>
+              <a:t>Source: consumer_financial_health_engagement_2025 (10,992 consumer-months, 999 customers); team k-means (k = 4) on 8 z-scaled behavioural features, 999 customers. Charts: notebooks/full_pipeline.ipynb.</a:t>
             </a:r>
             <a:endParaRPr lang="en-US" sz="850" dirty="0"/>
           </a:p>
@@ -12253,7 +12253,7 @@
                 <a:ea typeface="Arial" pitchFamily="34" charset="-122"/>
                 <a:cs typeface="Arial" pitchFamily="34" charset="-120"/>
               </a:rPr>
-              <a:t>A 10% spend trim could cut stress months by 28–32%, tested within 90 days</a:t>
+              <a:t>What-if: a 10% spend trim would cut stress months by 28–32% — to be tested in a 90-day pilot</a:t>
             </a:r>
             <a:endParaRPr lang="en-US" sz="2400" dirty="0"/>
           </a:p>
@@ -12381,7 +12381,7 @@
                 <a:ea typeface="Arial" pitchFamily="34" charset="-122"/>
                 <a:cs typeface="Arial" pitchFamily="34" charset="-120"/>
               </a:rPr>
-              <a:t>stress months if the Stretched 302 trim spend-to-income by 10%</a:t>
+              <a:t>stress months if the Stretched 302 trim spend-to-income by 10% (simulated, not measured)</a:t>
             </a:r>
             <a:endParaRPr lang="en-US" sz="1100" dirty="0"/>
           </a:p>
@@ -12969,7 +12969,7 @@
                 <a:ea typeface="Arial" pitchFamily="34" charset="-122"/>
                 <a:cs typeface="Arial" pitchFamily="34" charset="-120"/>
               </a:rPr>
-              <a:t>Budgeting for 302 and opt-in evening alerts first, each measured against a random holdout within 90 days.</a:t>
+              <a:t>Budgeting for 302 and opt-in evening alerts first, each to be measured against a random holdout in a 90-day pilot.</a:t>
             </a:r>
             <a:endParaRPr lang="en-US" sz="1300" dirty="0"/>
           </a:p>
@@ -14021,7 +14021,7 @@
                 <a:ea typeface="Arial" pitchFamily="34" charset="-122"/>
                 <a:cs typeface="Arial" pitchFamily="34" charset="-120"/>
               </a:rPr>
-              <a:t>slides 19–22</a:t>
+              <a:t>slides 19–21 · closing 22</a:t>
             </a:r>
             <a:endParaRPr lang="en-US" sz="1200" dirty="0"/>
           </a:p>
@@ -15037,7 +15037,7 @@
                 <a:ea typeface="Arial" pitchFamily="34" charset="-122"/>
                 <a:cs typeface="Arial" pitchFamily="34" charset="-120"/>
               </a:rPr>
-              <a:t>Two source years folded onto 2025 (case §12) → ratios are the signal</a:t>
+              <a:t>Two source years folded onto 2025 (case study §12) → ratios are the signal</a:t>
             </a:r>
             <a:endParaRPr lang="en-US" sz="1200" dirty="0"/>
           </a:p>
@@ -16352,7 +16352,7 @@
                 <a:ea typeface="Arial" pitchFamily="34" charset="-122"/>
                 <a:cs typeface="Arial" pitchFamily="34" charset="-120"/>
               </a:rPr>
-              <a:t>6 provinces qualify: Ha Noi, Dong Nai, Lam Dong, Hung Yen, Hai Phong, Nghe An</a:t>
+              <a:t>6 qualify (spend &gt; median, digital &lt; 41.2%): Dong Nai 40.7%, Hung Yen 40.8%, Hai Phong 40.8%, Ha Noi 40.9%, Lam Dong 41.1%, Nghe An 41.2%</a:t>
             </a:r>
             <a:endParaRPr lang="en-US" sz="1200" dirty="0"/>
           </a:p>
@@ -16373,7 +16373,7 @@
                 <a:ea typeface="Arial" pitchFamily="34" charset="-122"/>
                 <a:cs typeface="Arial" pitchFamily="34" charset="-120"/>
               </a:rPr>
-              <a:t>POS 58.9–59.3% vs 58.8% nationally; QR at par; small gaps in e-commerce and app</a:t>
+              <a:t>Channel mix: POS 58.9–59.3% vs 58.8% nationally; QR at par; the gap sits in e-commerce and app</a:t>
             </a:r>
             <a:endParaRPr lang="en-US" sz="1200" dirty="0"/>
           </a:p>
@@ -16395,6 +16395,27 @@
                 <a:cs typeface="Arial" pitchFamily="34" charset="-120"/>
               </a:rPr>
               <a:t>Customers differ 8.6pp within provinces vs 3.9pp across all 34 → target the customer, not the region</a:t>
+            </a:r>
+            <a:endParaRPr lang="en-US" sz="1200" dirty="0"/>
+          </a:p>
+          <a:p>
+            <a:pPr marL="342900" indent="-342900">
+              <a:spcAft>
+                <a:spcPts val="800"/>
+              </a:spcAft>
+              <a:buSzPct val="100000"/>
+              <a:buChar char="•"/>
+            </a:pPr>
+            <a:r>
+              <a:rPr lang="en-US" sz="1200" dirty="0">
+                <a:solidFill>
+                  <a:srgbClr val="1A2433"/>
+                </a:solidFill>
+                <a:latin typeface="Arial" pitchFamily="34" charset="0"/>
+                <a:ea typeface="Arial" pitchFamily="34" charset="-122"/>
+                <a:cs typeface="Arial" pitchFamily="34" charset="-120"/>
+              </a:rPr>
+              <a:t>Top market HCMC: 13.6% of spend at 41.3% digital; lagging: Quang Ngai 39.2% digital</a:t>
             </a:r>
             <a:endParaRPr lang="en-US" sz="1200" dirty="0"/>
           </a:p>
@@ -16842,7 +16863,7 @@
                 <a:ea typeface="Arial" pitchFamily="34" charset="-122"/>
                 <a:cs typeface="Arial" pitchFamily="34" charset="-120"/>
               </a:rPr>
-              <a:t>VND ticket for in-store groceries — top by spend (513.8B), 1.8× the fuel ticket</a:t>
+              <a:t>VND grocery ticket — top by spend (513.8B), 1.8× fuel. Lagging: travel (57,956 txns), online groceries (87.1B)</a:t>
             </a:r>
             <a:endParaRPr lang="en-US" sz="1050" dirty="0"/>
           </a:p>
@@ -16949,7 +16970,7 @@
                 <a:ea typeface="Arial" pitchFamily="34" charset="-122"/>
                 <a:cs typeface="Arial" pitchFamily="34" charset="-120"/>
               </a:rPr>
-              <a:t>lowest FHS: 25–34, still active (178.7 txns/month) with the highest spend-to-income 0.716</a:t>
+              <a:t>lowest FHS: 25–34, active (178.7 txns/mo); spend/income 0.716 vs 0.700, essential 0.468 vs 0.481</a:t>
             </a:r>
             <a:endParaRPr lang="en-US" sz="1050" dirty="0"/>
           </a:p>

</xml_diff>